<commit_message>
Add AF-in-pregnancy section to topic deck
Extends the Atrial Fibrillation topic deck from 16 to 18 slides with a
special-populations section:
- Anticoagulation in Pregnancy: LMWH / UFH preferred (do not cross the
  placenta) vs warfarin & DOACs avoided, plus peri-delivery and
  breastfeeding guidance
- Rhythm & Rate Control in Pregnancy: generally-safe agents, DC
  cardioversion, and amiodarone / atenolol cautions
- Adds a pregnancy takeaway to the Key Points summary

Co-Authored-By: Claude Opus 4.8 <noreply@anthropic.com>
Claude-Session: https://claude.ai/code/session_01S7QW8AwqyMReKwuqyBkBBv
</commit_message>
<xml_diff>
--- a/presentations/Atrial-Fibrillation-Topic-Review.pptx
+++ b/presentations/Atrial-Fibrillation-Topic-Review.pptx
@@ -21,9 +21,11 @@
     <p:sldId id="269" r:id="rId15"/>
     <p:sldId id="270" r:id="rId16"/>
     <p:sldId id="271" r:id="rId17"/>
+    <p:sldId id="272" r:id="rId18"/>
+    <p:sldId id="273" r:id="rId19"/>
   </p:sldIdLst>
   <p:notesMasterIdLst>
-    <p:notesMasterId r:id="rId18"/>
+    <p:notesMasterId r:id="rId20"/>
   </p:notesMasterIdLst>
   <p:sldSz cx="12191695" cy="6858000"/>
   <p:notesSz cx="6858000" cy="12191695"/>
@@ -1157,6 +1159,182 @@
             <a:fld id="{F7021451-1387-4CA6-816F-3879F97B5CBC}" type="slidenum">
               <a:rPr lang="en-US"/>
               <a:t>16</a:t>
+            </a:fld>
+            <a:endParaRPr lang="en-US"/>
+          </a:p>
+        </p:txBody>
+      </p:sp>
+    </p:spTree>
+    <p:extLst>
+      <p:ext uri="{BB962C8B-B14F-4D97-AF65-F5344CB8AC3E}">
+        <p14:creationId xmlns:p14="http://schemas.microsoft.com/office/powerpoint/2010/main" val="1024086991"/>
+      </p:ext>
+    </p:extLst>
+  </p:cSld>
+  <p:clrMapOvr>
+    <a:masterClrMapping/>
+  </p:clrMapOvr>
+</p:notes>
+</file>
+
+<file path=ppt/notesSlides/notesSlide17.xml><?xml version="1.0" encoding="utf-8"?>
+<p:notes xmlns:a="http://schemas.openxmlformats.org/drawingml/2006/main" xmlns:r="http://schemas.openxmlformats.org/officeDocument/2006/relationships" xmlns:p="http://schemas.openxmlformats.org/presentationml/2006/main">
+  <p:cSld>
+    <p:spTree>
+      <p:nvGrpSpPr>
+        <p:cNvPr id="1" name=""/>
+        <p:cNvGrpSpPr/>
+        <p:nvPr/>
+      </p:nvGrpSpPr>
+      <p:grpSpPr>
+        <a:xfrm>
+          <a:off x="0" y="0"/>
+          <a:ext cx="0" cy="0"/>
+          <a:chOff x="0" y="0"/>
+          <a:chExt cx="0" cy="0"/>
+        </a:xfrm>
+      </p:grpSpPr>
+      <p:sp>
+        <p:nvSpPr>
+          <p:cNvPr id="2" name="Slide Image Placeholder 1"/>
+          <p:cNvSpPr>
+            <a:spLocks noGrp="1" noRot="1" noChangeAspect="1"/>
+          </p:cNvSpPr>
+          <p:nvPr>
+            <p:ph type="sldImg"/>
+          </p:nvPr>
+        </p:nvSpPr>
+        <p:spPr/>
+      </p:sp>
+      <p:sp>
+        <p:nvSpPr>
+          <p:cNvPr id="3" name="Notes Placeholder 2"/>
+          <p:cNvSpPr>
+            <a:spLocks noGrp="1"/>
+          </p:cNvSpPr>
+          <p:nvPr>
+            <p:ph type="body" idx="1"/>
+          </p:nvPr>
+        </p:nvSpPr>
+        <p:spPr/>
+        <p:txBody>
+          <a:bodyPr/>
+          <a:lstStyle/>
+          <a:p>
+            <a:r>
+              <a:rPr lang="en-US" dirty="0"/>
+              <a:t/>
+            </a:r>
+            <a:endParaRPr lang="en-US" dirty="0"/>
+          </a:p>
+        </p:txBody>
+      </p:sp>
+      <p:sp>
+        <p:nvSpPr>
+          <p:cNvPr id="4" name="Slide Number Placeholder 3"/>
+          <p:cNvSpPr>
+            <a:spLocks noGrp="1"/>
+          </p:cNvSpPr>
+          <p:nvPr>
+            <p:ph type="sldNum" sz="quarter" idx="10"/>
+          </p:nvPr>
+        </p:nvSpPr>
+        <p:spPr/>
+        <p:txBody>
+          <a:bodyPr/>
+          <a:lstStyle/>
+          <a:p>
+            <a:fld id="{F7021451-1387-4CA6-816F-3879F97B5CBC}" type="slidenum">
+              <a:rPr lang="en-US"/>
+              <a:t>17</a:t>
+            </a:fld>
+            <a:endParaRPr lang="en-US"/>
+          </a:p>
+        </p:txBody>
+      </p:sp>
+    </p:spTree>
+    <p:extLst>
+      <p:ext uri="{BB962C8B-B14F-4D97-AF65-F5344CB8AC3E}">
+        <p14:creationId xmlns:p14="http://schemas.microsoft.com/office/powerpoint/2010/main" val="1024086991"/>
+      </p:ext>
+    </p:extLst>
+  </p:cSld>
+  <p:clrMapOvr>
+    <a:masterClrMapping/>
+  </p:clrMapOvr>
+</p:notes>
+</file>
+
+<file path=ppt/notesSlides/notesSlide18.xml><?xml version="1.0" encoding="utf-8"?>
+<p:notes xmlns:a="http://schemas.openxmlformats.org/drawingml/2006/main" xmlns:r="http://schemas.openxmlformats.org/officeDocument/2006/relationships" xmlns:p="http://schemas.openxmlformats.org/presentationml/2006/main">
+  <p:cSld>
+    <p:spTree>
+      <p:nvGrpSpPr>
+        <p:cNvPr id="1" name=""/>
+        <p:cNvGrpSpPr/>
+        <p:nvPr/>
+      </p:nvGrpSpPr>
+      <p:grpSpPr>
+        <a:xfrm>
+          <a:off x="0" y="0"/>
+          <a:ext cx="0" cy="0"/>
+          <a:chOff x="0" y="0"/>
+          <a:chExt cx="0" cy="0"/>
+        </a:xfrm>
+      </p:grpSpPr>
+      <p:sp>
+        <p:nvSpPr>
+          <p:cNvPr id="2" name="Slide Image Placeholder 1"/>
+          <p:cNvSpPr>
+            <a:spLocks noGrp="1" noRot="1" noChangeAspect="1"/>
+          </p:cNvSpPr>
+          <p:nvPr>
+            <p:ph type="sldImg"/>
+          </p:nvPr>
+        </p:nvSpPr>
+        <p:spPr/>
+      </p:sp>
+      <p:sp>
+        <p:nvSpPr>
+          <p:cNvPr id="3" name="Notes Placeholder 2"/>
+          <p:cNvSpPr>
+            <a:spLocks noGrp="1"/>
+          </p:cNvSpPr>
+          <p:nvPr>
+            <p:ph type="body" idx="1"/>
+          </p:nvPr>
+        </p:nvSpPr>
+        <p:spPr/>
+        <p:txBody>
+          <a:bodyPr/>
+          <a:lstStyle/>
+          <a:p>
+            <a:r>
+              <a:rPr lang="en-US" dirty="0"/>
+              <a:t/>
+            </a:r>
+            <a:endParaRPr lang="en-US" dirty="0"/>
+          </a:p>
+        </p:txBody>
+      </p:sp>
+      <p:sp>
+        <p:nvSpPr>
+          <p:cNvPr id="4" name="Slide Number Placeholder 3"/>
+          <p:cNvSpPr>
+            <a:spLocks noGrp="1"/>
+          </p:cNvSpPr>
+          <p:nvPr>
+            <p:ph type="sldNum" sz="quarter" idx="10"/>
+          </p:nvPr>
+        </p:nvSpPr>
+        <p:spPr/>
+        <p:txBody>
+          <a:bodyPr/>
+          <a:lstStyle/>
+          <a:p>
+            <a:fld id="{F7021451-1387-4CA6-816F-3879F97B5CBC}" type="slidenum">
+              <a:rPr lang="en-US"/>
+              <a:t>18</a:t>
             </a:fld>
             <a:endParaRPr lang="en-US"/>
           </a:p>
@@ -10731,6 +10909,2098 @@
     <p:bg>
       <p:bgPr>
         <a:solidFill>
+          <a:srgbClr val="FFFFFF"/>
+        </a:solidFill>
+      </p:bgPr>
+    </p:bg>
+    <p:spTree>
+      <p:nvGrpSpPr>
+        <p:cNvPr id="1" name=""/>
+        <p:cNvGrpSpPr/>
+        <p:nvPr/>
+      </p:nvGrpSpPr>
+      <p:grpSpPr>
+        <a:xfrm>
+          <a:off x="0" y="0"/>
+          <a:ext cx="0" cy="0"/>
+          <a:chOff x="0" y="0"/>
+          <a:chExt cx="0" cy="0"/>
+        </a:xfrm>
+      </p:grpSpPr>
+      <p:sp>
+        <p:nvSpPr>
+          <p:cNvPr id="2" name="Shape 0"/>
+          <p:cNvSpPr/>
+          <p:nvPr/>
+        </p:nvSpPr>
+        <p:spPr>
+          <a:xfrm>
+            <a:off x="502920" y="457200"/>
+            <a:ext cx="868680" cy="868680"/>
+          </a:xfrm>
+          <a:prstGeom prst="ellipse">
+            <a:avLst/>
+          </a:prstGeom>
+          <a:solidFill>
+            <a:srgbClr val="FFF0F3"/>
+          </a:solidFill>
+          <a:ln w="12700">
+            <a:solidFill>
+              <a:srgbClr val="FBD8DF"/>
+            </a:solidFill>
+            <a:prstDash val="solid"/>
+          </a:ln>
+        </p:spPr>
+      </p:sp>
+      <p:pic>
+        <p:nvPicPr>
+          <p:cNvPr id="3" name="Image 0" descr="preencoded.png">    </p:cNvPr>
+          <p:cNvPicPr>
+            <a:picLocks noChangeAspect="1"/>
+          </p:cNvPicPr>
+          <p:nvPr/>
+        </p:nvPicPr>
+        <p:blipFill>
+          <a:blip r:embed="rId1"/>
+          <a:stretch>
+            <a:fillRect/>
+          </a:stretch>
+        </p:blipFill>
+        <p:spPr>
+          <a:xfrm>
+            <a:off x="694944" y="649224"/>
+            <a:ext cx="484632" cy="484632"/>
+          </a:xfrm>
+          <a:prstGeom prst="rect">
+            <a:avLst/>
+          </a:prstGeom>
+        </p:spPr>
+      </p:pic>
+      <p:sp>
+        <p:nvSpPr>
+          <p:cNvPr id="4" name="Text 1"/>
+          <p:cNvSpPr/>
+          <p:nvPr/>
+        </p:nvSpPr>
+        <p:spPr>
+          <a:xfrm>
+            <a:off x="1572768" y="502920"/>
+            <a:ext cx="9966960" cy="274320"/>
+          </a:xfrm>
+          <a:prstGeom prst="rect">
+            <a:avLst/>
+          </a:prstGeom>
+          <a:noFill/>
+          <a:ln/>
+        </p:spPr>
+        <p:txBody>
+          <a:bodyPr wrap="square" rtlCol="0" anchor="t"/>
+          <a:lstStyle/>
+          <a:p>
+            <a:pPr algn="l" indent="0" marL="0">
+              <a:buNone/>
+            </a:pPr>
+            <a:r>
+              <a:rPr lang="en-US" sz="1250" b="1" spc="200" kern="0" dirty="0">
+                <a:solidFill>
+                  <a:srgbClr val="A4133C"/>
+                </a:solidFill>
+                <a:latin typeface="Calibri" pitchFamily="34" charset="0"/>
+                <a:ea typeface="Calibri" pitchFamily="34" charset="-122"/>
+                <a:cs typeface="Calibri" pitchFamily="34" charset="-120"/>
+              </a:rPr>
+              <a:t>SPECIAL POPULATIONS · PREGNANCY</a:t>
+            </a:r>
+            <a:endParaRPr lang="en-US" sz="1250" dirty="0"/>
+          </a:p>
+        </p:txBody>
+      </p:sp>
+      <p:sp>
+        <p:nvSpPr>
+          <p:cNvPr id="5" name="Text 2"/>
+          <p:cNvSpPr/>
+          <p:nvPr/>
+        </p:nvSpPr>
+        <p:spPr>
+          <a:xfrm>
+            <a:off x="1554480" y="749808"/>
+            <a:ext cx="10241280" cy="640080"/>
+          </a:xfrm>
+          <a:prstGeom prst="rect">
+            <a:avLst/>
+          </a:prstGeom>
+          <a:noFill/>
+          <a:ln/>
+        </p:spPr>
+        <p:txBody>
+          <a:bodyPr wrap="square" rtlCol="0" anchor="t"/>
+          <a:lstStyle/>
+          <a:p>
+            <a:pPr algn="l" indent="0" marL="0">
+              <a:buNone/>
+            </a:pPr>
+            <a:r>
+              <a:rPr lang="en-US" sz="3000" b="1" dirty="0">
+                <a:solidFill>
+                  <a:srgbClr val="2B2B33"/>
+                </a:solidFill>
+                <a:latin typeface="Cambria" pitchFamily="34" charset="0"/>
+                <a:ea typeface="Cambria" pitchFamily="34" charset="-122"/>
+                <a:cs typeface="Cambria" pitchFamily="34" charset="-120"/>
+              </a:rPr>
+              <a:t>Anticoagulation in Pregnancy</a:t>
+            </a:r>
+            <a:endParaRPr lang="en-US" sz="3000" dirty="0"/>
+          </a:p>
+        </p:txBody>
+      </p:sp>
+      <p:sp>
+        <p:nvSpPr>
+          <p:cNvPr id="6" name="Shape 3"/>
+          <p:cNvSpPr/>
+          <p:nvPr/>
+        </p:nvSpPr>
+        <p:spPr>
+          <a:xfrm>
+            <a:off x="502920" y="1783080"/>
+            <a:ext cx="5532120" cy="2971800"/>
+          </a:xfrm>
+          <a:prstGeom prst="roundRect">
+            <a:avLst>
+              <a:gd name="adj" fmla="val 3692"/>
+            </a:avLst>
+          </a:prstGeom>
+          <a:solidFill>
+            <a:srgbClr val="FFF0F3"/>
+          </a:solidFill>
+          <a:ln w="12700">
+            <a:solidFill>
+              <a:srgbClr val="FBD8DF"/>
+            </a:solidFill>
+            <a:prstDash val="solid"/>
+          </a:ln>
+          <a:effectLst>
+            <a:outerShdw sx="100000" sy="100000" kx="0" ky="0" algn="bl" rotWithShape="0" blurRad="127000" dist="50800" dir="5400000">
+              <a:srgbClr val="C9A3AC">
+                <a:alpha val="45000"/>
+              </a:srgbClr>
+            </a:outerShdw>
+          </a:effectLst>
+        </p:spPr>
+      </p:sp>
+      <p:sp>
+        <p:nvSpPr>
+          <p:cNvPr id="7" name="Text 4"/>
+          <p:cNvSpPr/>
+          <p:nvPr/>
+        </p:nvSpPr>
+        <p:spPr>
+          <a:xfrm>
+            <a:off x="822960" y="2011680"/>
+            <a:ext cx="4846320" cy="274320"/>
+          </a:xfrm>
+          <a:prstGeom prst="rect">
+            <a:avLst/>
+          </a:prstGeom>
+          <a:noFill/>
+          <a:ln/>
+        </p:spPr>
+        <p:txBody>
+          <a:bodyPr wrap="square" rtlCol="0" anchor="t"/>
+          <a:lstStyle/>
+          <a:p>
+            <a:pPr algn="l" indent="0" marL="0">
+              <a:buNone/>
+            </a:pPr>
+            <a:r>
+              <a:rPr lang="en-US" sz="1300" b="1" spc="150" kern="0" dirty="0">
+                <a:solidFill>
+                  <a:srgbClr val="2E7D32"/>
+                </a:solidFill>
+                <a:latin typeface="Calibri" pitchFamily="34" charset="0"/>
+                <a:ea typeface="Calibri" pitchFamily="34" charset="-122"/>
+                <a:cs typeface="Calibri" pitchFamily="34" charset="-120"/>
+              </a:rPr>
+              <a:t>✓  </a:t>
+            </a:r>
+            <a:pPr algn="l" indent="0" marL="0">
+              <a:buNone/>
+            </a:pPr>
+            <a:r>
+              <a:rPr lang="en-US" sz="1300" b="1" spc="150" kern="0" dirty="0">
+                <a:solidFill>
+                  <a:srgbClr val="2E7D32"/>
+                </a:solidFill>
+                <a:latin typeface="Calibri" pitchFamily="34" charset="0"/>
+                <a:ea typeface="Calibri" pitchFamily="34" charset="-122"/>
+                <a:cs typeface="Calibri" pitchFamily="34" charset="-120"/>
+              </a:rPr>
+              <a:t>PREFERRED</a:t>
+            </a:r>
+            <a:endParaRPr lang="en-US" sz="1300" dirty="0"/>
+          </a:p>
+        </p:txBody>
+      </p:sp>
+      <p:sp>
+        <p:nvSpPr>
+          <p:cNvPr id="8" name="Shape 5"/>
+          <p:cNvSpPr/>
+          <p:nvPr/>
+        </p:nvSpPr>
+        <p:spPr>
+          <a:xfrm>
+            <a:off x="822960" y="2395728"/>
+            <a:ext cx="548640" cy="548640"/>
+          </a:xfrm>
+          <a:prstGeom prst="ellipse">
+            <a:avLst/>
+          </a:prstGeom>
+          <a:solidFill>
+            <a:srgbClr val="2E7D32"/>
+          </a:solidFill>
+          <a:ln/>
+        </p:spPr>
+      </p:sp>
+      <p:pic>
+        <p:nvPicPr>
+          <p:cNvPr id="9" name="Image 1" descr="preencoded.png">    </p:cNvPr>
+          <p:cNvPicPr>
+            <a:picLocks noChangeAspect="1"/>
+          </p:cNvPicPr>
+          <p:nvPr/>
+        </p:nvPicPr>
+        <p:blipFill>
+          <a:blip r:embed="rId2"/>
+          <a:stretch>
+            <a:fillRect/>
+          </a:stretch>
+        </p:blipFill>
+        <p:spPr>
+          <a:xfrm>
+            <a:off x="960120" y="2551176"/>
+            <a:ext cx="283464" cy="246888"/>
+          </a:xfrm>
+          <a:prstGeom prst="rect">
+            <a:avLst/>
+          </a:prstGeom>
+        </p:spPr>
+      </p:pic>
+      <p:sp>
+        <p:nvSpPr>
+          <p:cNvPr id="10" name="Text 6"/>
+          <p:cNvSpPr/>
+          <p:nvPr/>
+        </p:nvSpPr>
+        <p:spPr>
+          <a:xfrm>
+            <a:off x="1508760" y="2350008"/>
+            <a:ext cx="4343400" cy="365760"/>
+          </a:xfrm>
+          <a:prstGeom prst="rect">
+            <a:avLst/>
+          </a:prstGeom>
+          <a:noFill/>
+          <a:ln/>
+        </p:spPr>
+        <p:txBody>
+          <a:bodyPr wrap="square" lIns="0" tIns="0" rIns="0" bIns="0" rtlCol="0" anchor="t"/>
+          <a:lstStyle/>
+          <a:p>
+            <a:pPr algn="l" indent="0" marL="0">
+              <a:buNone/>
+            </a:pPr>
+            <a:r>
+              <a:rPr lang="en-US" sz="1650" b="1" dirty="0">
+                <a:solidFill>
+                  <a:srgbClr val="2B2B33"/>
+                </a:solidFill>
+                <a:latin typeface="Cambria" pitchFamily="34" charset="0"/>
+                <a:ea typeface="Cambria" pitchFamily="34" charset="-122"/>
+                <a:cs typeface="Cambria" pitchFamily="34" charset="-120"/>
+              </a:rPr>
+              <a:t>LMWH (enoxaparin)</a:t>
+            </a:r>
+            <a:endParaRPr lang="en-US" sz="1650" dirty="0"/>
+          </a:p>
+        </p:txBody>
+      </p:sp>
+      <p:sp>
+        <p:nvSpPr>
+          <p:cNvPr id="11" name="Text 7"/>
+          <p:cNvSpPr/>
+          <p:nvPr/>
+        </p:nvSpPr>
+        <p:spPr>
+          <a:xfrm>
+            <a:off x="1508760" y="2706624"/>
+            <a:ext cx="4389120" cy="685800"/>
+          </a:xfrm>
+          <a:prstGeom prst="rect">
+            <a:avLst/>
+          </a:prstGeom>
+          <a:noFill/>
+          <a:ln/>
+        </p:spPr>
+        <p:txBody>
+          <a:bodyPr wrap="square" lIns="0" tIns="0" rIns="0" bIns="0" rtlCol="0" anchor="t"/>
+          <a:lstStyle/>
+          <a:p>
+            <a:pPr algn="l" indent="0" marL="0">
+              <a:lnSpc>
+                <a:spcPct val="108000"/>
+              </a:lnSpc>
+              <a:buNone/>
+            </a:pPr>
+            <a:r>
+              <a:rPr lang="en-US" sz="1250" dirty="0">
+                <a:solidFill>
+                  <a:srgbClr val="6B6B76"/>
+                </a:solidFill>
+                <a:latin typeface="Calibri" pitchFamily="34" charset="0"/>
+                <a:ea typeface="Calibri" pitchFamily="34" charset="-122"/>
+                <a:cs typeface="Calibri" pitchFamily="34" charset="-120"/>
+              </a:rPr>
+              <a:t>Does not cross the placenta — the agent of choice; weight-adjusted, monitor anti-Xa</a:t>
+            </a:r>
+            <a:endParaRPr lang="en-US" sz="1250" dirty="0"/>
+          </a:p>
+        </p:txBody>
+      </p:sp>
+      <p:sp>
+        <p:nvSpPr>
+          <p:cNvPr id="12" name="Shape 8"/>
+          <p:cNvSpPr/>
+          <p:nvPr/>
+        </p:nvSpPr>
+        <p:spPr>
+          <a:xfrm>
+            <a:off x="822960" y="3511296"/>
+            <a:ext cx="548640" cy="548640"/>
+          </a:xfrm>
+          <a:prstGeom prst="ellipse">
+            <a:avLst/>
+          </a:prstGeom>
+          <a:solidFill>
+            <a:srgbClr val="2E7D32"/>
+          </a:solidFill>
+          <a:ln/>
+        </p:spPr>
+      </p:sp>
+      <p:pic>
+        <p:nvPicPr>
+          <p:cNvPr id="13" name="Image 2" descr="preencoded.png">    </p:cNvPr>
+          <p:cNvPicPr>
+            <a:picLocks noChangeAspect="1"/>
+          </p:cNvPicPr>
+          <p:nvPr/>
+        </p:nvPicPr>
+        <p:blipFill>
+          <a:blip r:embed="rId3"/>
+          <a:stretch>
+            <a:fillRect/>
+          </a:stretch>
+        </p:blipFill>
+        <p:spPr>
+          <a:xfrm>
+            <a:off x="960120" y="3666744"/>
+            <a:ext cx="283464" cy="246888"/>
+          </a:xfrm>
+          <a:prstGeom prst="rect">
+            <a:avLst/>
+          </a:prstGeom>
+        </p:spPr>
+      </p:pic>
+      <p:sp>
+        <p:nvSpPr>
+          <p:cNvPr id="14" name="Text 9"/>
+          <p:cNvSpPr/>
+          <p:nvPr/>
+        </p:nvSpPr>
+        <p:spPr>
+          <a:xfrm>
+            <a:off x="1508760" y="3465576"/>
+            <a:ext cx="4343400" cy="365760"/>
+          </a:xfrm>
+          <a:prstGeom prst="rect">
+            <a:avLst/>
+          </a:prstGeom>
+          <a:noFill/>
+          <a:ln/>
+        </p:spPr>
+        <p:txBody>
+          <a:bodyPr wrap="square" lIns="0" tIns="0" rIns="0" bIns="0" rtlCol="0" anchor="t"/>
+          <a:lstStyle/>
+          <a:p>
+            <a:pPr algn="l" indent="0" marL="0">
+              <a:buNone/>
+            </a:pPr>
+            <a:r>
+              <a:rPr lang="en-US" sz="1650" b="1" dirty="0">
+                <a:solidFill>
+                  <a:srgbClr val="2B2B33"/>
+                </a:solidFill>
+                <a:latin typeface="Cambria" pitchFamily="34" charset="0"/>
+                <a:ea typeface="Cambria" pitchFamily="34" charset="-122"/>
+                <a:cs typeface="Cambria" pitchFamily="34" charset="-120"/>
+              </a:rPr>
+              <a:t>Unfractionated heparin</a:t>
+            </a:r>
+            <a:endParaRPr lang="en-US" sz="1650" dirty="0"/>
+          </a:p>
+        </p:txBody>
+      </p:sp>
+      <p:sp>
+        <p:nvSpPr>
+          <p:cNvPr id="15" name="Text 10"/>
+          <p:cNvSpPr/>
+          <p:nvPr/>
+        </p:nvSpPr>
+        <p:spPr>
+          <a:xfrm>
+            <a:off x="1508760" y="3822192"/>
+            <a:ext cx="4389120" cy="685800"/>
+          </a:xfrm>
+          <a:prstGeom prst="rect">
+            <a:avLst/>
+          </a:prstGeom>
+          <a:noFill/>
+          <a:ln/>
+        </p:spPr>
+        <p:txBody>
+          <a:bodyPr wrap="square" lIns="0" tIns="0" rIns="0" bIns="0" rtlCol="0" anchor="t"/>
+          <a:lstStyle/>
+          <a:p>
+            <a:pPr algn="l" indent="0" marL="0">
+              <a:lnSpc>
+                <a:spcPct val="108000"/>
+              </a:lnSpc>
+              <a:buNone/>
+            </a:pPr>
+            <a:r>
+              <a:rPr lang="en-US" sz="1250" dirty="0">
+                <a:solidFill>
+                  <a:srgbClr val="6B6B76"/>
+                </a:solidFill>
+                <a:latin typeface="Calibri" pitchFamily="34" charset="0"/>
+                <a:ea typeface="Calibri" pitchFamily="34" charset="-122"/>
+                <a:cs typeface="Calibri" pitchFamily="34" charset="-120"/>
+              </a:rPr>
+              <a:t>Also placenta-safe; useful peri-delivery — short-acting &amp; reversible</a:t>
+            </a:r>
+            <a:endParaRPr lang="en-US" sz="1250" dirty="0"/>
+          </a:p>
+        </p:txBody>
+      </p:sp>
+      <p:sp>
+        <p:nvSpPr>
+          <p:cNvPr id="16" name="Shape 11"/>
+          <p:cNvSpPr/>
+          <p:nvPr/>
+        </p:nvSpPr>
+        <p:spPr>
+          <a:xfrm>
+            <a:off x="6172200" y="1783080"/>
+            <a:ext cx="5532120" cy="2971800"/>
+          </a:xfrm>
+          <a:prstGeom prst="roundRect">
+            <a:avLst>
+              <a:gd name="adj" fmla="val 3692"/>
+            </a:avLst>
+          </a:prstGeom>
+          <a:solidFill>
+            <a:srgbClr val="590D22"/>
+          </a:solidFill>
+          <a:ln/>
+          <a:effectLst>
+            <a:outerShdw sx="100000" sy="100000" kx="0" ky="0" algn="bl" rotWithShape="0" blurRad="127000" dist="50800" dir="5400000">
+              <a:srgbClr val="C9A3AC">
+                <a:alpha val="45000"/>
+              </a:srgbClr>
+            </a:outerShdw>
+          </a:effectLst>
+        </p:spPr>
+      </p:sp>
+      <p:sp>
+        <p:nvSpPr>
+          <p:cNvPr id="17" name="Text 12"/>
+          <p:cNvSpPr/>
+          <p:nvPr/>
+        </p:nvSpPr>
+        <p:spPr>
+          <a:xfrm>
+            <a:off x="6492240" y="2011680"/>
+            <a:ext cx="4846320" cy="274320"/>
+          </a:xfrm>
+          <a:prstGeom prst="rect">
+            <a:avLst/>
+          </a:prstGeom>
+          <a:noFill/>
+          <a:ln/>
+        </p:spPr>
+        <p:txBody>
+          <a:bodyPr wrap="square" rtlCol="0" anchor="t"/>
+          <a:lstStyle/>
+          <a:p>
+            <a:pPr algn="l" indent="0" marL="0">
+              <a:buNone/>
+            </a:pPr>
+            <a:r>
+              <a:rPr lang="en-US" sz="1300" b="1" spc="150" kern="0" dirty="0">
+                <a:solidFill>
+                  <a:srgbClr val="FF4D6D"/>
+                </a:solidFill>
+                <a:latin typeface="Calibri" pitchFamily="34" charset="0"/>
+                <a:ea typeface="Calibri" pitchFamily="34" charset="-122"/>
+                <a:cs typeface="Calibri" pitchFamily="34" charset="-120"/>
+              </a:rPr>
+              <a:t>✕  </a:t>
+            </a:r>
+            <a:pPr algn="l" indent="0" marL="0">
+              <a:buNone/>
+            </a:pPr>
+            <a:r>
+              <a:rPr lang="en-US" sz="1300" b="1" spc="150" kern="0" dirty="0">
+                <a:solidFill>
+                  <a:srgbClr val="FFFFFF"/>
+                </a:solidFill>
+                <a:latin typeface="Calibri" pitchFamily="34" charset="0"/>
+                <a:ea typeface="Calibri" pitchFamily="34" charset="-122"/>
+                <a:cs typeface="Calibri" pitchFamily="34" charset="-120"/>
+              </a:rPr>
+              <a:t>AVOID</a:t>
+            </a:r>
+            <a:endParaRPr lang="en-US" sz="1300" dirty="0"/>
+          </a:p>
+        </p:txBody>
+      </p:sp>
+      <p:sp>
+        <p:nvSpPr>
+          <p:cNvPr id="18" name="Shape 13"/>
+          <p:cNvSpPr/>
+          <p:nvPr/>
+        </p:nvSpPr>
+        <p:spPr>
+          <a:xfrm>
+            <a:off x="6492240" y="2395728"/>
+            <a:ext cx="548640" cy="548640"/>
+          </a:xfrm>
+          <a:prstGeom prst="ellipse">
+            <a:avLst/>
+          </a:prstGeom>
+          <a:solidFill>
+            <a:srgbClr val="A4133C"/>
+          </a:solidFill>
+          <a:ln/>
+        </p:spPr>
+      </p:sp>
+      <p:pic>
+        <p:nvPicPr>
+          <p:cNvPr id="19" name="Image 3" descr="preencoded.png">    </p:cNvPr>
+          <p:cNvPicPr>
+            <a:picLocks noChangeAspect="1"/>
+          </p:cNvPicPr>
+          <p:nvPr/>
+        </p:nvPicPr>
+        <p:blipFill>
+          <a:blip r:embed="rId4"/>
+          <a:stretch>
+            <a:fillRect/>
+          </a:stretch>
+        </p:blipFill>
+        <p:spPr>
+          <a:xfrm>
+            <a:off x="6638544" y="2551176"/>
+            <a:ext cx="256032" cy="256032"/>
+          </a:xfrm>
+          <a:prstGeom prst="rect">
+            <a:avLst/>
+          </a:prstGeom>
+        </p:spPr>
+      </p:pic>
+      <p:sp>
+        <p:nvSpPr>
+          <p:cNvPr id="20" name="Text 14"/>
+          <p:cNvSpPr/>
+          <p:nvPr/>
+        </p:nvSpPr>
+        <p:spPr>
+          <a:xfrm>
+            <a:off x="7178040" y="2350008"/>
+            <a:ext cx="4297680" cy="365760"/>
+          </a:xfrm>
+          <a:prstGeom prst="rect">
+            <a:avLst/>
+          </a:prstGeom>
+          <a:noFill/>
+          <a:ln/>
+        </p:spPr>
+        <p:txBody>
+          <a:bodyPr wrap="square" lIns="0" tIns="0" rIns="0" bIns="0" rtlCol="0" anchor="t"/>
+          <a:lstStyle/>
+          <a:p>
+            <a:pPr algn="l" indent="0" marL="0">
+              <a:buNone/>
+            </a:pPr>
+            <a:r>
+              <a:rPr lang="en-US" sz="1650" b="1" dirty="0">
+                <a:solidFill>
+                  <a:srgbClr val="FFFFFF"/>
+                </a:solidFill>
+                <a:latin typeface="Cambria" pitchFamily="34" charset="0"/>
+                <a:ea typeface="Cambria" pitchFamily="34" charset="-122"/>
+                <a:cs typeface="Cambria" pitchFamily="34" charset="-120"/>
+              </a:rPr>
+              <a:t>Warfarin (VKA)</a:t>
+            </a:r>
+            <a:endParaRPr lang="en-US" sz="1650" dirty="0"/>
+          </a:p>
+        </p:txBody>
+      </p:sp>
+      <p:sp>
+        <p:nvSpPr>
+          <p:cNvPr id="21" name="Text 15"/>
+          <p:cNvSpPr/>
+          <p:nvPr/>
+        </p:nvSpPr>
+        <p:spPr>
+          <a:xfrm>
+            <a:off x="7178040" y="2706624"/>
+            <a:ext cx="4343400" cy="685800"/>
+          </a:xfrm>
+          <a:prstGeom prst="rect">
+            <a:avLst/>
+          </a:prstGeom>
+          <a:noFill/>
+          <a:ln/>
+        </p:spPr>
+        <p:txBody>
+          <a:bodyPr wrap="square" lIns="0" tIns="0" rIns="0" bIns="0" rtlCol="0" anchor="t"/>
+          <a:lstStyle/>
+          <a:p>
+            <a:pPr algn="l" indent="0" marL="0">
+              <a:lnSpc>
+                <a:spcPct val="108000"/>
+              </a:lnSpc>
+              <a:buNone/>
+            </a:pPr>
+            <a:r>
+              <a:rPr lang="en-US" sz="1250" dirty="0">
+                <a:solidFill>
+                  <a:srgbClr val="FBD8DF"/>
+                </a:solidFill>
+                <a:latin typeface="Calibri" pitchFamily="34" charset="0"/>
+                <a:ea typeface="Calibri" pitchFamily="34" charset="-122"/>
+                <a:cs typeface="Calibri" pitchFamily="34" charset="-120"/>
+              </a:rPr>
+              <a:t>Teratogenic — embryopathy at weeks 6–12 and fetal bleeding near term</a:t>
+            </a:r>
+            <a:endParaRPr lang="en-US" sz="1250" dirty="0"/>
+          </a:p>
+        </p:txBody>
+      </p:sp>
+      <p:sp>
+        <p:nvSpPr>
+          <p:cNvPr id="22" name="Shape 16"/>
+          <p:cNvSpPr/>
+          <p:nvPr/>
+        </p:nvSpPr>
+        <p:spPr>
+          <a:xfrm>
+            <a:off x="6492240" y="3511296"/>
+            <a:ext cx="548640" cy="548640"/>
+          </a:xfrm>
+          <a:prstGeom prst="ellipse">
+            <a:avLst/>
+          </a:prstGeom>
+          <a:solidFill>
+            <a:srgbClr val="A4133C"/>
+          </a:solidFill>
+          <a:ln/>
+        </p:spPr>
+      </p:sp>
+      <p:pic>
+        <p:nvPicPr>
+          <p:cNvPr id="23" name="Image 4" descr="preencoded.png">    </p:cNvPr>
+          <p:cNvPicPr>
+            <a:picLocks noChangeAspect="1"/>
+          </p:cNvPicPr>
+          <p:nvPr/>
+        </p:nvPicPr>
+        <p:blipFill>
+          <a:blip r:embed="rId5"/>
+          <a:stretch>
+            <a:fillRect/>
+          </a:stretch>
+        </p:blipFill>
+        <p:spPr>
+          <a:xfrm>
+            <a:off x="6638544" y="3666744"/>
+            <a:ext cx="256032" cy="256032"/>
+          </a:xfrm>
+          <a:prstGeom prst="rect">
+            <a:avLst/>
+          </a:prstGeom>
+        </p:spPr>
+      </p:pic>
+      <p:sp>
+        <p:nvSpPr>
+          <p:cNvPr id="24" name="Text 17"/>
+          <p:cNvSpPr/>
+          <p:nvPr/>
+        </p:nvSpPr>
+        <p:spPr>
+          <a:xfrm>
+            <a:off x="7178040" y="3465576"/>
+            <a:ext cx="4297680" cy="365760"/>
+          </a:xfrm>
+          <a:prstGeom prst="rect">
+            <a:avLst/>
+          </a:prstGeom>
+          <a:noFill/>
+          <a:ln/>
+        </p:spPr>
+        <p:txBody>
+          <a:bodyPr wrap="square" lIns="0" tIns="0" rIns="0" bIns="0" rtlCol="0" anchor="t"/>
+          <a:lstStyle/>
+          <a:p>
+            <a:pPr algn="l" indent="0" marL="0">
+              <a:buNone/>
+            </a:pPr>
+            <a:r>
+              <a:rPr lang="en-US" sz="1650" b="1" dirty="0">
+                <a:solidFill>
+                  <a:srgbClr val="FFFFFF"/>
+                </a:solidFill>
+                <a:latin typeface="Cambria" pitchFamily="34" charset="0"/>
+                <a:ea typeface="Cambria" pitchFamily="34" charset="-122"/>
+                <a:cs typeface="Cambria" pitchFamily="34" charset="-120"/>
+              </a:rPr>
+              <a:t>DOACs</a:t>
+            </a:r>
+            <a:endParaRPr lang="en-US" sz="1650" dirty="0"/>
+          </a:p>
+        </p:txBody>
+      </p:sp>
+      <p:sp>
+        <p:nvSpPr>
+          <p:cNvPr id="25" name="Text 18"/>
+          <p:cNvSpPr/>
+          <p:nvPr/>
+        </p:nvSpPr>
+        <p:spPr>
+          <a:xfrm>
+            <a:off x="7178040" y="3822192"/>
+            <a:ext cx="4343400" cy="685800"/>
+          </a:xfrm>
+          <a:prstGeom prst="rect">
+            <a:avLst/>
+          </a:prstGeom>
+          <a:noFill/>
+          <a:ln/>
+        </p:spPr>
+        <p:txBody>
+          <a:bodyPr wrap="square" lIns="0" tIns="0" rIns="0" bIns="0" rtlCol="0" anchor="t"/>
+          <a:lstStyle/>
+          <a:p>
+            <a:pPr algn="l" indent="0" marL="0">
+              <a:lnSpc>
+                <a:spcPct val="108000"/>
+              </a:lnSpc>
+              <a:buNone/>
+            </a:pPr>
+            <a:r>
+              <a:rPr lang="en-US" sz="1250" dirty="0">
+                <a:solidFill>
+                  <a:srgbClr val="FBD8DF"/>
+                </a:solidFill>
+                <a:latin typeface="Calibri" pitchFamily="34" charset="0"/>
+                <a:ea typeface="Calibri" pitchFamily="34" charset="-122"/>
+                <a:cs typeface="Calibri" pitchFamily="34" charset="-120"/>
+              </a:rPr>
+              <a:t>Not recommended — cross the placenta with limited safety data</a:t>
+            </a:r>
+            <a:endParaRPr lang="en-US" sz="1250" dirty="0"/>
+          </a:p>
+        </p:txBody>
+      </p:sp>
+      <p:sp>
+        <p:nvSpPr>
+          <p:cNvPr id="26" name="Shape 19"/>
+          <p:cNvSpPr/>
+          <p:nvPr/>
+        </p:nvSpPr>
+        <p:spPr>
+          <a:xfrm>
+            <a:off x="502920" y="4937760"/>
+            <a:ext cx="11183112" cy="1051560"/>
+          </a:xfrm>
+          <a:prstGeom prst="roundRect">
+            <a:avLst>
+              <a:gd name="adj" fmla="val 10435"/>
+            </a:avLst>
+          </a:prstGeom>
+          <a:solidFill>
+            <a:srgbClr val="FBD8DF"/>
+          </a:solidFill>
+          <a:ln/>
+        </p:spPr>
+      </p:sp>
+      <p:sp>
+        <p:nvSpPr>
+          <p:cNvPr id="27" name="Text 20"/>
+          <p:cNvSpPr/>
+          <p:nvPr/>
+        </p:nvSpPr>
+        <p:spPr>
+          <a:xfrm>
+            <a:off x="914400" y="5084064"/>
+            <a:ext cx="10424160" cy="365760"/>
+          </a:xfrm>
+          <a:prstGeom prst="rect">
+            <a:avLst/>
+          </a:prstGeom>
+          <a:noFill/>
+          <a:ln/>
+        </p:spPr>
+        <p:txBody>
+          <a:bodyPr wrap="square" lIns="0" tIns="0" rIns="0" bIns="0" rtlCol="0" anchor="ctr"/>
+          <a:lstStyle/>
+          <a:p>
+            <a:pPr algn="l" indent="0" marL="0">
+              <a:buNone/>
+            </a:pPr>
+            <a:r>
+              <a:rPr lang="en-US" sz="1350" b="1" dirty="0">
+                <a:solidFill>
+                  <a:srgbClr val="A4133C"/>
+                </a:solidFill>
+                <a:latin typeface="Calibri" pitchFamily="34" charset="0"/>
+                <a:ea typeface="Calibri" pitchFamily="34" charset="-122"/>
+                <a:cs typeface="Calibri" pitchFamily="34" charset="-120"/>
+              </a:rPr>
+              <a:t>Peri-delivery   </a:t>
+            </a:r>
+            <a:pPr algn="l" indent="0" marL="0">
+              <a:buNone/>
+            </a:pPr>
+            <a:r>
+              <a:rPr lang="en-US" sz="1350" dirty="0">
+                <a:solidFill>
+                  <a:srgbClr val="2B2B33"/>
+                </a:solidFill>
+                <a:latin typeface="Calibri" pitchFamily="34" charset="0"/>
+                <a:ea typeface="Calibri" pitchFamily="34" charset="-122"/>
+                <a:cs typeface="Calibri" pitchFamily="34" charset="-120"/>
+              </a:rPr>
+              <a:t>switch LMWH → UFH (or briefly hold) to allow neuraxial anaesthesia and limit bleeding.</a:t>
+            </a:r>
+            <a:endParaRPr lang="en-US" sz="1350" dirty="0"/>
+          </a:p>
+        </p:txBody>
+      </p:sp>
+      <p:sp>
+        <p:nvSpPr>
+          <p:cNvPr id="28" name="Text 21"/>
+          <p:cNvSpPr/>
+          <p:nvPr/>
+        </p:nvSpPr>
+        <p:spPr>
+          <a:xfrm>
+            <a:off x="914400" y="5468112"/>
+            <a:ext cx="10607040" cy="365760"/>
+          </a:xfrm>
+          <a:prstGeom prst="rect">
+            <a:avLst/>
+          </a:prstGeom>
+          <a:noFill/>
+          <a:ln/>
+        </p:spPr>
+        <p:txBody>
+          <a:bodyPr wrap="square" lIns="0" tIns="0" rIns="0" bIns="0" rtlCol="0" anchor="ctr"/>
+          <a:lstStyle/>
+          <a:p>
+            <a:pPr algn="l" indent="0" marL="0">
+              <a:buNone/>
+            </a:pPr>
+            <a:r>
+              <a:rPr lang="en-US" sz="1350" b="1" dirty="0">
+                <a:solidFill>
+                  <a:srgbClr val="A4133C"/>
+                </a:solidFill>
+                <a:latin typeface="Calibri" pitchFamily="34" charset="0"/>
+                <a:ea typeface="Calibri" pitchFamily="34" charset="-122"/>
+                <a:cs typeface="Calibri" pitchFamily="34" charset="-120"/>
+              </a:rPr>
+              <a:t>Breastfeeding   </a:t>
+            </a:r>
+            <a:pPr algn="l" indent="0" marL="0">
+              <a:buNone/>
+            </a:pPr>
+            <a:r>
+              <a:rPr lang="en-US" sz="1350" dirty="0">
+                <a:solidFill>
+                  <a:srgbClr val="2B2B33"/>
+                </a:solidFill>
+                <a:latin typeface="Calibri" pitchFamily="34" charset="0"/>
+                <a:ea typeface="Calibri" pitchFamily="34" charset="-122"/>
+                <a:cs typeface="Calibri" pitchFamily="34" charset="-120"/>
+              </a:rPr>
+              <a:t>warfarin, LMWH and UFH are compatible; DOACs are avoided. Plan with a specialist team.</a:t>
+            </a:r>
+            <a:endParaRPr lang="en-US" sz="1350" dirty="0"/>
+          </a:p>
+        </p:txBody>
+      </p:sp>
+      <p:sp>
+        <p:nvSpPr>
+          <p:cNvPr id="29" name="Text 22"/>
+          <p:cNvSpPr/>
+          <p:nvPr/>
+        </p:nvSpPr>
+        <p:spPr>
+          <a:xfrm>
+            <a:off x="11277295" y="6355080"/>
+            <a:ext cx="548640" cy="320040"/>
+          </a:xfrm>
+          <a:prstGeom prst="rect">
+            <a:avLst/>
+          </a:prstGeom>
+          <a:noFill/>
+          <a:ln/>
+        </p:spPr>
+        <p:txBody>
+          <a:bodyPr wrap="square" rtlCol="0" anchor="t"/>
+          <a:lstStyle/>
+          <a:p>
+            <a:pPr algn="r" indent="0" marL="0">
+              <a:buNone/>
+            </a:pPr>
+            <a:r>
+              <a:rPr lang="en-US" sz="1100" b="1" dirty="0">
+                <a:solidFill>
+                  <a:srgbClr val="6B6B76"/>
+                </a:solidFill>
+                <a:latin typeface="Calibri" pitchFamily="34" charset="0"/>
+                <a:ea typeface="Calibri" pitchFamily="34" charset="-122"/>
+                <a:cs typeface="Calibri" pitchFamily="34" charset="-120"/>
+              </a:rPr>
+              <a:t>16</a:t>
+            </a:r>
+            <a:endParaRPr lang="en-US" sz="1100" dirty="0"/>
+          </a:p>
+        </p:txBody>
+      </p:sp>
+      <p:sp>
+        <p:nvSpPr>
+          <p:cNvPr id="30" name="Text 23"/>
+          <p:cNvSpPr/>
+          <p:nvPr/>
+        </p:nvSpPr>
+        <p:spPr>
+          <a:xfrm>
+            <a:off x="502920" y="6355080"/>
+            <a:ext cx="7315200" cy="320040"/>
+          </a:xfrm>
+          <a:prstGeom prst="rect">
+            <a:avLst/>
+          </a:prstGeom>
+          <a:noFill/>
+          <a:ln/>
+        </p:spPr>
+        <p:txBody>
+          <a:bodyPr wrap="square" rtlCol="0" anchor="t"/>
+          <a:lstStyle/>
+          <a:p>
+            <a:pPr algn="l" indent="0" marL="0">
+              <a:buNone/>
+            </a:pPr>
+            <a:r>
+              <a:rPr lang="en-US" sz="900" dirty="0">
+                <a:solidFill>
+                  <a:srgbClr val="6B6B76"/>
+                </a:solidFill>
+                <a:latin typeface="Calibri" pitchFamily="34" charset="0"/>
+                <a:ea typeface="Calibri" pitchFamily="34" charset="-122"/>
+                <a:cs typeface="Calibri" pitchFamily="34" charset="-120"/>
+              </a:rPr>
+              <a:t>Atrial Fibrillation — Clinical Topic Review</a:t>
+            </a:r>
+            <a:endParaRPr lang="en-US" sz="900" dirty="0"/>
+          </a:p>
+        </p:txBody>
+      </p:sp>
+    </p:spTree>
+  </p:cSld>
+  <p:clrMapOvr>
+    <a:masterClrMapping/>
+  </p:clrMapOvr>
+</p:sld>
+</file>
+
+<file path=ppt/slides/slide17.xml><?xml version="1.0" encoding="utf-8"?>
+<p:sld xmlns:a="http://schemas.openxmlformats.org/drawingml/2006/main" xmlns:r="http://schemas.openxmlformats.org/officeDocument/2006/relationships" xmlns:p="http://schemas.openxmlformats.org/presentationml/2006/main">
+  <p:cSld name="Slide 17">
+    <p:bg>
+      <p:bgPr>
+        <a:solidFill>
+          <a:srgbClr val="FFFFFF"/>
+        </a:solidFill>
+      </p:bgPr>
+    </p:bg>
+    <p:spTree>
+      <p:nvGrpSpPr>
+        <p:cNvPr id="1" name=""/>
+        <p:cNvGrpSpPr/>
+        <p:nvPr/>
+      </p:nvGrpSpPr>
+      <p:grpSpPr>
+        <a:xfrm>
+          <a:off x="0" y="0"/>
+          <a:ext cx="0" cy="0"/>
+          <a:chOff x="0" y="0"/>
+          <a:chExt cx="0" cy="0"/>
+        </a:xfrm>
+      </p:grpSpPr>
+      <p:sp>
+        <p:nvSpPr>
+          <p:cNvPr id="2" name="Shape 0"/>
+          <p:cNvSpPr/>
+          <p:nvPr/>
+        </p:nvSpPr>
+        <p:spPr>
+          <a:xfrm>
+            <a:off x="502920" y="457200"/>
+            <a:ext cx="868680" cy="868680"/>
+          </a:xfrm>
+          <a:prstGeom prst="ellipse">
+            <a:avLst/>
+          </a:prstGeom>
+          <a:solidFill>
+            <a:srgbClr val="FFF0F3"/>
+          </a:solidFill>
+          <a:ln w="12700">
+            <a:solidFill>
+              <a:srgbClr val="FBD8DF"/>
+            </a:solidFill>
+            <a:prstDash val="solid"/>
+          </a:ln>
+        </p:spPr>
+      </p:sp>
+      <p:pic>
+        <p:nvPicPr>
+          <p:cNvPr id="3" name="Image 0" descr="preencoded.png">    </p:cNvPr>
+          <p:cNvPicPr>
+            <a:picLocks noChangeAspect="1"/>
+          </p:cNvPicPr>
+          <p:nvPr/>
+        </p:nvPicPr>
+        <p:blipFill>
+          <a:blip r:embed="rId1"/>
+          <a:stretch>
+            <a:fillRect/>
+          </a:stretch>
+        </p:blipFill>
+        <p:spPr>
+          <a:xfrm>
+            <a:off x="694944" y="649224"/>
+            <a:ext cx="484632" cy="484632"/>
+          </a:xfrm>
+          <a:prstGeom prst="rect">
+            <a:avLst/>
+          </a:prstGeom>
+        </p:spPr>
+      </p:pic>
+      <p:sp>
+        <p:nvSpPr>
+          <p:cNvPr id="4" name="Text 1"/>
+          <p:cNvSpPr/>
+          <p:nvPr/>
+        </p:nvSpPr>
+        <p:spPr>
+          <a:xfrm>
+            <a:off x="1572768" y="502920"/>
+            <a:ext cx="9966960" cy="274320"/>
+          </a:xfrm>
+          <a:prstGeom prst="rect">
+            <a:avLst/>
+          </a:prstGeom>
+          <a:noFill/>
+          <a:ln/>
+        </p:spPr>
+        <p:txBody>
+          <a:bodyPr wrap="square" rtlCol="0" anchor="t"/>
+          <a:lstStyle/>
+          <a:p>
+            <a:pPr algn="l" indent="0" marL="0">
+              <a:buNone/>
+            </a:pPr>
+            <a:r>
+              <a:rPr lang="en-US" sz="1250" b="1" spc="200" kern="0" dirty="0">
+                <a:solidFill>
+                  <a:srgbClr val="A4133C"/>
+                </a:solidFill>
+                <a:latin typeface="Calibri" pitchFamily="34" charset="0"/>
+                <a:ea typeface="Calibri" pitchFamily="34" charset="-122"/>
+                <a:cs typeface="Calibri" pitchFamily="34" charset="-120"/>
+              </a:rPr>
+              <a:t>SPECIAL POPULATIONS · PREGNANCY</a:t>
+            </a:r>
+            <a:endParaRPr lang="en-US" sz="1250" dirty="0"/>
+          </a:p>
+        </p:txBody>
+      </p:sp>
+      <p:sp>
+        <p:nvSpPr>
+          <p:cNvPr id="5" name="Text 2"/>
+          <p:cNvSpPr/>
+          <p:nvPr/>
+        </p:nvSpPr>
+        <p:spPr>
+          <a:xfrm>
+            <a:off x="1554480" y="749808"/>
+            <a:ext cx="10241280" cy="640080"/>
+          </a:xfrm>
+          <a:prstGeom prst="rect">
+            <a:avLst/>
+          </a:prstGeom>
+          <a:noFill/>
+          <a:ln/>
+        </p:spPr>
+        <p:txBody>
+          <a:bodyPr wrap="square" rtlCol="0" anchor="t"/>
+          <a:lstStyle/>
+          <a:p>
+            <a:pPr algn="l" indent="0" marL="0">
+              <a:buNone/>
+            </a:pPr>
+            <a:r>
+              <a:rPr lang="en-US" sz="3000" b="1" dirty="0">
+                <a:solidFill>
+                  <a:srgbClr val="2B2B33"/>
+                </a:solidFill>
+                <a:latin typeface="Cambria" pitchFamily="34" charset="0"/>
+                <a:ea typeface="Cambria" pitchFamily="34" charset="-122"/>
+                <a:cs typeface="Cambria" pitchFamily="34" charset="-120"/>
+              </a:rPr>
+              <a:t>Rhythm &amp; Rate Control in Pregnancy</a:t>
+            </a:r>
+            <a:endParaRPr lang="en-US" sz="3000" dirty="0"/>
+          </a:p>
+        </p:txBody>
+      </p:sp>
+      <p:sp>
+        <p:nvSpPr>
+          <p:cNvPr id="6" name="Shape 3"/>
+          <p:cNvSpPr/>
+          <p:nvPr/>
+        </p:nvSpPr>
+        <p:spPr>
+          <a:xfrm>
+            <a:off x="502920" y="1783080"/>
+            <a:ext cx="5532120" cy="4206240"/>
+          </a:xfrm>
+          <a:prstGeom prst="roundRect">
+            <a:avLst>
+              <a:gd name="adj" fmla="val 2609"/>
+            </a:avLst>
+          </a:prstGeom>
+          <a:solidFill>
+            <a:srgbClr val="FFF0F3"/>
+          </a:solidFill>
+          <a:ln w="12700">
+            <a:solidFill>
+              <a:srgbClr val="FBD8DF"/>
+            </a:solidFill>
+            <a:prstDash val="solid"/>
+          </a:ln>
+          <a:effectLst>
+            <a:outerShdw sx="100000" sy="100000" kx="0" ky="0" algn="bl" rotWithShape="0" blurRad="127000" dist="50800" dir="5400000">
+              <a:srgbClr val="C9A3AC">
+                <a:alpha val="45000"/>
+              </a:srgbClr>
+            </a:outerShdw>
+          </a:effectLst>
+        </p:spPr>
+      </p:sp>
+      <p:sp>
+        <p:nvSpPr>
+          <p:cNvPr id="7" name="Text 4"/>
+          <p:cNvSpPr/>
+          <p:nvPr/>
+        </p:nvSpPr>
+        <p:spPr>
+          <a:xfrm>
+            <a:off x="868680" y="2057400"/>
+            <a:ext cx="4846320" cy="274320"/>
+          </a:xfrm>
+          <a:prstGeom prst="rect">
+            <a:avLst/>
+          </a:prstGeom>
+          <a:noFill/>
+          <a:ln/>
+        </p:spPr>
+        <p:txBody>
+          <a:bodyPr wrap="square" rtlCol="0" anchor="t"/>
+          <a:lstStyle/>
+          <a:p>
+            <a:pPr algn="l" indent="0" marL="0">
+              <a:buNone/>
+            </a:pPr>
+            <a:r>
+              <a:rPr lang="en-US" sz="1300" b="1" spc="150" kern="0" dirty="0">
+                <a:solidFill>
+                  <a:srgbClr val="2E7D32"/>
+                </a:solidFill>
+                <a:latin typeface="Calibri" pitchFamily="34" charset="0"/>
+                <a:ea typeface="Calibri" pitchFamily="34" charset="-122"/>
+                <a:cs typeface="Calibri" pitchFamily="34" charset="-120"/>
+              </a:rPr>
+              <a:t>✓  </a:t>
+            </a:r>
+            <a:pPr algn="l" indent="0" marL="0">
+              <a:buNone/>
+            </a:pPr>
+            <a:r>
+              <a:rPr lang="en-US" sz="1300" b="1" spc="150" kern="0" dirty="0">
+                <a:solidFill>
+                  <a:srgbClr val="2E7D32"/>
+                </a:solidFill>
+                <a:latin typeface="Calibri" pitchFamily="34" charset="0"/>
+                <a:ea typeface="Calibri" pitchFamily="34" charset="-122"/>
+                <a:cs typeface="Calibri" pitchFamily="34" charset="-120"/>
+              </a:rPr>
+              <a:t>GENERALLY SAFE</a:t>
+            </a:r>
+            <a:endParaRPr lang="en-US" sz="1300" dirty="0"/>
+          </a:p>
+        </p:txBody>
+      </p:sp>
+      <p:sp>
+        <p:nvSpPr>
+          <p:cNvPr id="8" name="Shape 5"/>
+          <p:cNvSpPr/>
+          <p:nvPr/>
+        </p:nvSpPr>
+        <p:spPr>
+          <a:xfrm>
+            <a:off x="868680" y="2542032"/>
+            <a:ext cx="566928" cy="566928"/>
+          </a:xfrm>
+          <a:prstGeom prst="ellipse">
+            <a:avLst/>
+          </a:prstGeom>
+          <a:solidFill>
+            <a:srgbClr val="FFFFFF"/>
+          </a:solidFill>
+          <a:ln w="12700">
+            <a:solidFill>
+              <a:srgbClr val="FBD8DF"/>
+            </a:solidFill>
+            <a:prstDash val="solid"/>
+          </a:ln>
+        </p:spPr>
+      </p:sp>
+      <p:pic>
+        <p:nvPicPr>
+          <p:cNvPr id="9" name="Image 1" descr="preencoded.png">    </p:cNvPr>
+          <p:cNvPicPr>
+            <a:picLocks noChangeAspect="1"/>
+          </p:cNvPicPr>
+          <p:nvPr/>
+        </p:nvPicPr>
+        <p:blipFill>
+          <a:blip r:embed="rId2"/>
+          <a:stretch>
+            <a:fillRect/>
+          </a:stretch>
+        </p:blipFill>
+        <p:spPr>
+          <a:xfrm>
+            <a:off x="1014984" y="2688336"/>
+            <a:ext cx="274320" cy="274320"/>
+          </a:xfrm>
+          <a:prstGeom prst="rect">
+            <a:avLst/>
+          </a:prstGeom>
+        </p:spPr>
+      </p:pic>
+      <p:sp>
+        <p:nvSpPr>
+          <p:cNvPr id="10" name="Text 6"/>
+          <p:cNvSpPr/>
+          <p:nvPr/>
+        </p:nvSpPr>
+        <p:spPr>
+          <a:xfrm>
+            <a:off x="1618488" y="2505456"/>
+            <a:ext cx="4233672" cy="292608"/>
+          </a:xfrm>
+          <a:prstGeom prst="rect">
+            <a:avLst/>
+          </a:prstGeom>
+          <a:noFill/>
+          <a:ln/>
+        </p:spPr>
+        <p:txBody>
+          <a:bodyPr wrap="square" lIns="0" tIns="0" rIns="0" bIns="0" rtlCol="0" anchor="t"/>
+          <a:lstStyle/>
+          <a:p>
+            <a:pPr algn="l" indent="0" marL="0">
+              <a:buNone/>
+            </a:pPr>
+            <a:r>
+              <a:rPr lang="en-US" sz="1600" b="1" dirty="0">
+                <a:solidFill>
+                  <a:srgbClr val="2B2B33"/>
+                </a:solidFill>
+                <a:latin typeface="Cambria" pitchFamily="34" charset="0"/>
+                <a:ea typeface="Cambria" pitchFamily="34" charset="-122"/>
+                <a:cs typeface="Cambria" pitchFamily="34" charset="-120"/>
+              </a:rPr>
+              <a:t>Beta-blockers</a:t>
+            </a:r>
+            <a:endParaRPr lang="en-US" sz="1600" dirty="0"/>
+          </a:p>
+        </p:txBody>
+      </p:sp>
+      <p:sp>
+        <p:nvSpPr>
+          <p:cNvPr id="11" name="Text 7"/>
+          <p:cNvSpPr/>
+          <p:nvPr/>
+        </p:nvSpPr>
+        <p:spPr>
+          <a:xfrm>
+            <a:off x="1618488" y="2816352"/>
+            <a:ext cx="4233672" cy="365760"/>
+          </a:xfrm>
+          <a:prstGeom prst="rect">
+            <a:avLst/>
+          </a:prstGeom>
+          <a:noFill/>
+          <a:ln/>
+        </p:spPr>
+        <p:txBody>
+          <a:bodyPr wrap="square" lIns="0" tIns="0" rIns="0" bIns="0" rtlCol="0" anchor="t"/>
+          <a:lstStyle/>
+          <a:p>
+            <a:pPr algn="l" indent="0" marL="0">
+              <a:buNone/>
+            </a:pPr>
+            <a:r>
+              <a:rPr lang="en-US" sz="1250" dirty="0">
+                <a:solidFill>
+                  <a:srgbClr val="6B6B76"/>
+                </a:solidFill>
+                <a:latin typeface="Calibri" pitchFamily="34" charset="0"/>
+                <a:ea typeface="Calibri" pitchFamily="34" charset="-122"/>
+                <a:cs typeface="Calibri" pitchFamily="34" charset="-120"/>
+              </a:rPr>
+              <a:t>First-line rate control (metoprolol, bisoprolol) — avoid atenolol</a:t>
+            </a:r>
+            <a:endParaRPr lang="en-US" sz="1250" dirty="0"/>
+          </a:p>
+        </p:txBody>
+      </p:sp>
+      <p:sp>
+        <p:nvSpPr>
+          <p:cNvPr id="12" name="Shape 8"/>
+          <p:cNvSpPr/>
+          <p:nvPr/>
+        </p:nvSpPr>
+        <p:spPr>
+          <a:xfrm>
+            <a:off x="868680" y="3621024"/>
+            <a:ext cx="566928" cy="566928"/>
+          </a:xfrm>
+          <a:prstGeom prst="ellipse">
+            <a:avLst/>
+          </a:prstGeom>
+          <a:solidFill>
+            <a:srgbClr val="FFFFFF"/>
+          </a:solidFill>
+          <a:ln w="12700">
+            <a:solidFill>
+              <a:srgbClr val="FBD8DF"/>
+            </a:solidFill>
+            <a:prstDash val="solid"/>
+          </a:ln>
+        </p:spPr>
+      </p:sp>
+      <p:pic>
+        <p:nvPicPr>
+          <p:cNvPr id="13" name="Image 2" descr="preencoded.png">    </p:cNvPr>
+          <p:cNvPicPr>
+            <a:picLocks noChangeAspect="1"/>
+          </p:cNvPicPr>
+          <p:nvPr/>
+        </p:nvPicPr>
+        <p:blipFill>
+          <a:blip r:embed="rId3"/>
+          <a:stretch>
+            <a:fillRect/>
+          </a:stretch>
+        </p:blipFill>
+        <p:spPr>
+          <a:xfrm>
+            <a:off x="1014984" y="3767328"/>
+            <a:ext cx="274320" cy="274320"/>
+          </a:xfrm>
+          <a:prstGeom prst="rect">
+            <a:avLst/>
+          </a:prstGeom>
+        </p:spPr>
+      </p:pic>
+      <p:sp>
+        <p:nvSpPr>
+          <p:cNvPr id="14" name="Text 9"/>
+          <p:cNvSpPr/>
+          <p:nvPr/>
+        </p:nvSpPr>
+        <p:spPr>
+          <a:xfrm>
+            <a:off x="1618488" y="3584448"/>
+            <a:ext cx="4233672" cy="292608"/>
+          </a:xfrm>
+          <a:prstGeom prst="rect">
+            <a:avLst/>
+          </a:prstGeom>
+          <a:noFill/>
+          <a:ln/>
+        </p:spPr>
+        <p:txBody>
+          <a:bodyPr wrap="square" lIns="0" tIns="0" rIns="0" bIns="0" rtlCol="0" anchor="t"/>
+          <a:lstStyle/>
+          <a:p>
+            <a:pPr algn="l" indent="0" marL="0">
+              <a:buNone/>
+            </a:pPr>
+            <a:r>
+              <a:rPr lang="en-US" sz="1600" b="1" dirty="0">
+                <a:solidFill>
+                  <a:srgbClr val="2B2B33"/>
+                </a:solidFill>
+                <a:latin typeface="Cambria" pitchFamily="34" charset="0"/>
+                <a:ea typeface="Cambria" pitchFamily="34" charset="-122"/>
+                <a:cs typeface="Cambria" pitchFamily="34" charset="-120"/>
+              </a:rPr>
+              <a:t>Digoxin</a:t>
+            </a:r>
+            <a:endParaRPr lang="en-US" sz="1600" dirty="0"/>
+          </a:p>
+        </p:txBody>
+      </p:sp>
+      <p:sp>
+        <p:nvSpPr>
+          <p:cNvPr id="15" name="Text 10"/>
+          <p:cNvSpPr/>
+          <p:nvPr/>
+        </p:nvSpPr>
+        <p:spPr>
+          <a:xfrm>
+            <a:off x="1618488" y="3895344"/>
+            <a:ext cx="4233672" cy="365760"/>
+          </a:xfrm>
+          <a:prstGeom prst="rect">
+            <a:avLst/>
+          </a:prstGeom>
+          <a:noFill/>
+          <a:ln/>
+        </p:spPr>
+        <p:txBody>
+          <a:bodyPr wrap="square" lIns="0" tIns="0" rIns="0" bIns="0" rtlCol="0" anchor="t"/>
+          <a:lstStyle/>
+          <a:p>
+            <a:pPr algn="l" indent="0" marL="0">
+              <a:buNone/>
+            </a:pPr>
+            <a:r>
+              <a:rPr lang="en-US" sz="1250" dirty="0">
+                <a:solidFill>
+                  <a:srgbClr val="6B6B76"/>
+                </a:solidFill>
+                <a:latin typeface="Calibri" pitchFamily="34" charset="0"/>
+                <a:ea typeface="Calibri" pitchFamily="34" charset="-122"/>
+                <a:cs typeface="Calibri" pitchFamily="34" charset="-120"/>
+              </a:rPr>
+              <a:t>Safe option for rate control</a:t>
+            </a:r>
+            <a:endParaRPr lang="en-US" sz="1250" dirty="0"/>
+          </a:p>
+        </p:txBody>
+      </p:sp>
+      <p:sp>
+        <p:nvSpPr>
+          <p:cNvPr id="16" name="Shape 11"/>
+          <p:cNvSpPr/>
+          <p:nvPr/>
+        </p:nvSpPr>
+        <p:spPr>
+          <a:xfrm>
+            <a:off x="868680" y="4700016"/>
+            <a:ext cx="566928" cy="566928"/>
+          </a:xfrm>
+          <a:prstGeom prst="ellipse">
+            <a:avLst/>
+          </a:prstGeom>
+          <a:solidFill>
+            <a:srgbClr val="FFFFFF"/>
+          </a:solidFill>
+          <a:ln w="12700">
+            <a:solidFill>
+              <a:srgbClr val="FBD8DF"/>
+            </a:solidFill>
+            <a:prstDash val="solid"/>
+          </a:ln>
+        </p:spPr>
+      </p:sp>
+      <p:pic>
+        <p:nvPicPr>
+          <p:cNvPr id="17" name="Image 3" descr="preencoded.png">    </p:cNvPr>
+          <p:cNvPicPr>
+            <a:picLocks noChangeAspect="1"/>
+          </p:cNvPicPr>
+          <p:nvPr/>
+        </p:nvPicPr>
+        <p:blipFill>
+          <a:blip r:embed="rId4"/>
+          <a:stretch>
+            <a:fillRect/>
+          </a:stretch>
+        </p:blipFill>
+        <p:spPr>
+          <a:xfrm>
+            <a:off x="1014984" y="4846320"/>
+            <a:ext cx="274320" cy="274320"/>
+          </a:xfrm>
+          <a:prstGeom prst="rect">
+            <a:avLst/>
+          </a:prstGeom>
+        </p:spPr>
+      </p:pic>
+      <p:sp>
+        <p:nvSpPr>
+          <p:cNvPr id="18" name="Text 12"/>
+          <p:cNvSpPr/>
+          <p:nvPr/>
+        </p:nvSpPr>
+        <p:spPr>
+          <a:xfrm>
+            <a:off x="1618488" y="4663440"/>
+            <a:ext cx="4233672" cy="292608"/>
+          </a:xfrm>
+          <a:prstGeom prst="rect">
+            <a:avLst/>
+          </a:prstGeom>
+          <a:noFill/>
+          <a:ln/>
+        </p:spPr>
+        <p:txBody>
+          <a:bodyPr wrap="square" lIns="0" tIns="0" rIns="0" bIns="0" rtlCol="0" anchor="t"/>
+          <a:lstStyle/>
+          <a:p>
+            <a:pPr algn="l" indent="0" marL="0">
+              <a:buNone/>
+            </a:pPr>
+            <a:r>
+              <a:rPr lang="en-US" sz="1600" b="1" dirty="0">
+                <a:solidFill>
+                  <a:srgbClr val="2B2B33"/>
+                </a:solidFill>
+                <a:latin typeface="Cambria" pitchFamily="34" charset="0"/>
+                <a:ea typeface="Cambria" pitchFamily="34" charset="-122"/>
+                <a:cs typeface="Cambria" pitchFamily="34" charset="-120"/>
+              </a:rPr>
+              <a:t>Flecainide / sotalol</a:t>
+            </a:r>
+            <a:endParaRPr lang="en-US" sz="1600" dirty="0"/>
+          </a:p>
+        </p:txBody>
+      </p:sp>
+      <p:sp>
+        <p:nvSpPr>
+          <p:cNvPr id="19" name="Text 13"/>
+          <p:cNvSpPr/>
+          <p:nvPr/>
+        </p:nvSpPr>
+        <p:spPr>
+          <a:xfrm>
+            <a:off x="1618488" y="4974336"/>
+            <a:ext cx="4233672" cy="365760"/>
+          </a:xfrm>
+          <a:prstGeom prst="rect">
+            <a:avLst/>
+          </a:prstGeom>
+          <a:noFill/>
+          <a:ln/>
+        </p:spPr>
+        <p:txBody>
+          <a:bodyPr wrap="square" lIns="0" tIns="0" rIns="0" bIns="0" rtlCol="0" anchor="t"/>
+          <a:lstStyle/>
+          <a:p>
+            <a:pPr algn="l" indent="0" marL="0">
+              <a:buNone/>
+            </a:pPr>
+            <a:r>
+              <a:rPr lang="en-US" sz="1250" dirty="0">
+                <a:solidFill>
+                  <a:srgbClr val="6B6B76"/>
+                </a:solidFill>
+                <a:latin typeface="Calibri" pitchFamily="34" charset="0"/>
+                <a:ea typeface="Calibri" pitchFamily="34" charset="-122"/>
+                <a:cs typeface="Calibri" pitchFamily="34" charset="-120"/>
+              </a:rPr>
+              <a:t>For rhythm control when needed</a:t>
+            </a:r>
+            <a:endParaRPr lang="en-US" sz="1250" dirty="0"/>
+          </a:p>
+        </p:txBody>
+      </p:sp>
+      <p:sp>
+        <p:nvSpPr>
+          <p:cNvPr id="20" name="Shape 14"/>
+          <p:cNvSpPr/>
+          <p:nvPr/>
+        </p:nvSpPr>
+        <p:spPr>
+          <a:xfrm>
+            <a:off x="6172200" y="1783080"/>
+            <a:ext cx="5532120" cy="2011680"/>
+          </a:xfrm>
+          <a:prstGeom prst="roundRect">
+            <a:avLst>
+              <a:gd name="adj" fmla="val 5455"/>
+            </a:avLst>
+          </a:prstGeom>
+          <a:solidFill>
+            <a:srgbClr val="590D22"/>
+          </a:solidFill>
+          <a:ln/>
+          <a:effectLst>
+            <a:outerShdw sx="100000" sy="100000" kx="0" ky="0" algn="bl" rotWithShape="0" blurRad="127000" dist="50800" dir="5400000">
+              <a:srgbClr val="C9A3AC">
+                <a:alpha val="45000"/>
+              </a:srgbClr>
+            </a:outerShdw>
+          </a:effectLst>
+        </p:spPr>
+      </p:sp>
+      <p:sp>
+        <p:nvSpPr>
+          <p:cNvPr id="21" name="Shape 15"/>
+          <p:cNvSpPr/>
+          <p:nvPr/>
+        </p:nvSpPr>
+        <p:spPr>
+          <a:xfrm>
+            <a:off x="6492240" y="2148840"/>
+            <a:ext cx="868680" cy="868680"/>
+          </a:xfrm>
+          <a:prstGeom prst="ellipse">
+            <a:avLst/>
+          </a:prstGeom>
+          <a:solidFill>
+            <a:srgbClr val="A4133C"/>
+          </a:solidFill>
+          <a:ln/>
+        </p:spPr>
+      </p:sp>
+      <p:pic>
+        <p:nvPicPr>
+          <p:cNvPr id="22" name="Image 4" descr="preencoded.png">    </p:cNvPr>
+          <p:cNvPicPr>
+            <a:picLocks noChangeAspect="1"/>
+          </p:cNvPicPr>
+          <p:nvPr/>
+        </p:nvPicPr>
+        <p:blipFill>
+          <a:blip r:embed="rId5"/>
+          <a:stretch>
+            <a:fillRect/>
+          </a:stretch>
+        </p:blipFill>
+        <p:spPr>
+          <a:xfrm>
+            <a:off x="6729984" y="2377440"/>
+            <a:ext cx="402336" cy="402336"/>
+          </a:xfrm>
+          <a:prstGeom prst="rect">
+            <a:avLst/>
+          </a:prstGeom>
+        </p:spPr>
+      </p:pic>
+      <p:sp>
+        <p:nvSpPr>
+          <p:cNvPr id="23" name="Text 16"/>
+          <p:cNvSpPr/>
+          <p:nvPr/>
+        </p:nvSpPr>
+        <p:spPr>
+          <a:xfrm>
+            <a:off x="7498080" y="2194560"/>
+            <a:ext cx="4023360" cy="457200"/>
+          </a:xfrm>
+          <a:prstGeom prst="rect">
+            <a:avLst/>
+          </a:prstGeom>
+          <a:noFill/>
+          <a:ln/>
+        </p:spPr>
+        <p:txBody>
+          <a:bodyPr wrap="square" rtlCol="0" anchor="ctr"/>
+          <a:lstStyle/>
+          <a:p>
+            <a:pPr algn="l" indent="0" marL="0">
+              <a:buNone/>
+            </a:pPr>
+            <a:r>
+              <a:rPr lang="en-US" sz="2100" b="1" dirty="0">
+                <a:solidFill>
+                  <a:srgbClr val="FFFFFF"/>
+                </a:solidFill>
+                <a:latin typeface="Cambria" pitchFamily="34" charset="0"/>
+                <a:ea typeface="Cambria" pitchFamily="34" charset="-122"/>
+                <a:cs typeface="Cambria" pitchFamily="34" charset="-120"/>
+              </a:rPr>
+              <a:t>Cardioversion</a:t>
+            </a:r>
+            <a:endParaRPr lang="en-US" sz="2100" dirty="0"/>
+          </a:p>
+        </p:txBody>
+      </p:sp>
+      <p:sp>
+        <p:nvSpPr>
+          <p:cNvPr id="24" name="Text 17"/>
+          <p:cNvSpPr/>
+          <p:nvPr/>
+        </p:nvSpPr>
+        <p:spPr>
+          <a:xfrm>
+            <a:off x="6537960" y="2852928"/>
+            <a:ext cx="5029200" cy="822960"/>
+          </a:xfrm>
+          <a:prstGeom prst="rect">
+            <a:avLst/>
+          </a:prstGeom>
+          <a:noFill/>
+          <a:ln/>
+        </p:spPr>
+        <p:txBody>
+          <a:bodyPr wrap="square" rtlCol="0" anchor="t"/>
+          <a:lstStyle/>
+          <a:p>
+            <a:pPr algn="l" indent="0" marL="0">
+              <a:lnSpc>
+                <a:spcPct val="112000"/>
+              </a:lnSpc>
+              <a:buNone/>
+            </a:pPr>
+            <a:r>
+              <a:rPr lang="en-US" sz="1400" dirty="0">
+                <a:solidFill>
+                  <a:srgbClr val="FBD8DF"/>
+                </a:solidFill>
+                <a:latin typeface="Calibri" pitchFamily="34" charset="0"/>
+                <a:ea typeface="Calibri" pitchFamily="34" charset="-122"/>
+                <a:cs typeface="Calibri" pitchFamily="34" charset="-120"/>
+              </a:rPr>
+              <a:t>DC cardioversion is safe in all trimesters — perform with fetal monitoring.</a:t>
+            </a:r>
+            <a:endParaRPr lang="en-US" sz="1400" dirty="0"/>
+          </a:p>
+        </p:txBody>
+      </p:sp>
+      <p:sp>
+        <p:nvSpPr>
+          <p:cNvPr id="25" name="Shape 18"/>
+          <p:cNvSpPr/>
+          <p:nvPr/>
+        </p:nvSpPr>
+        <p:spPr>
+          <a:xfrm>
+            <a:off x="6172200" y="3977640"/>
+            <a:ext cx="5532120" cy="2011680"/>
+          </a:xfrm>
+          <a:prstGeom prst="roundRect">
+            <a:avLst>
+              <a:gd name="adj" fmla="val 5455"/>
+            </a:avLst>
+          </a:prstGeom>
+          <a:solidFill>
+            <a:srgbClr val="FFF0F3"/>
+          </a:solidFill>
+          <a:ln w="12700">
+            <a:solidFill>
+              <a:srgbClr val="FBD8DF"/>
+            </a:solidFill>
+            <a:prstDash val="solid"/>
+          </a:ln>
+          <a:effectLst>
+            <a:outerShdw sx="100000" sy="100000" kx="0" ky="0" algn="bl" rotWithShape="0" blurRad="127000" dist="50800" dir="5400000">
+              <a:srgbClr val="C9A3AC">
+                <a:alpha val="45000"/>
+              </a:srgbClr>
+            </a:outerShdw>
+          </a:effectLst>
+        </p:spPr>
+      </p:sp>
+      <p:sp>
+        <p:nvSpPr>
+          <p:cNvPr id="26" name="Text 19"/>
+          <p:cNvSpPr/>
+          <p:nvPr/>
+        </p:nvSpPr>
+        <p:spPr>
+          <a:xfrm>
+            <a:off x="6537960" y="4206240"/>
+            <a:ext cx="4937760" cy="274320"/>
+          </a:xfrm>
+          <a:prstGeom prst="rect">
+            <a:avLst/>
+          </a:prstGeom>
+          <a:noFill/>
+          <a:ln/>
+        </p:spPr>
+        <p:txBody>
+          <a:bodyPr wrap="square" rtlCol="0" anchor="t"/>
+          <a:lstStyle/>
+          <a:p>
+            <a:pPr algn="l" indent="0" marL="0">
+              <a:buNone/>
+            </a:pPr>
+            <a:r>
+              <a:rPr lang="en-US" sz="1300" b="1" spc="120" kern="0" dirty="0">
+                <a:solidFill>
+                  <a:srgbClr val="A4133C"/>
+                </a:solidFill>
+                <a:latin typeface="Calibri" pitchFamily="34" charset="0"/>
+                <a:ea typeface="Calibri" pitchFamily="34" charset="-122"/>
+                <a:cs typeface="Calibri" pitchFamily="34" charset="-120"/>
+              </a:rPr>
+              <a:t>✕  </a:t>
+            </a:r>
+            <a:pPr algn="l" indent="0" marL="0">
+              <a:buNone/>
+            </a:pPr>
+            <a:r>
+              <a:rPr lang="en-US" sz="1300" b="1" spc="120" kern="0" dirty="0">
+                <a:solidFill>
+                  <a:srgbClr val="A4133C"/>
+                </a:solidFill>
+                <a:latin typeface="Calibri" pitchFamily="34" charset="0"/>
+                <a:ea typeface="Calibri" pitchFamily="34" charset="-122"/>
+                <a:cs typeface="Calibri" pitchFamily="34" charset="-120"/>
+              </a:rPr>
+              <a:t>USE WITH CAUTION / AVOID</a:t>
+            </a:r>
+            <a:endParaRPr lang="en-US" sz="1300" dirty="0"/>
+          </a:p>
+        </p:txBody>
+      </p:sp>
+      <p:sp>
+        <p:nvSpPr>
+          <p:cNvPr id="27" name="Text 20"/>
+          <p:cNvSpPr/>
+          <p:nvPr/>
+        </p:nvSpPr>
+        <p:spPr>
+          <a:xfrm>
+            <a:off x="6537960" y="4645152"/>
+            <a:ext cx="5029200" cy="594360"/>
+          </a:xfrm>
+          <a:prstGeom prst="rect">
+            <a:avLst/>
+          </a:prstGeom>
+          <a:noFill/>
+          <a:ln/>
+        </p:spPr>
+        <p:txBody>
+          <a:bodyPr wrap="square" lIns="0" tIns="0" rIns="0" bIns="0" rtlCol="0" anchor="t"/>
+          <a:lstStyle/>
+          <a:p>
+            <a:pPr algn="l" indent="0" marL="0">
+              <a:lnSpc>
+                <a:spcPct val="105000"/>
+              </a:lnSpc>
+              <a:buNone/>
+            </a:pPr>
+            <a:r>
+              <a:rPr lang="en-US" sz="1350" b="1" dirty="0">
+                <a:solidFill>
+                  <a:srgbClr val="2B2B33"/>
+                </a:solidFill>
+                <a:latin typeface="Calibri" pitchFamily="34" charset="0"/>
+                <a:ea typeface="Calibri" pitchFamily="34" charset="-122"/>
+                <a:cs typeface="Calibri" pitchFamily="34" charset="-120"/>
+              </a:rPr>
+              <a:t>Amiodarone  </a:t>
+            </a:r>
+            <a:pPr algn="l" indent="0" marL="0">
+              <a:lnSpc>
+                <a:spcPct val="105000"/>
+              </a:lnSpc>
+              <a:buNone/>
+            </a:pPr>
+            <a:r>
+              <a:rPr lang="en-US" sz="1350" dirty="0">
+                <a:solidFill>
+                  <a:srgbClr val="6B6B76"/>
+                </a:solidFill>
+                <a:latin typeface="Calibri" pitchFamily="34" charset="0"/>
+                <a:ea typeface="Calibri" pitchFamily="34" charset="-122"/>
+                <a:cs typeface="Calibri" pitchFamily="34" charset="-120"/>
+              </a:rPr>
+              <a:t>— fetal thyroid dysfunction &amp; IUGR; only if life-threatening</a:t>
+            </a:r>
+            <a:endParaRPr lang="en-US" sz="1350" dirty="0"/>
+          </a:p>
+        </p:txBody>
+      </p:sp>
+      <p:sp>
+        <p:nvSpPr>
+          <p:cNvPr id="28" name="Text 21"/>
+          <p:cNvSpPr/>
+          <p:nvPr/>
+        </p:nvSpPr>
+        <p:spPr>
+          <a:xfrm>
+            <a:off x="6537960" y="5285232"/>
+            <a:ext cx="5029200" cy="457200"/>
+          </a:xfrm>
+          <a:prstGeom prst="rect">
+            <a:avLst/>
+          </a:prstGeom>
+          <a:noFill/>
+          <a:ln/>
+        </p:spPr>
+        <p:txBody>
+          <a:bodyPr wrap="square" lIns="0" tIns="0" rIns="0" bIns="0" rtlCol="0" anchor="t"/>
+          <a:lstStyle/>
+          <a:p>
+            <a:pPr algn="l" indent="0" marL="0">
+              <a:buNone/>
+            </a:pPr>
+            <a:r>
+              <a:rPr lang="en-US" sz="1350" b="1" dirty="0">
+                <a:solidFill>
+                  <a:srgbClr val="2B2B33"/>
+                </a:solidFill>
+                <a:latin typeface="Calibri" pitchFamily="34" charset="0"/>
+                <a:ea typeface="Calibri" pitchFamily="34" charset="-122"/>
+                <a:cs typeface="Calibri" pitchFamily="34" charset="-120"/>
+              </a:rPr>
+              <a:t>Atenolol  </a:t>
+            </a:r>
+            <a:pPr algn="l" indent="0" marL="0">
+              <a:buNone/>
+            </a:pPr>
+            <a:r>
+              <a:rPr lang="en-US" sz="1350" dirty="0">
+                <a:solidFill>
+                  <a:srgbClr val="6B6B76"/>
+                </a:solidFill>
+                <a:latin typeface="Calibri" pitchFamily="34" charset="0"/>
+                <a:ea typeface="Calibri" pitchFamily="34" charset="-122"/>
+                <a:cs typeface="Calibri" pitchFamily="34" charset="-120"/>
+              </a:rPr>
+              <a:t>— linked to fetal growth restriction</a:t>
+            </a:r>
+            <a:endParaRPr lang="en-US" sz="1350" dirty="0"/>
+          </a:p>
+        </p:txBody>
+      </p:sp>
+      <p:sp>
+        <p:nvSpPr>
+          <p:cNvPr id="29" name="Text 22"/>
+          <p:cNvSpPr/>
+          <p:nvPr/>
+        </p:nvSpPr>
+        <p:spPr>
+          <a:xfrm>
+            <a:off x="11277295" y="6355080"/>
+            <a:ext cx="548640" cy="320040"/>
+          </a:xfrm>
+          <a:prstGeom prst="rect">
+            <a:avLst/>
+          </a:prstGeom>
+          <a:noFill/>
+          <a:ln/>
+        </p:spPr>
+        <p:txBody>
+          <a:bodyPr wrap="square" rtlCol="0" anchor="t"/>
+          <a:lstStyle/>
+          <a:p>
+            <a:pPr algn="r" indent="0" marL="0">
+              <a:buNone/>
+            </a:pPr>
+            <a:r>
+              <a:rPr lang="en-US" sz="1100" b="1" dirty="0">
+                <a:solidFill>
+                  <a:srgbClr val="6B6B76"/>
+                </a:solidFill>
+                <a:latin typeface="Calibri" pitchFamily="34" charset="0"/>
+                <a:ea typeface="Calibri" pitchFamily="34" charset="-122"/>
+                <a:cs typeface="Calibri" pitchFamily="34" charset="-120"/>
+              </a:rPr>
+              <a:t>17</a:t>
+            </a:r>
+            <a:endParaRPr lang="en-US" sz="1100" dirty="0"/>
+          </a:p>
+        </p:txBody>
+      </p:sp>
+      <p:sp>
+        <p:nvSpPr>
+          <p:cNvPr id="30" name="Text 23"/>
+          <p:cNvSpPr/>
+          <p:nvPr/>
+        </p:nvSpPr>
+        <p:spPr>
+          <a:xfrm>
+            <a:off x="502920" y="6355080"/>
+            <a:ext cx="7315200" cy="320040"/>
+          </a:xfrm>
+          <a:prstGeom prst="rect">
+            <a:avLst/>
+          </a:prstGeom>
+          <a:noFill/>
+          <a:ln/>
+        </p:spPr>
+        <p:txBody>
+          <a:bodyPr wrap="square" rtlCol="0" anchor="t"/>
+          <a:lstStyle/>
+          <a:p>
+            <a:pPr algn="l" indent="0" marL="0">
+              <a:buNone/>
+            </a:pPr>
+            <a:r>
+              <a:rPr lang="en-US" sz="900" dirty="0">
+                <a:solidFill>
+                  <a:srgbClr val="6B6B76"/>
+                </a:solidFill>
+                <a:latin typeface="Calibri" pitchFamily="34" charset="0"/>
+                <a:ea typeface="Calibri" pitchFamily="34" charset="-122"/>
+                <a:cs typeface="Calibri" pitchFamily="34" charset="-120"/>
+              </a:rPr>
+              <a:t>Atrial Fibrillation — Clinical Topic Review</a:t>
+            </a:r>
+            <a:endParaRPr lang="en-US" sz="900" dirty="0"/>
+          </a:p>
+        </p:txBody>
+      </p:sp>
+    </p:spTree>
+  </p:cSld>
+  <p:clrMapOvr>
+    <a:masterClrMapping/>
+  </p:clrMapOvr>
+</p:sld>
+</file>
+
+<file path=ppt/slides/slide18.xml><?xml version="1.0" encoding="utf-8"?>
+<p:sld xmlns:a="http://schemas.openxmlformats.org/drawingml/2006/main" xmlns:r="http://schemas.openxmlformats.org/officeDocument/2006/relationships" xmlns:p="http://schemas.openxmlformats.org/presentationml/2006/main">
+  <p:cSld name="Slide 18">
+    <p:bg>
+      <p:bgPr>
+        <a:solidFill>
           <a:srgbClr val="590D22"/>
         </a:solidFill>
       </p:bgPr>
@@ -10927,7 +13197,7 @@
         </p:nvSpPr>
         <p:spPr>
           <a:xfrm>
-            <a:off x="713232" y="2816352"/>
+            <a:off x="713232" y="2596896"/>
             <a:ext cx="292608" cy="292608"/>
           </a:xfrm>
           <a:prstGeom prst="ellipse">
@@ -10955,7 +13225,7 @@
         </p:blipFill>
         <p:spPr>
           <a:xfrm>
-            <a:off x="777240" y="2880360"/>
+            <a:off x="777240" y="2660904"/>
             <a:ext cx="164592" cy="164592"/>
           </a:xfrm>
           <a:prstGeom prst="rect">
@@ -10971,8 +13241,8 @@
         </p:nvSpPr>
         <p:spPr>
           <a:xfrm>
-            <a:off x="1188720" y="2788920"/>
-            <a:ext cx="9692640" cy="548640"/>
+            <a:off x="1188720" y="2578608"/>
+            <a:ext cx="10058400" cy="502920"/>
           </a:xfrm>
           <a:prstGeom prst="rect">
             <a:avLst/>
@@ -10991,7 +13261,7 @@
               <a:buNone/>
             </a:pPr>
             <a:r>
-              <a:rPr lang="en-US" sz="1550" dirty="0">
+              <a:rPr lang="en-US" sz="1500" dirty="0">
                 <a:solidFill>
                   <a:srgbClr val="FBD8DF"/>
                 </a:solidFill>
@@ -11001,7 +13271,7 @@
               </a:rPr>
               <a:t>AF = irregularly irregular rhythm with absent P waves and a fibrillatory baseline.</a:t>
             </a:r>
-            <a:endParaRPr lang="en-US" sz="1550" dirty="0"/>
+            <a:endParaRPr lang="en-US" sz="1500" dirty="0"/>
           </a:p>
         </p:txBody>
       </p:sp>
@@ -11013,7 +13283,7 @@
         </p:nvSpPr>
         <p:spPr>
           <a:xfrm>
-            <a:off x="713232" y="3419856"/>
+            <a:off x="713232" y="3145536"/>
             <a:ext cx="292608" cy="292608"/>
           </a:xfrm>
           <a:prstGeom prst="ellipse">
@@ -11041,7 +13311,7 @@
         </p:blipFill>
         <p:spPr>
           <a:xfrm>
-            <a:off x="777240" y="3483864"/>
+            <a:off x="777240" y="3209544"/>
             <a:ext cx="164592" cy="164592"/>
           </a:xfrm>
           <a:prstGeom prst="rect">
@@ -11057,8 +13327,8 @@
         </p:nvSpPr>
         <p:spPr>
           <a:xfrm>
-            <a:off x="1188720" y="3392424"/>
-            <a:ext cx="9692640" cy="548640"/>
+            <a:off x="1188720" y="3127248"/>
+            <a:ext cx="10058400" cy="502920"/>
           </a:xfrm>
           <a:prstGeom prst="rect">
             <a:avLst/>
@@ -11077,7 +13347,7 @@
               <a:buNone/>
             </a:pPr>
             <a:r>
-              <a:rPr lang="en-US" sz="1550" dirty="0">
+              <a:rPr lang="en-US" sz="1500" dirty="0">
                 <a:solidFill>
                   <a:srgbClr val="FBD8DF"/>
                 </a:solidFill>
@@ -11085,9 +13355,9 @@
                 <a:ea typeface="Calibri" pitchFamily="34" charset="-122"/>
                 <a:cs typeface="Calibri" pitchFamily="34" charset="-120"/>
               </a:rPr>
-              <a:t>The commonest sustained arrhythmia — strongly linked to hypertension, age and structural heart disease.</a:t>
-            </a:r>
-            <a:endParaRPr lang="en-US" sz="1550" dirty="0"/>
+              <a:t>The commonest sustained arrhythmia — linked to hypertension, age and structural heart disease.</a:t>
+            </a:r>
+            <a:endParaRPr lang="en-US" sz="1500" dirty="0"/>
           </a:p>
         </p:txBody>
       </p:sp>
@@ -11099,7 +13369,7 @@
         </p:nvSpPr>
         <p:spPr>
           <a:xfrm>
-            <a:off x="713232" y="4023360"/>
+            <a:off x="713232" y="3694176"/>
             <a:ext cx="292608" cy="292608"/>
           </a:xfrm>
           <a:prstGeom prst="ellipse">
@@ -11127,7 +13397,7 @@
         </p:blipFill>
         <p:spPr>
           <a:xfrm>
-            <a:off x="777240" y="4087368"/>
+            <a:off x="777240" y="3758184"/>
             <a:ext cx="164592" cy="164592"/>
           </a:xfrm>
           <a:prstGeom prst="rect">
@@ -11143,8 +13413,8 @@
         </p:nvSpPr>
         <p:spPr>
           <a:xfrm>
-            <a:off x="1188720" y="3995928"/>
-            <a:ext cx="9692640" cy="548640"/>
+            <a:off x="1188720" y="3675888"/>
+            <a:ext cx="10058400" cy="502920"/>
           </a:xfrm>
           <a:prstGeom prst="rect">
             <a:avLst/>
@@ -11163,7 +13433,7 @@
               <a:buNone/>
             </a:pPr>
             <a:r>
-              <a:rPr lang="en-US" sz="1550" dirty="0">
+              <a:rPr lang="en-US" sz="1500" dirty="0">
                 <a:solidFill>
                   <a:srgbClr val="FBD8DF"/>
                 </a:solidFill>
@@ -11171,9 +13441,9 @@
                 <a:ea typeface="Calibri" pitchFamily="34" charset="-122"/>
                 <a:cs typeface="Calibri" pitchFamily="34" charset="-120"/>
               </a:rPr>
-              <a:t>Its main danger is thromboembolic stroke — always assess stroke risk.</a:t>
-            </a:r>
-            <a:endParaRPr lang="en-US" sz="1550" dirty="0"/>
+              <a:t>Its main danger is thromboembolic stroke — always assess stroke risk (CHA₂DS₂-VASc).</a:t>
+            </a:r>
+            <a:endParaRPr lang="en-US" sz="1500" dirty="0"/>
           </a:p>
         </p:txBody>
       </p:sp>
@@ -11185,7 +13455,7 @@
         </p:nvSpPr>
         <p:spPr>
           <a:xfrm>
-            <a:off x="713232" y="4626864"/>
+            <a:off x="713232" y="4242816"/>
             <a:ext cx="292608" cy="292608"/>
           </a:xfrm>
           <a:prstGeom prst="ellipse">
@@ -11213,7 +13483,7 @@
         </p:blipFill>
         <p:spPr>
           <a:xfrm>
-            <a:off x="777240" y="4690872"/>
+            <a:off x="777240" y="4306824"/>
             <a:ext cx="164592" cy="164592"/>
           </a:xfrm>
           <a:prstGeom prst="rect">
@@ -11229,8 +13499,8 @@
         </p:nvSpPr>
         <p:spPr>
           <a:xfrm>
-            <a:off x="1188720" y="4599432"/>
-            <a:ext cx="9692640" cy="548640"/>
+            <a:off x="1188720" y="4224528"/>
+            <a:ext cx="10058400" cy="502920"/>
           </a:xfrm>
           <a:prstGeom prst="rect">
             <a:avLst/>
@@ -11249,7 +13519,7 @@
               <a:buNone/>
             </a:pPr>
             <a:r>
-              <a:rPr lang="en-US" sz="1550" dirty="0">
+              <a:rPr lang="en-US" sz="1500" dirty="0">
                 <a:solidFill>
                   <a:srgbClr val="FBD8DF"/>
                 </a:solidFill>
@@ -11257,9 +13527,9 @@
                 <a:ea typeface="Calibri" pitchFamily="34" charset="-122"/>
                 <a:cs typeface="Calibri" pitchFamily="34" charset="-120"/>
               </a:rPr>
-              <a:t>Key differentials: atrial flutter, multifocal atrial tachycardia, frequent PACs, SVT, and pre-excited AF / VT.</a:t>
-            </a:r>
-            <a:endParaRPr lang="en-US" sz="1550" dirty="0"/>
+              <a:t>Differentials: atrial flutter, multifocal atrial tachycardia, frequent PACs, SVT, pre-excited AF / VT.</a:t>
+            </a:r>
+            <a:endParaRPr lang="en-US" sz="1500" dirty="0"/>
           </a:p>
         </p:txBody>
       </p:sp>
@@ -11271,7 +13541,7 @@
         </p:nvSpPr>
         <p:spPr>
           <a:xfrm>
-            <a:off x="713232" y="5230368"/>
+            <a:off x="713232" y="4791456"/>
             <a:ext cx="292608" cy="292608"/>
           </a:xfrm>
           <a:prstGeom prst="ellipse">
@@ -11299,7 +13569,7 @@
         </p:blipFill>
         <p:spPr>
           <a:xfrm>
-            <a:off x="777240" y="5294376"/>
+            <a:off x="777240" y="4855464"/>
             <a:ext cx="164592" cy="164592"/>
           </a:xfrm>
           <a:prstGeom prst="rect">
@@ -11315,8 +13585,8 @@
         </p:nvSpPr>
         <p:spPr>
           <a:xfrm>
-            <a:off x="1188720" y="5202936"/>
-            <a:ext cx="9692640" cy="548640"/>
+            <a:off x="1188720" y="4773168"/>
+            <a:ext cx="10058400" cy="502920"/>
           </a:xfrm>
           <a:prstGeom prst="rect">
             <a:avLst/>
@@ -11335,7 +13605,7 @@
               <a:buNone/>
             </a:pPr>
             <a:r>
-              <a:rPr lang="en-US" sz="1550" dirty="0">
+              <a:rPr lang="en-US" sz="1500" dirty="0">
                 <a:solidFill>
                   <a:srgbClr val="FBD8DF"/>
                 </a:solidFill>
@@ -11343,22 +13613,108 @@
                 <a:ea typeface="Calibri" pitchFamily="34" charset="-122"/>
                 <a:cs typeface="Calibri" pitchFamily="34" charset="-120"/>
               </a:rPr>
-              <a:t>Manage with the ABC pathway: Anticoagulation, Better symptom control, Comorbidity management.</a:t>
-            </a:r>
-            <a:endParaRPr lang="en-US" sz="1550" dirty="0"/>
-          </a:p>
-        </p:txBody>
-      </p:sp>
-      <p:sp>
-        <p:nvSpPr>
-          <p:cNvPr id="23" name="Text 14"/>
-          <p:cNvSpPr/>
-          <p:nvPr/>
-        </p:nvSpPr>
-        <p:spPr>
-          <a:xfrm>
-            <a:off x="685800" y="5760720"/>
-            <a:ext cx="5486400" cy="457200"/>
+              <a:t>Manage with the ABC pathway: Anticoagulation, Better symptom control, Comorbidities.</a:t>
+            </a:r>
+            <a:endParaRPr lang="en-US" sz="1500" dirty="0"/>
+          </a:p>
+        </p:txBody>
+      </p:sp>
+      <p:sp>
+        <p:nvSpPr>
+          <p:cNvPr id="23" name="Shape 14"/>
+          <p:cNvSpPr/>
+          <p:nvPr/>
+        </p:nvSpPr>
+        <p:spPr>
+          <a:xfrm>
+            <a:off x="713232" y="5340096"/>
+            <a:ext cx="292608" cy="292608"/>
+          </a:xfrm>
+          <a:prstGeom prst="ellipse">
+            <a:avLst/>
+          </a:prstGeom>
+          <a:solidFill>
+            <a:srgbClr val="A4133C"/>
+          </a:solidFill>
+          <a:ln/>
+        </p:spPr>
+      </p:sp>
+      <p:pic>
+        <p:nvPicPr>
+          <p:cNvPr id="24" name="Image 7" descr="preencoded.png">    </p:cNvPr>
+          <p:cNvPicPr>
+            <a:picLocks noChangeAspect="1"/>
+          </p:cNvPicPr>
+          <p:nvPr/>
+        </p:nvPicPr>
+        <p:blipFill>
+          <a:blip r:embed="rId8"/>
+          <a:stretch>
+            <a:fillRect/>
+          </a:stretch>
+        </p:blipFill>
+        <p:spPr>
+          <a:xfrm>
+            <a:off x="777240" y="5404104"/>
+            <a:ext cx="164592" cy="164592"/>
+          </a:xfrm>
+          <a:prstGeom prst="rect">
+            <a:avLst/>
+          </a:prstGeom>
+        </p:spPr>
+      </p:pic>
+      <p:sp>
+        <p:nvSpPr>
+          <p:cNvPr id="25" name="Text 15"/>
+          <p:cNvSpPr/>
+          <p:nvPr/>
+        </p:nvSpPr>
+        <p:spPr>
+          <a:xfrm>
+            <a:off x="1188720" y="5321808"/>
+            <a:ext cx="10058400" cy="502920"/>
+          </a:xfrm>
+          <a:prstGeom prst="rect">
+            <a:avLst/>
+          </a:prstGeom>
+          <a:noFill/>
+          <a:ln/>
+        </p:spPr>
+        <p:txBody>
+          <a:bodyPr wrap="square" lIns="0" tIns="0" rIns="0" bIns="0" rtlCol="0" anchor="ctr"/>
+          <a:lstStyle/>
+          <a:p>
+            <a:pPr algn="l" indent="0" marL="0">
+              <a:lnSpc>
+                <a:spcPct val="105000"/>
+              </a:lnSpc>
+              <a:buNone/>
+            </a:pPr>
+            <a:r>
+              <a:rPr lang="en-US" sz="1500" dirty="0">
+                <a:solidFill>
+                  <a:srgbClr val="FBD8DF"/>
+                </a:solidFill>
+                <a:latin typeface="Calibri" pitchFamily="34" charset="0"/>
+                <a:ea typeface="Calibri" pitchFamily="34" charset="-122"/>
+                <a:cs typeface="Calibri" pitchFamily="34" charset="-120"/>
+              </a:rPr>
+              <a:t>In pregnancy: LMWH is the anticoagulant of choice — avoid warfarin and DOACs.</a:t>
+            </a:r>
+            <a:endParaRPr lang="en-US" sz="1500" dirty="0"/>
+          </a:p>
+        </p:txBody>
+      </p:sp>
+      <p:sp>
+        <p:nvSpPr>
+          <p:cNvPr id="26" name="Text 16"/>
+          <p:cNvSpPr/>
+          <p:nvPr/>
+        </p:nvSpPr>
+        <p:spPr>
+          <a:xfrm>
+            <a:off x="685800" y="5943600"/>
+            <a:ext cx="5486400" cy="411480"/>
           </a:xfrm>
           <a:prstGeom prst="rect">
             <a:avLst/>
@@ -11374,7 +13730,7 @@
               <a:buNone/>
             </a:pPr>
             <a:r>
-              <a:rPr lang="en-US" sz="2300" b="1" i="1" dirty="0">
+              <a:rPr lang="en-US" sz="2200" b="1" i="1" dirty="0">
                 <a:solidFill>
                   <a:srgbClr val="FBD8DF"/>
                 </a:solidFill>
@@ -11384,13 +13740,13 @@
               </a:rPr>
               <a:t>Thank you</a:t>
             </a:r>
-            <a:endParaRPr lang="en-US" sz="2300" dirty="0"/>
-          </a:p>
-        </p:txBody>
-      </p:sp>
-      <p:sp>
-        <p:nvSpPr>
-          <p:cNvPr id="24" name="Text 15"/>
+            <a:endParaRPr lang="en-US" sz="2200" dirty="0"/>
+          </a:p>
+        </p:txBody>
+      </p:sp>
+      <p:sp>
+        <p:nvSpPr>
+          <p:cNvPr id="27" name="Text 17"/>
           <p:cNvSpPr/>
           <p:nvPr/>
         </p:nvSpPr>
@@ -11421,7 +13777,7 @@
                 <a:ea typeface="Calibri" pitchFamily="34" charset="-122"/>
                 <a:cs typeface="Calibri" pitchFamily="34" charset="-120"/>
               </a:rPr>
-              <a:t>16</a:t>
+              <a:t>18</a:t>
             </a:r>
             <a:endParaRPr lang="en-US" sz="1100" dirty="0"/>
           </a:p>
@@ -11429,7 +13785,7 @@
       </p:sp>
       <p:sp>
         <p:nvSpPr>
-          <p:cNvPr id="25" name="Text 16"/>
+          <p:cNvPr id="28" name="Text 18"/>
           <p:cNvSpPr/>
           <p:nvPr/>
         </p:nvSpPr>

</xml_diff>

<commit_message>
Add dedicated Thank You closing slide
End the deck with a beautiful full-bleed Thank You slide (heart-pulse
badge, ECG heartbeat divider, 'Questions & Discussion Welcome', presenter
chip) and remove the small redundant thank-you text from the Key Points
slide. Combined deck now 39 slides; topic deck 19.

Co-Authored-By: Claude Opus 4.8 <noreply@anthropic.com>
Claude-Session: https://claude.ai/code/session_01S7QW8AwqyMReKwuqyBkBBv
</commit_message>
<xml_diff>
--- a/presentations/Atrial-Fibrillation-Topic-Review.pptx
+++ b/presentations/Atrial-Fibrillation-Topic-Review.pptx
@@ -23,9 +23,10 @@
     <p:sldId id="271" r:id="rId17"/>
     <p:sldId id="272" r:id="rId18"/>
     <p:sldId id="273" r:id="rId19"/>
+    <p:sldId id="274" r:id="rId20"/>
   </p:sldIdLst>
   <p:notesMasterIdLst>
-    <p:notesMasterId r:id="rId20"/>
+    <p:notesMasterId r:id="rId21"/>
   </p:notesMasterIdLst>
   <p:sldSz cx="12191695" cy="6858000"/>
   <p:notesSz cx="6858000" cy="12191695"/>
@@ -1335,6 +1336,94 @@
             <a:fld id="{F7021451-1387-4CA6-816F-3879F97B5CBC}" type="slidenum">
               <a:rPr lang="en-US"/>
               <a:t>18</a:t>
+            </a:fld>
+            <a:endParaRPr lang="en-US"/>
+          </a:p>
+        </p:txBody>
+      </p:sp>
+    </p:spTree>
+    <p:extLst>
+      <p:ext uri="{BB962C8B-B14F-4D97-AF65-F5344CB8AC3E}">
+        <p14:creationId xmlns:p14="http://schemas.microsoft.com/office/powerpoint/2010/main" val="1024086991"/>
+      </p:ext>
+    </p:extLst>
+  </p:cSld>
+  <p:clrMapOvr>
+    <a:masterClrMapping/>
+  </p:clrMapOvr>
+</p:notes>
+</file>
+
+<file path=ppt/notesSlides/notesSlide19.xml><?xml version="1.0" encoding="utf-8"?>
+<p:notes xmlns:a="http://schemas.openxmlformats.org/drawingml/2006/main" xmlns:r="http://schemas.openxmlformats.org/officeDocument/2006/relationships" xmlns:p="http://schemas.openxmlformats.org/presentationml/2006/main">
+  <p:cSld>
+    <p:spTree>
+      <p:nvGrpSpPr>
+        <p:cNvPr id="1" name=""/>
+        <p:cNvGrpSpPr/>
+        <p:nvPr/>
+      </p:nvGrpSpPr>
+      <p:grpSpPr>
+        <a:xfrm>
+          <a:off x="0" y="0"/>
+          <a:ext cx="0" cy="0"/>
+          <a:chOff x="0" y="0"/>
+          <a:chExt cx="0" cy="0"/>
+        </a:xfrm>
+      </p:grpSpPr>
+      <p:sp>
+        <p:nvSpPr>
+          <p:cNvPr id="2" name="Slide Image Placeholder 1"/>
+          <p:cNvSpPr>
+            <a:spLocks noGrp="1" noRot="1" noChangeAspect="1"/>
+          </p:cNvSpPr>
+          <p:nvPr>
+            <p:ph type="sldImg"/>
+          </p:nvPr>
+        </p:nvSpPr>
+        <p:spPr/>
+      </p:sp>
+      <p:sp>
+        <p:nvSpPr>
+          <p:cNvPr id="3" name="Notes Placeholder 2"/>
+          <p:cNvSpPr>
+            <a:spLocks noGrp="1"/>
+          </p:cNvSpPr>
+          <p:nvPr>
+            <p:ph type="body" idx="1"/>
+          </p:nvPr>
+        </p:nvSpPr>
+        <p:spPr/>
+        <p:txBody>
+          <a:bodyPr/>
+          <a:lstStyle/>
+          <a:p>
+            <a:r>
+              <a:rPr lang="en-US" dirty="0"/>
+              <a:t/>
+            </a:r>
+            <a:endParaRPr lang="en-US" dirty="0"/>
+          </a:p>
+        </p:txBody>
+      </p:sp>
+      <p:sp>
+        <p:nvSpPr>
+          <p:cNvPr id="4" name="Slide Number Placeholder 3"/>
+          <p:cNvSpPr>
+            <a:spLocks noGrp="1"/>
+          </p:cNvSpPr>
+          <p:nvPr>
+            <p:ph type="sldNum" sz="quarter" idx="10"/>
+          </p:nvPr>
+        </p:nvSpPr>
+        <p:spPr/>
+        <p:txBody>
+          <a:bodyPr/>
+          <a:lstStyle/>
+          <a:p>
+            <a:fld id="{F7021451-1387-4CA6-816F-3879F97B5CBC}" type="slidenum">
+              <a:rPr lang="en-US"/>
+              <a:t>19</a:t>
             </a:fld>
             <a:endParaRPr lang="en-US"/>
           </a:p>
@@ -13713,8 +13802,8 @@
         </p:nvSpPr>
         <p:spPr>
           <a:xfrm>
-            <a:off x="685800" y="5943600"/>
-            <a:ext cx="5486400" cy="411480"/>
+            <a:off x="11277295" y="6355080"/>
+            <a:ext cx="548640" cy="320040"/>
           </a:xfrm>
           <a:prstGeom prst="rect">
             <a:avLst/>
@@ -13726,34 +13815,262 @@
           <a:bodyPr wrap="square" rtlCol="0" anchor="t"/>
           <a:lstStyle/>
           <a:p>
+            <a:pPr algn="r" indent="0" marL="0">
+              <a:buNone/>
+            </a:pPr>
+            <a:r>
+              <a:rPr lang="en-US" sz="1100" b="1" dirty="0">
+                <a:solidFill>
+                  <a:srgbClr val="FBD8DF"/>
+                </a:solidFill>
+                <a:latin typeface="Calibri" pitchFamily="34" charset="0"/>
+                <a:ea typeface="Calibri" pitchFamily="34" charset="-122"/>
+                <a:cs typeface="Calibri" pitchFamily="34" charset="-120"/>
+              </a:rPr>
+              <a:t>18</a:t>
+            </a:r>
+            <a:endParaRPr lang="en-US" sz="1100" dirty="0"/>
+          </a:p>
+        </p:txBody>
+      </p:sp>
+      <p:sp>
+        <p:nvSpPr>
+          <p:cNvPr id="27" name="Text 17"/>
+          <p:cNvSpPr/>
+          <p:nvPr/>
+        </p:nvSpPr>
+        <p:spPr>
+          <a:xfrm>
+            <a:off x="502920" y="6355080"/>
+            <a:ext cx="7315200" cy="320040"/>
+          </a:xfrm>
+          <a:prstGeom prst="rect">
+            <a:avLst/>
+          </a:prstGeom>
+          <a:noFill/>
+          <a:ln/>
+        </p:spPr>
+        <p:txBody>
+          <a:bodyPr wrap="square" rtlCol="0" anchor="t"/>
+          <a:lstStyle/>
+          <a:p>
             <a:pPr algn="l" indent="0" marL="0">
               <a:buNone/>
             </a:pPr>
             <a:r>
-              <a:rPr lang="en-US" sz="2200" b="1" i="1" dirty="0">
+              <a:rPr lang="en-US" sz="900" dirty="0">
                 <a:solidFill>
                   <a:srgbClr val="FBD8DF"/>
+                </a:solidFill>
+                <a:latin typeface="Calibri" pitchFamily="34" charset="0"/>
+                <a:ea typeface="Calibri" pitchFamily="34" charset="-122"/>
+                <a:cs typeface="Calibri" pitchFamily="34" charset="-120"/>
+              </a:rPr>
+              <a:t>Atrial Fibrillation — Clinical Topic Review</a:t>
+            </a:r>
+            <a:endParaRPr lang="en-US" sz="900" dirty="0"/>
+          </a:p>
+        </p:txBody>
+      </p:sp>
+    </p:spTree>
+  </p:cSld>
+  <p:clrMapOvr>
+    <a:masterClrMapping/>
+  </p:clrMapOvr>
+</p:sld>
+</file>
+
+<file path=ppt/slides/slide19.xml><?xml version="1.0" encoding="utf-8"?>
+<p:sld xmlns:a="http://schemas.openxmlformats.org/drawingml/2006/main" xmlns:r="http://schemas.openxmlformats.org/officeDocument/2006/relationships" xmlns:p="http://schemas.openxmlformats.org/presentationml/2006/main">
+  <p:cSld name="Slide 19">
+    <p:bg>
+      <p:bgPr>
+        <a:solidFill>
+          <a:srgbClr val="590D22"/>
+        </a:solidFill>
+      </p:bgPr>
+    </p:bg>
+    <p:spTree>
+      <p:nvGrpSpPr>
+        <p:cNvPr id="1" name=""/>
+        <p:cNvGrpSpPr/>
+        <p:nvPr/>
+      </p:nvGrpSpPr>
+      <p:grpSpPr>
+        <a:xfrm>
+          <a:off x="0" y="0"/>
+          <a:ext cx="0" cy="0"/>
+          <a:chOff x="0" y="0"/>
+          <a:chExt cx="0" cy="0"/>
+        </a:xfrm>
+      </p:grpSpPr>
+      <p:sp>
+        <p:nvSpPr>
+          <p:cNvPr id="2" name="Shape 0"/>
+          <p:cNvSpPr/>
+          <p:nvPr/>
+        </p:nvSpPr>
+        <p:spPr>
+          <a:xfrm>
+            <a:off x="0" y="0"/>
+            <a:ext cx="12191695" cy="6858000"/>
+          </a:xfrm>
+          <a:prstGeom prst="rect">
+            <a:avLst/>
+          </a:prstGeom>
+          <a:solidFill>
+            <a:srgbClr val="3A0A17">
+              <a:alpha val="74000"/>
+            </a:srgbClr>
+          </a:solidFill>
+          <a:ln/>
+        </p:spPr>
+      </p:sp>
+      <p:pic>
+        <p:nvPicPr>
+          <p:cNvPr id="3" name="Image 0" descr="preencoded.png">    </p:cNvPr>
+          <p:cNvPicPr>
+            <a:picLocks noChangeAspect="1"/>
+          </p:cNvPicPr>
+          <p:nvPr/>
+        </p:nvPicPr>
+        <p:blipFill>
+          <a:blip r:embed="rId1">
+            <a:alphaModFix amt="10000"/>
+          </a:blip>
+          <a:stretch>
+            <a:fillRect/>
+          </a:stretch>
+        </p:blipFill>
+        <p:spPr>
+          <a:xfrm>
+            <a:off x="8092440" y="3063240"/>
+            <a:ext cx="4754880" cy="4754880"/>
+          </a:xfrm>
+          <a:prstGeom prst="rect">
+            <a:avLst/>
+          </a:prstGeom>
+        </p:spPr>
+      </p:pic>
+      <p:pic>
+        <p:nvPicPr>
+          <p:cNvPr id="4" name="Image 1" descr="preencoded.png">    </p:cNvPr>
+          <p:cNvPicPr>
+            <a:picLocks noChangeAspect="1"/>
+          </p:cNvPicPr>
+          <p:nvPr/>
+        </p:nvPicPr>
+        <p:blipFill>
+          <a:blip r:embed="rId2">
+            <a:alphaModFix amt="7000"/>
+          </a:blip>
+          <a:stretch>
+            <a:fillRect/>
+          </a:stretch>
+        </p:blipFill>
+        <p:spPr>
+          <a:xfrm>
+            <a:off x="-822960" y="-960120"/>
+            <a:ext cx="4023360" cy="4023360"/>
+          </a:xfrm>
+          <a:prstGeom prst="rect">
+            <a:avLst/>
+          </a:prstGeom>
+        </p:spPr>
+      </p:pic>
+      <p:sp>
+        <p:nvSpPr>
+          <p:cNvPr id="5" name="Shape 1"/>
+          <p:cNvSpPr/>
+          <p:nvPr/>
+        </p:nvSpPr>
+        <p:spPr>
+          <a:xfrm>
+            <a:off x="5711800" y="1234440"/>
+            <a:ext cx="768096" cy="768096"/>
+          </a:xfrm>
+          <a:prstGeom prst="ellipse">
+            <a:avLst/>
+          </a:prstGeom>
+          <a:solidFill>
+            <a:srgbClr val="A4133C"/>
+          </a:solidFill>
+          <a:ln/>
+        </p:spPr>
+      </p:sp>
+      <p:pic>
+        <p:nvPicPr>
+          <p:cNvPr id="6" name="Image 2" descr="preencoded.png">    </p:cNvPr>
+          <p:cNvPicPr>
+            <a:picLocks noChangeAspect="1"/>
+          </p:cNvPicPr>
+          <p:nvPr/>
+        </p:nvPicPr>
+        <p:blipFill>
+          <a:blip r:embed="rId3"/>
+          <a:stretch>
+            <a:fillRect/>
+          </a:stretch>
+        </p:blipFill>
+        <p:spPr>
+          <a:xfrm>
+            <a:off x="5867248" y="1399032"/>
+            <a:ext cx="457200" cy="457200"/>
+          </a:xfrm>
+          <a:prstGeom prst="rect">
+            <a:avLst/>
+          </a:prstGeom>
+        </p:spPr>
+      </p:pic>
+      <p:sp>
+        <p:nvSpPr>
+          <p:cNvPr id="7" name="Text 2"/>
+          <p:cNvSpPr/>
+          <p:nvPr/>
+        </p:nvSpPr>
+        <p:spPr>
+          <a:xfrm>
+            <a:off x="457200" y="2286000"/>
+            <a:ext cx="11274552" cy="1554480"/>
+          </a:xfrm>
+          <a:prstGeom prst="rect">
+            <a:avLst/>
+          </a:prstGeom>
+          <a:noFill/>
+          <a:ln/>
+        </p:spPr>
+        <p:txBody>
+          <a:bodyPr wrap="square" rtlCol="0" anchor="t"/>
+          <a:lstStyle/>
+          <a:p>
+            <a:pPr algn="ctr" indent="0" marL="0">
+              <a:buNone/>
+            </a:pPr>
+            <a:r>
+              <a:rPr lang="en-US" sz="8800" b="1" dirty="0">
+                <a:solidFill>
+                  <a:srgbClr val="FFFFFF"/>
                 </a:solidFill>
                 <a:latin typeface="Cambria" pitchFamily="34" charset="0"/>
                 <a:ea typeface="Cambria" pitchFamily="34" charset="-122"/>
                 <a:cs typeface="Cambria" pitchFamily="34" charset="-120"/>
               </a:rPr>
-              <a:t>Thank you</a:t>
-            </a:r>
-            <a:endParaRPr lang="en-US" sz="2200" dirty="0"/>
-          </a:p>
-        </p:txBody>
-      </p:sp>
-      <p:sp>
-        <p:nvSpPr>
-          <p:cNvPr id="27" name="Text 17"/>
-          <p:cNvSpPr/>
-          <p:nvPr/>
-        </p:nvSpPr>
-        <p:spPr>
-          <a:xfrm>
-            <a:off x="11277295" y="6355080"/>
-            <a:ext cx="548640" cy="320040"/>
+              <a:t>Thank You</a:t>
+            </a:r>
+            <a:endParaRPr lang="en-US" sz="8800" dirty="0"/>
+          </a:p>
+        </p:txBody>
+      </p:sp>
+      <p:sp>
+        <p:nvSpPr>
+          <p:cNvPr id="8" name="Text 3"/>
+          <p:cNvSpPr/>
+          <p:nvPr/>
+        </p:nvSpPr>
+        <p:spPr>
+          <a:xfrm>
+            <a:off x="457200" y="4114800"/>
+            <a:ext cx="11274552" cy="457200"/>
           </a:xfrm>
           <a:prstGeom prst="rect">
             <a:avLst/>
@@ -13765,60 +14082,264 @@
           <a:bodyPr wrap="square" rtlCol="0" anchor="t"/>
           <a:lstStyle/>
           <a:p>
-            <a:pPr algn="r" indent="0" marL="0">
-              <a:buNone/>
-            </a:pPr>
-            <a:r>
-              <a:rPr lang="en-US" sz="1100" b="1" dirty="0">
-                <a:solidFill>
-                  <a:srgbClr val="FBD8DF"/>
+            <a:pPr algn="ctr" indent="0" marL="0">
+              <a:buNone/>
+            </a:pPr>
+            <a:r>
+              <a:rPr lang="en-US" sz="2200" i="1" dirty="0">
+                <a:solidFill>
+                  <a:srgbClr val="FF4D6D"/>
                 </a:solidFill>
                 <a:latin typeface="Calibri" pitchFamily="34" charset="0"/>
                 <a:ea typeface="Calibri" pitchFamily="34" charset="-122"/>
                 <a:cs typeface="Calibri" pitchFamily="34" charset="-120"/>
               </a:rPr>
-              <a:t>18</a:t>
-            </a:r>
-            <a:endParaRPr lang="en-US" sz="1100" dirty="0"/>
-          </a:p>
-        </p:txBody>
-      </p:sp>
-      <p:sp>
-        <p:nvSpPr>
-          <p:cNvPr id="28" name="Text 18"/>
-          <p:cNvSpPr/>
-          <p:nvPr/>
-        </p:nvSpPr>
-        <p:spPr>
-          <a:xfrm>
-            <a:off x="502920" y="6355080"/>
-            <a:ext cx="7315200" cy="320040"/>
-          </a:xfrm>
-          <a:prstGeom prst="rect">
-            <a:avLst/>
-          </a:prstGeom>
-          <a:noFill/>
-          <a:ln/>
-        </p:spPr>
-        <p:txBody>
-          <a:bodyPr wrap="square" rtlCol="0" anchor="t"/>
-          <a:lstStyle/>
-          <a:p>
-            <a:pPr algn="l" indent="0" marL="0">
-              <a:buNone/>
-            </a:pPr>
-            <a:r>
-              <a:rPr lang="en-US" sz="900" dirty="0">
-                <a:solidFill>
-                  <a:srgbClr val="FBD8DF"/>
+              <a:t>Questions &amp; Discussion Welcome</a:t>
+            </a:r>
+            <a:endParaRPr lang="en-US" sz="2200" dirty="0"/>
+          </a:p>
+        </p:txBody>
+      </p:sp>
+      <p:sp>
+        <p:nvSpPr>
+          <p:cNvPr id="9" name="Shape 4"/>
+          <p:cNvSpPr/>
+          <p:nvPr/>
+        </p:nvSpPr>
+        <p:spPr>
+          <a:xfrm>
+            <a:off x="3355848" y="5212080"/>
+            <a:ext cx="1865376" cy="0"/>
+          </a:xfrm>
+          <a:prstGeom prst="line">
+            <a:avLst/>
+          </a:prstGeom>
+          <a:noFill/>
+          <a:ln w="28575">
+            <a:solidFill>
+              <a:srgbClr val="FF4D6D"/>
+            </a:solidFill>
+            <a:prstDash val="solid"/>
+          </a:ln>
+        </p:spPr>
+      </p:sp>
+      <p:sp>
+        <p:nvSpPr>
+          <p:cNvPr id="10" name="Shape 5"/>
+          <p:cNvSpPr/>
+          <p:nvPr/>
+        </p:nvSpPr>
+        <p:spPr>
+          <a:xfrm flipV="1">
+            <a:off x="5221224" y="5065776"/>
+            <a:ext cx="329184" cy="146304"/>
+          </a:xfrm>
+          <a:prstGeom prst="line">
+            <a:avLst/>
+          </a:prstGeom>
+          <a:noFill/>
+          <a:ln w="28575">
+            <a:solidFill>
+              <a:srgbClr val="FF4D6D"/>
+            </a:solidFill>
+            <a:prstDash val="solid"/>
+          </a:ln>
+        </p:spPr>
+      </p:sp>
+      <p:sp>
+        <p:nvSpPr>
+          <p:cNvPr id="11" name="Shape 6"/>
+          <p:cNvSpPr/>
+          <p:nvPr/>
+        </p:nvSpPr>
+        <p:spPr>
+          <a:xfrm>
+            <a:off x="5550408" y="5065776"/>
+            <a:ext cx="329184" cy="457200"/>
+          </a:xfrm>
+          <a:prstGeom prst="line">
+            <a:avLst/>
+          </a:prstGeom>
+          <a:noFill/>
+          <a:ln w="28575">
+            <a:solidFill>
+              <a:srgbClr val="FF4D6D"/>
+            </a:solidFill>
+            <a:prstDash val="solid"/>
+          </a:ln>
+        </p:spPr>
+      </p:sp>
+      <p:sp>
+        <p:nvSpPr>
+          <p:cNvPr id="12" name="Shape 7"/>
+          <p:cNvSpPr/>
+          <p:nvPr/>
+        </p:nvSpPr>
+        <p:spPr>
+          <a:xfrm flipV="1">
+            <a:off x="5879592" y="4709160"/>
+            <a:ext cx="329184" cy="813816"/>
+          </a:xfrm>
+          <a:prstGeom prst="line">
+            <a:avLst/>
+          </a:prstGeom>
+          <a:noFill/>
+          <a:ln w="28575">
+            <a:solidFill>
+              <a:srgbClr val="FF4D6D"/>
+            </a:solidFill>
+            <a:prstDash val="solid"/>
+          </a:ln>
+        </p:spPr>
+      </p:sp>
+      <p:sp>
+        <p:nvSpPr>
+          <p:cNvPr id="13" name="Shape 8"/>
+          <p:cNvSpPr/>
+          <p:nvPr/>
+        </p:nvSpPr>
+        <p:spPr>
+          <a:xfrm>
+            <a:off x="6208776" y="4709160"/>
+            <a:ext cx="329184" cy="685800"/>
+          </a:xfrm>
+          <a:prstGeom prst="line">
+            <a:avLst/>
+          </a:prstGeom>
+          <a:noFill/>
+          <a:ln w="28575">
+            <a:solidFill>
+              <a:srgbClr val="FF4D6D"/>
+            </a:solidFill>
+            <a:prstDash val="solid"/>
+          </a:ln>
+        </p:spPr>
+      </p:sp>
+      <p:sp>
+        <p:nvSpPr>
+          <p:cNvPr id="14" name="Shape 9"/>
+          <p:cNvSpPr/>
+          <p:nvPr/>
+        </p:nvSpPr>
+        <p:spPr>
+          <a:xfrm flipV="1">
+            <a:off x="6537960" y="5212080"/>
+            <a:ext cx="329184" cy="182880"/>
+          </a:xfrm>
+          <a:prstGeom prst="line">
+            <a:avLst/>
+          </a:prstGeom>
+          <a:noFill/>
+          <a:ln w="28575">
+            <a:solidFill>
+              <a:srgbClr val="FF4D6D"/>
+            </a:solidFill>
+            <a:prstDash val="solid"/>
+          </a:ln>
+        </p:spPr>
+      </p:sp>
+      <p:sp>
+        <p:nvSpPr>
+          <p:cNvPr id="15" name="Shape 10"/>
+          <p:cNvSpPr/>
+          <p:nvPr/>
+        </p:nvSpPr>
+        <p:spPr>
+          <a:xfrm>
+            <a:off x="6867144" y="5212080"/>
+            <a:ext cx="1975104" cy="0"/>
+          </a:xfrm>
+          <a:prstGeom prst="line">
+            <a:avLst/>
+          </a:prstGeom>
+          <a:noFill/>
+          <a:ln w="28575">
+            <a:solidFill>
+              <a:srgbClr val="FF4D6D"/>
+            </a:solidFill>
+            <a:prstDash val="solid"/>
+          </a:ln>
+        </p:spPr>
+      </p:sp>
+      <p:sp>
+        <p:nvSpPr>
+          <p:cNvPr id="16" name="Shape 11"/>
+          <p:cNvSpPr/>
+          <p:nvPr/>
+        </p:nvSpPr>
+        <p:spPr>
+          <a:xfrm>
+            <a:off x="2621128" y="5486400"/>
+            <a:ext cx="6949440" cy="658368"/>
+          </a:xfrm>
+          <a:prstGeom prst="roundRect">
+            <a:avLst>
+              <a:gd name="adj" fmla="val 50000"/>
+            </a:avLst>
+          </a:prstGeom>
+          <a:solidFill>
+            <a:srgbClr val="FFFFFF">
+              <a:alpha val="8000"/>
+            </a:srgbClr>
+          </a:solidFill>
+          <a:ln w="12700">
+            <a:solidFill>
+              <a:srgbClr val="FF4D6D"/>
+            </a:solidFill>
+            <a:prstDash val="solid"/>
+          </a:ln>
+        </p:spPr>
+      </p:sp>
+      <p:sp>
+        <p:nvSpPr>
+          <p:cNvPr id="17" name="Text 12"/>
+          <p:cNvSpPr/>
+          <p:nvPr/>
+        </p:nvSpPr>
+        <p:spPr>
+          <a:xfrm>
+            <a:off x="2621128" y="5486400"/>
+            <a:ext cx="6949440" cy="658368"/>
+          </a:xfrm>
+          <a:prstGeom prst="rect">
+            <a:avLst/>
+          </a:prstGeom>
+          <a:noFill/>
+          <a:ln/>
+        </p:spPr>
+        <p:txBody>
+          <a:bodyPr wrap="square" rtlCol="0" anchor="ctr"/>
+          <a:lstStyle/>
+          <a:p>
+            <a:pPr algn="ctr" indent="0" marL="0">
+              <a:buNone/>
+            </a:pPr>
+            <a:r>
+              <a:rPr lang="en-US" sz="1400" b="1" dirty="0">
+                <a:solidFill>
+                  <a:srgbClr val="FFFFFF"/>
                 </a:solidFill>
                 <a:latin typeface="Calibri" pitchFamily="34" charset="0"/>
                 <a:ea typeface="Calibri" pitchFamily="34" charset="-122"/>
                 <a:cs typeface="Calibri" pitchFamily="34" charset="-120"/>
               </a:rPr>
-              <a:t>Atrial Fibrillation — Clinical Topic Review</a:t>
-            </a:r>
-            <a:endParaRPr lang="en-US" sz="900" dirty="0"/>
+              <a:t>Dr Mubashir Aziz</a:t>
+            </a:r>
+            <a:pPr algn="ctr" indent="0" marL="0">
+              <a:buNone/>
+            </a:pPr>
+            <a:r>
+              <a:rPr lang="en-US" sz="1400" dirty="0">
+                <a:solidFill>
+                  <a:srgbClr val="FBD8DF"/>
+                </a:solidFill>
+                <a:latin typeface="Calibri" pitchFamily="34" charset="0"/>
+                <a:ea typeface="Calibri" pitchFamily="34" charset="-122"/>
+                <a:cs typeface="Calibri" pitchFamily="34" charset="-120"/>
+              </a:rPr>
+              <a:t>   ·   Department of Cardiology · PEIC, Bahawalpur</a:t>
+            </a:r>
+            <a:endParaRPr lang="en-US" sz="1400" dirty="0"/>
           </a:p>
         </p:txBody>
       </p:sp>

</xml_diff>

<commit_message>
Add 'AF in Pregnancy — Overview' slide
New overview slide (epidemiology ~60/100,000, underlying causes;
anticoagulation with warfarin/LMWH by trimester; acute management with
cardioversion, IV metoprolol, flecainide/sotalol; long-term rhythm
control) placed after the pregnancy rate/rhythm slide. Combined deck now
44 slides; topic 21.

Co-Authored-By: Claude Opus 4.8 <noreply@anthropic.com>
Claude-Session: https://claude.ai/code/session_01S7QW8AwqyMReKwuqyBkBBv
</commit_message>
<xml_diff>
--- a/presentations/Atrial-Fibrillation-Topic-Review.pptx
+++ b/presentations/Atrial-Fibrillation-Topic-Review.pptx
@@ -25,9 +25,10 @@
     <p:sldId id="273" r:id="rId19"/>
     <p:sldId id="274" r:id="rId20"/>
     <p:sldId id="275" r:id="rId21"/>
+    <p:sldId id="276" r:id="rId22"/>
   </p:sldIdLst>
   <p:notesMasterIdLst>
-    <p:notesMasterId r:id="rId22"/>
+    <p:notesMasterId r:id="rId23"/>
   </p:notesMasterIdLst>
   <p:sldSz cx="12191695" cy="6858000"/>
   <p:notesSz cx="6858000" cy="12191695"/>
@@ -1601,6 +1602,94 @@
             <a:fld id="{F7021451-1387-4CA6-816F-3879F97B5CBC}" type="slidenum">
               <a:rPr lang="en-US"/>
               <a:t>20</a:t>
+            </a:fld>
+            <a:endParaRPr lang="en-US"/>
+          </a:p>
+        </p:txBody>
+      </p:sp>
+    </p:spTree>
+    <p:extLst>
+      <p:ext uri="{BB962C8B-B14F-4D97-AF65-F5344CB8AC3E}">
+        <p14:creationId xmlns:p14="http://schemas.microsoft.com/office/powerpoint/2010/main" val="1024086991"/>
+      </p:ext>
+    </p:extLst>
+  </p:cSld>
+  <p:clrMapOvr>
+    <a:masterClrMapping/>
+  </p:clrMapOvr>
+</p:notes>
+</file>
+
+<file path=ppt/notesSlides/notesSlide21.xml><?xml version="1.0" encoding="utf-8"?>
+<p:notes xmlns:a="http://schemas.openxmlformats.org/drawingml/2006/main" xmlns:r="http://schemas.openxmlformats.org/officeDocument/2006/relationships" xmlns:p="http://schemas.openxmlformats.org/presentationml/2006/main">
+  <p:cSld>
+    <p:spTree>
+      <p:nvGrpSpPr>
+        <p:cNvPr id="1" name=""/>
+        <p:cNvGrpSpPr/>
+        <p:nvPr/>
+      </p:nvGrpSpPr>
+      <p:grpSpPr>
+        <a:xfrm>
+          <a:off x="0" y="0"/>
+          <a:ext cx="0" cy="0"/>
+          <a:chOff x="0" y="0"/>
+          <a:chExt cx="0" cy="0"/>
+        </a:xfrm>
+      </p:grpSpPr>
+      <p:sp>
+        <p:nvSpPr>
+          <p:cNvPr id="2" name="Slide Image Placeholder 1"/>
+          <p:cNvSpPr>
+            <a:spLocks noGrp="1" noRot="1" noChangeAspect="1"/>
+          </p:cNvSpPr>
+          <p:nvPr>
+            <p:ph type="sldImg"/>
+          </p:nvPr>
+        </p:nvSpPr>
+        <p:spPr/>
+      </p:sp>
+      <p:sp>
+        <p:nvSpPr>
+          <p:cNvPr id="3" name="Notes Placeholder 2"/>
+          <p:cNvSpPr>
+            <a:spLocks noGrp="1"/>
+          </p:cNvSpPr>
+          <p:nvPr>
+            <p:ph type="body" idx="1"/>
+          </p:nvPr>
+        </p:nvSpPr>
+        <p:spPr/>
+        <p:txBody>
+          <a:bodyPr/>
+          <a:lstStyle/>
+          <a:p>
+            <a:r>
+              <a:rPr lang="en-US" dirty="0"/>
+              <a:t/>
+            </a:r>
+            <a:endParaRPr lang="en-US" dirty="0"/>
+          </a:p>
+        </p:txBody>
+      </p:sp>
+      <p:sp>
+        <p:nvSpPr>
+          <p:cNvPr id="4" name="Slide Number Placeholder 3"/>
+          <p:cNvSpPr>
+            <a:spLocks noGrp="1"/>
+          </p:cNvSpPr>
+          <p:nvPr>
+            <p:ph type="sldNum" sz="quarter" idx="10"/>
+          </p:nvPr>
+        </p:nvSpPr>
+        <p:spPr/>
+        <p:txBody>
+          <a:bodyPr/>
+          <a:lstStyle/>
+          <a:p>
+            <a:fld id="{F7021451-1387-4CA6-816F-3879F97B5CBC}" type="slidenum">
+              <a:rPr lang="en-US"/>
+              <a:t>21</a:t>
             </a:fld>
             <a:endParaRPr lang="en-US"/>
           </a:p>
@@ -14575,7 +14664,7 @@
     <p:bg>
       <p:bgPr>
         <a:solidFill>
-          <a:srgbClr val="590D22"/>
+          <a:srgbClr val="FFFFFF"/>
         </a:solidFill>
       </p:bgPr>
     </p:bg>
@@ -14601,18 +14690,21 @@
         </p:nvSpPr>
         <p:spPr>
           <a:xfrm>
-            <a:off x="0" y="0"/>
-            <a:ext cx="12191695" cy="6858000"/>
-          </a:xfrm>
-          <a:prstGeom prst="rect">
+            <a:off x="502920" y="457200"/>
+            <a:ext cx="868680" cy="868680"/>
+          </a:xfrm>
+          <a:prstGeom prst="ellipse">
             <a:avLst/>
           </a:prstGeom>
           <a:solidFill>
-            <a:srgbClr val="3A0A17">
-              <a:alpha val="65000"/>
-            </a:srgbClr>
+            <a:srgbClr val="FFF0F3"/>
           </a:solidFill>
-          <a:ln/>
+          <a:ln w="12700">
+            <a:solidFill>
+              <a:srgbClr val="FBD8DF"/>
+            </a:solidFill>
+            <a:prstDash val="solid"/>
+          </a:ln>
         </p:spPr>
       </p:sp>
       <p:pic>
@@ -14624,17 +14716,15 @@
           <p:nvPr/>
         </p:nvPicPr>
         <p:blipFill>
-          <a:blip r:embed="rId1">
-            <a:alphaModFix amt="9000"/>
-          </a:blip>
+          <a:blip r:embed="rId1"/>
           <a:stretch>
             <a:fillRect/>
           </a:stretch>
         </p:blipFill>
         <p:spPr>
           <a:xfrm>
-            <a:off x="8321040" y="3291840"/>
-            <a:ext cx="4572000" cy="4572000"/>
+            <a:off x="694944" y="649224"/>
+            <a:ext cx="484632" cy="484632"/>
           </a:xfrm>
           <a:prstGeom prst="rect">
             <a:avLst/>
@@ -14643,14 +14733,214 @@
       </p:pic>
       <p:sp>
         <p:nvSpPr>
-          <p:cNvPr id="4" name="Shape 1"/>
-          <p:cNvSpPr/>
-          <p:nvPr/>
-        </p:nvSpPr>
-        <p:spPr>
-          <a:xfrm>
-            <a:off x="685800" y="685800"/>
-            <a:ext cx="960120" cy="960120"/>
+          <p:cNvPr id="4" name="Text 1"/>
+          <p:cNvSpPr/>
+          <p:nvPr/>
+        </p:nvSpPr>
+        <p:spPr>
+          <a:xfrm>
+            <a:off x="1572768" y="502920"/>
+            <a:ext cx="9966960" cy="274320"/>
+          </a:xfrm>
+          <a:prstGeom prst="rect">
+            <a:avLst/>
+          </a:prstGeom>
+          <a:noFill/>
+          <a:ln/>
+        </p:spPr>
+        <p:txBody>
+          <a:bodyPr wrap="square" rtlCol="0" anchor="t"/>
+          <a:lstStyle/>
+          <a:p>
+            <a:pPr algn="l" indent="0" marL="0">
+              <a:buNone/>
+            </a:pPr>
+            <a:r>
+              <a:rPr lang="en-US" sz="1250" b="1" spc="200" kern="0" dirty="0">
+                <a:solidFill>
+                  <a:srgbClr val="A4133C"/>
+                </a:solidFill>
+                <a:latin typeface="Calibri" pitchFamily="34" charset="0"/>
+                <a:ea typeface="Calibri" pitchFamily="34" charset="-122"/>
+                <a:cs typeface="Calibri" pitchFamily="34" charset="-120"/>
+              </a:rPr>
+              <a:t>SPECIAL POPULATIONS · PREGNANCY</a:t>
+            </a:r>
+            <a:endParaRPr lang="en-US" sz="1250" dirty="0"/>
+          </a:p>
+        </p:txBody>
+      </p:sp>
+      <p:sp>
+        <p:nvSpPr>
+          <p:cNvPr id="5" name="Text 2"/>
+          <p:cNvSpPr/>
+          <p:nvPr/>
+        </p:nvSpPr>
+        <p:spPr>
+          <a:xfrm>
+            <a:off x="1554480" y="749808"/>
+            <a:ext cx="10241280" cy="640080"/>
+          </a:xfrm>
+          <a:prstGeom prst="rect">
+            <a:avLst/>
+          </a:prstGeom>
+          <a:noFill/>
+          <a:ln/>
+        </p:spPr>
+        <p:txBody>
+          <a:bodyPr wrap="square" rtlCol="0" anchor="t"/>
+          <a:lstStyle/>
+          <a:p>
+            <a:pPr algn="l" indent="0" marL="0">
+              <a:buNone/>
+            </a:pPr>
+            <a:r>
+              <a:rPr lang="en-US" sz="3000" b="1" dirty="0">
+                <a:solidFill>
+                  <a:srgbClr val="2B2B33"/>
+                </a:solidFill>
+                <a:latin typeface="Cambria" pitchFamily="34" charset="0"/>
+                <a:ea typeface="Cambria" pitchFamily="34" charset="-122"/>
+                <a:cs typeface="Cambria" pitchFamily="34" charset="-120"/>
+              </a:rPr>
+              <a:t>AF in Pregnancy — Overview</a:t>
+            </a:r>
+            <a:endParaRPr lang="en-US" sz="3000" dirty="0"/>
+          </a:p>
+        </p:txBody>
+      </p:sp>
+      <p:sp>
+        <p:nvSpPr>
+          <p:cNvPr id="6" name="Shape 3"/>
+          <p:cNvSpPr/>
+          <p:nvPr/>
+        </p:nvSpPr>
+        <p:spPr>
+          <a:xfrm>
+            <a:off x="502920" y="1572768"/>
+            <a:ext cx="11183112" cy="914400"/>
+          </a:xfrm>
+          <a:prstGeom prst="roundRect">
+            <a:avLst>
+              <a:gd name="adj" fmla="val 12000"/>
+            </a:avLst>
+          </a:prstGeom>
+          <a:solidFill>
+            <a:srgbClr val="590D22"/>
+          </a:solidFill>
+          <a:ln/>
+          <a:effectLst>
+            <a:outerShdw sx="100000" sy="100000" kx="0" ky="0" algn="bl" rotWithShape="0" blurRad="127000" dist="50800" dir="5400000">
+              <a:srgbClr val="C9A3AC">
+                <a:alpha val="45000"/>
+              </a:srgbClr>
+            </a:outerShdw>
+          </a:effectLst>
+        </p:spPr>
+      </p:sp>
+      <p:sp>
+        <p:nvSpPr>
+          <p:cNvPr id="7" name="Text 4"/>
+          <p:cNvSpPr/>
+          <p:nvPr/>
+        </p:nvSpPr>
+        <p:spPr>
+          <a:xfrm>
+            <a:off x="914400" y="1572768"/>
+            <a:ext cx="10424160" cy="914400"/>
+          </a:xfrm>
+          <a:prstGeom prst="rect">
+            <a:avLst/>
+          </a:prstGeom>
+          <a:noFill/>
+          <a:ln/>
+        </p:spPr>
+        <p:txBody>
+          <a:bodyPr wrap="square" rtlCol="0" anchor="ctr"/>
+          <a:lstStyle/>
+          <a:p>
+            <a:pPr algn="l" indent="0" marL="0">
+              <a:lnSpc>
+                <a:spcPct val="110000"/>
+              </a:lnSpc>
+              <a:buNone/>
+            </a:pPr>
+            <a:r>
+              <a:rPr lang="en-US" sz="1400" b="1" dirty="0">
+                <a:solidFill>
+                  <a:srgbClr val="FFFFFF"/>
+                </a:solidFill>
+                <a:latin typeface="Calibri" pitchFamily="34" charset="0"/>
+                <a:ea typeface="Calibri" pitchFamily="34" charset="-122"/>
+                <a:cs typeface="Calibri" pitchFamily="34" charset="-120"/>
+              </a:rPr>
+              <a:t>Rare — ~60 / 100,000 pregnancies</a:t>
+            </a:r>
+            <a:pPr algn="l" indent="0" marL="0">
+              <a:lnSpc>
+                <a:spcPct val="110000"/>
+              </a:lnSpc>
+              <a:buNone/>
+            </a:pPr>
+            <a:r>
+              <a:rPr lang="en-US" sz="1400" dirty="0">
+                <a:solidFill>
+                  <a:srgbClr val="FBD8DF"/>
+                </a:solidFill>
+                <a:latin typeface="Calibri" pitchFamily="34" charset="0"/>
+                <a:ea typeface="Calibri" pitchFamily="34" charset="-122"/>
+                <a:cs typeface="Calibri" pitchFamily="34" charset="-120"/>
+              </a:rPr>
+              <a:t>   ·   often congenital / valvular disease, thyrotoxicosis or electrolyte disturbance   ·   hypercoagulable, but no proven rise in AF-related thromboembolism</a:t>
+            </a:r>
+            <a:endParaRPr lang="en-US" sz="1400" dirty="0"/>
+          </a:p>
+        </p:txBody>
+      </p:sp>
+      <p:sp>
+        <p:nvSpPr>
+          <p:cNvPr id="8" name="Shape 5"/>
+          <p:cNvSpPr/>
+          <p:nvPr/>
+        </p:nvSpPr>
+        <p:spPr>
+          <a:xfrm>
+            <a:off x="502920" y="2670048"/>
+            <a:ext cx="3611880" cy="3319272"/>
+          </a:xfrm>
+          <a:prstGeom prst="roundRect">
+            <a:avLst>
+              <a:gd name="adj" fmla="val 3306"/>
+            </a:avLst>
+          </a:prstGeom>
+          <a:solidFill>
+            <a:srgbClr val="FFF0F3"/>
+          </a:solidFill>
+          <a:ln w="12700">
+            <a:solidFill>
+              <a:srgbClr val="FBD8DF"/>
+            </a:solidFill>
+            <a:prstDash val="solid"/>
+          </a:ln>
+          <a:effectLst>
+            <a:outerShdw sx="100000" sy="100000" kx="0" ky="0" algn="bl" rotWithShape="0" blurRad="127000" dist="50800" dir="5400000">
+              <a:srgbClr val="C9A3AC">
+                <a:alpha val="45000"/>
+              </a:srgbClr>
+            </a:outerShdw>
+          </a:effectLst>
+        </p:spPr>
+      </p:sp>
+      <p:sp>
+        <p:nvSpPr>
+          <p:cNvPr id="9" name="Shape 6"/>
+          <p:cNvSpPr/>
+          <p:nvPr/>
+        </p:nvSpPr>
+        <p:spPr>
+          <a:xfrm>
+            <a:off x="777240" y="2926080"/>
+            <a:ext cx="658368" cy="658368"/>
           </a:xfrm>
           <a:prstGeom prst="ellipse">
             <a:avLst/>
@@ -14663,7 +14953,7 @@
       </p:sp>
       <p:pic>
         <p:nvPicPr>
-          <p:cNvPr id="5" name="Image 1" descr="preencoded.png">    </p:cNvPr>
+          <p:cNvPr id="10" name="Image 1" descr="preencoded.png">    </p:cNvPr>
           <p:cNvPicPr>
             <a:picLocks noChangeAspect="1"/>
           </p:cNvPicPr>
@@ -14677,8 +14967,8 @@
         </p:blipFill>
         <p:spPr>
           <a:xfrm>
-            <a:off x="905256" y="905256"/>
-            <a:ext cx="521208" cy="521208"/>
+            <a:off x="932688" y="3081528"/>
+            <a:ext cx="347472" cy="347472"/>
           </a:xfrm>
           <a:prstGeom prst="rect">
             <a:avLst/>
@@ -14687,92 +14977,273 @@
       </p:pic>
       <p:sp>
         <p:nvSpPr>
-          <p:cNvPr id="6" name="Text 2"/>
-          <p:cNvSpPr/>
-          <p:nvPr/>
-        </p:nvSpPr>
-        <p:spPr>
-          <a:xfrm>
-            <a:off x="1828800" y="868680"/>
-            <a:ext cx="8229600" cy="548640"/>
-          </a:xfrm>
-          <a:prstGeom prst="rect">
-            <a:avLst/>
-          </a:prstGeom>
-          <a:noFill/>
-          <a:ln/>
-        </p:spPr>
-        <p:txBody>
-          <a:bodyPr wrap="square" rtlCol="0" anchor="ctr"/>
-          <a:lstStyle/>
-          <a:p>
-            <a:pPr algn="l" indent="0" marL="0">
-              <a:buNone/>
-            </a:pPr>
-            <a:r>
-              <a:rPr lang="en-US" sz="1700" b="1" spc="300" kern="0" dirty="0">
-                <a:solidFill>
-                  <a:srgbClr val="FF4D6D"/>
+          <p:cNvPr id="11" name="Text 7"/>
+          <p:cNvSpPr/>
+          <p:nvPr/>
+        </p:nvSpPr>
+        <p:spPr>
+          <a:xfrm>
+            <a:off x="1554480" y="2926080"/>
+            <a:ext cx="2423160" cy="658368"/>
+          </a:xfrm>
+          <a:prstGeom prst="rect">
+            <a:avLst/>
+          </a:prstGeom>
+          <a:noFill/>
+          <a:ln/>
+        </p:spPr>
+        <p:txBody>
+          <a:bodyPr wrap="square" lIns="0" tIns="0" rIns="0" bIns="0" rtlCol="0" anchor="ctr"/>
+          <a:lstStyle/>
+          <a:p>
+            <a:pPr algn="l" indent="0" marL="0">
+              <a:buNone/>
+            </a:pPr>
+            <a:r>
+              <a:rPr lang="en-US" sz="1700" b="1" dirty="0">
+                <a:solidFill>
+                  <a:srgbClr val="2B2B33"/>
+                </a:solidFill>
+                <a:latin typeface="Cambria" pitchFamily="34" charset="0"/>
+                <a:ea typeface="Cambria" pitchFamily="34" charset="-122"/>
+                <a:cs typeface="Cambria" pitchFamily="34" charset="-120"/>
+              </a:rPr>
+              <a:t>Anticoagulation</a:t>
+            </a:r>
+            <a:endParaRPr lang="en-US" sz="1700" dirty="0"/>
+          </a:p>
+        </p:txBody>
+      </p:sp>
+      <p:sp>
+        <p:nvSpPr>
+          <p:cNvPr id="12" name="Shape 8"/>
+          <p:cNvSpPr/>
+          <p:nvPr/>
+        </p:nvSpPr>
+        <p:spPr>
+          <a:xfrm>
+            <a:off x="795528" y="3822192"/>
+            <a:ext cx="118872" cy="118872"/>
+          </a:xfrm>
+          <a:prstGeom prst="ellipse">
+            <a:avLst/>
+          </a:prstGeom>
+          <a:solidFill>
+            <a:srgbClr val="FF4D6D"/>
+          </a:solidFill>
+          <a:ln/>
+        </p:spPr>
+      </p:sp>
+      <p:sp>
+        <p:nvSpPr>
+          <p:cNvPr id="13" name="Text 9"/>
+          <p:cNvSpPr/>
+          <p:nvPr/>
+        </p:nvSpPr>
+        <p:spPr>
+          <a:xfrm>
+            <a:off x="1033272" y="3767328"/>
+            <a:ext cx="2834640" cy="676656"/>
+          </a:xfrm>
+          <a:prstGeom prst="rect">
+            <a:avLst/>
+          </a:prstGeom>
+          <a:noFill/>
+          <a:ln/>
+        </p:spPr>
+        <p:txBody>
+          <a:bodyPr wrap="square" lIns="0" tIns="0" rIns="0" bIns="0" rtlCol="0" anchor="t"/>
+          <a:lstStyle/>
+          <a:p>
+            <a:pPr algn="l" indent="0" marL="0">
+              <a:lnSpc>
+                <a:spcPct val="102000"/>
+              </a:lnSpc>
+              <a:buNone/>
+            </a:pPr>
+            <a:r>
+              <a:rPr lang="en-US" sz="1250" dirty="0">
+                <a:solidFill>
+                  <a:srgbClr val="2B2B33"/>
                 </a:solidFill>
                 <a:latin typeface="Calibri" pitchFamily="34" charset="0"/>
                 <a:ea typeface="Calibri" pitchFamily="34" charset="-122"/>
                 <a:cs typeface="Calibri" pitchFamily="34" charset="-120"/>
               </a:rPr>
-              <a:t>SUMMARY</a:t>
-            </a:r>
-            <a:endParaRPr lang="en-US" sz="1700" dirty="0"/>
-          </a:p>
-        </p:txBody>
-      </p:sp>
-      <p:sp>
-        <p:nvSpPr>
-          <p:cNvPr id="7" name="Text 3"/>
-          <p:cNvSpPr/>
-          <p:nvPr/>
-        </p:nvSpPr>
-        <p:spPr>
-          <a:xfrm>
-            <a:off x="640080" y="1691640"/>
-            <a:ext cx="10058400" cy="914400"/>
-          </a:xfrm>
-          <a:prstGeom prst="rect">
-            <a:avLst/>
-          </a:prstGeom>
-          <a:noFill/>
-          <a:ln/>
-        </p:spPr>
-        <p:txBody>
-          <a:bodyPr wrap="square" rtlCol="0" anchor="t"/>
-          <a:lstStyle/>
-          <a:p>
-            <a:pPr algn="l" indent="0" marL="0">
-              <a:buNone/>
-            </a:pPr>
-            <a:r>
-              <a:rPr lang="en-US" sz="4600" b="1" dirty="0">
-                <a:solidFill>
-                  <a:srgbClr val="FFFFFF"/>
-                </a:solidFill>
-                <a:latin typeface="Cambria" pitchFamily="34" charset="0"/>
-                <a:ea typeface="Cambria" pitchFamily="34" charset="-122"/>
-                <a:cs typeface="Cambria" pitchFamily="34" charset="-120"/>
-              </a:rPr>
-              <a:t>Key Points</a:t>
-            </a:r>
-            <a:endParaRPr lang="en-US" sz="4600" dirty="0"/>
-          </a:p>
-        </p:txBody>
-      </p:sp>
-      <p:sp>
-        <p:nvSpPr>
-          <p:cNvPr id="8" name="Shape 4"/>
-          <p:cNvSpPr/>
-          <p:nvPr/>
-        </p:nvSpPr>
-        <p:spPr>
-          <a:xfrm>
-            <a:off x="713232" y="2596896"/>
-            <a:ext cx="292608" cy="292608"/>
+              <a:t>Same criteria as non-pregnant women</a:t>
+            </a:r>
+            <a:endParaRPr lang="en-US" sz="1250" dirty="0"/>
+          </a:p>
+        </p:txBody>
+      </p:sp>
+      <p:sp>
+        <p:nvSpPr>
+          <p:cNvPr id="14" name="Shape 10"/>
+          <p:cNvSpPr/>
+          <p:nvPr/>
+        </p:nvSpPr>
+        <p:spPr>
+          <a:xfrm>
+            <a:off x="795528" y="4553712"/>
+            <a:ext cx="118872" cy="118872"/>
+          </a:xfrm>
+          <a:prstGeom prst="ellipse">
+            <a:avLst/>
+          </a:prstGeom>
+          <a:solidFill>
+            <a:srgbClr val="FF4D6D"/>
+          </a:solidFill>
+          <a:ln/>
+        </p:spPr>
+      </p:sp>
+      <p:sp>
+        <p:nvSpPr>
+          <p:cNvPr id="15" name="Text 11"/>
+          <p:cNvSpPr/>
+          <p:nvPr/>
+        </p:nvSpPr>
+        <p:spPr>
+          <a:xfrm>
+            <a:off x="1033272" y="4498848"/>
+            <a:ext cx="2834640" cy="676656"/>
+          </a:xfrm>
+          <a:prstGeom prst="rect">
+            <a:avLst/>
+          </a:prstGeom>
+          <a:noFill/>
+          <a:ln/>
+        </p:spPr>
+        <p:txBody>
+          <a:bodyPr wrap="square" lIns="0" tIns="0" rIns="0" bIns="0" rtlCol="0" anchor="t"/>
+          <a:lstStyle/>
+          <a:p>
+            <a:pPr algn="l" indent="0" marL="0">
+              <a:lnSpc>
+                <a:spcPct val="102000"/>
+              </a:lnSpc>
+              <a:buNone/>
+            </a:pPr>
+            <a:r>
+              <a:rPr lang="en-US" sz="1250" dirty="0">
+                <a:solidFill>
+                  <a:srgbClr val="2B2B33"/>
+                </a:solidFill>
+                <a:latin typeface="Calibri" pitchFamily="34" charset="0"/>
+                <a:ea typeface="Calibri" pitchFamily="34" charset="-122"/>
+                <a:cs typeface="Calibri" pitchFamily="34" charset="-120"/>
+              </a:rPr>
+              <a:t>Warfarin (not DOAC) — 2nd trimester to 1 month before delivery</a:t>
+            </a:r>
+            <a:endParaRPr lang="en-US" sz="1250" dirty="0"/>
+          </a:p>
+        </p:txBody>
+      </p:sp>
+      <p:sp>
+        <p:nvSpPr>
+          <p:cNvPr id="16" name="Shape 12"/>
+          <p:cNvSpPr/>
+          <p:nvPr/>
+        </p:nvSpPr>
+        <p:spPr>
+          <a:xfrm>
+            <a:off x="795528" y="5285232"/>
+            <a:ext cx="118872" cy="118872"/>
+          </a:xfrm>
+          <a:prstGeom prst="ellipse">
+            <a:avLst/>
+          </a:prstGeom>
+          <a:solidFill>
+            <a:srgbClr val="FF4D6D"/>
+          </a:solidFill>
+          <a:ln/>
+        </p:spPr>
+      </p:sp>
+      <p:sp>
+        <p:nvSpPr>
+          <p:cNvPr id="17" name="Text 13"/>
+          <p:cNvSpPr/>
+          <p:nvPr/>
+        </p:nvSpPr>
+        <p:spPr>
+          <a:xfrm>
+            <a:off x="1033272" y="5230368"/>
+            <a:ext cx="2834640" cy="676656"/>
+          </a:xfrm>
+          <a:prstGeom prst="rect">
+            <a:avLst/>
+          </a:prstGeom>
+          <a:noFill/>
+          <a:ln/>
+        </p:spPr>
+        <p:txBody>
+          <a:bodyPr wrap="square" lIns="0" tIns="0" rIns="0" bIns="0" rtlCol="0" anchor="t"/>
+          <a:lstStyle/>
+          <a:p>
+            <a:pPr algn="l" indent="0" marL="0">
+              <a:lnSpc>
+                <a:spcPct val="102000"/>
+              </a:lnSpc>
+              <a:buNone/>
+            </a:pPr>
+            <a:r>
+              <a:rPr lang="en-US" sz="1250" dirty="0">
+                <a:solidFill>
+                  <a:srgbClr val="2B2B33"/>
+                </a:solidFill>
+                <a:latin typeface="Calibri" pitchFamily="34" charset="0"/>
+                <a:ea typeface="Calibri" pitchFamily="34" charset="-122"/>
+                <a:cs typeface="Calibri" pitchFamily="34" charset="-120"/>
+              </a:rPr>
+              <a:t>LMWH (SC) — 1st trimester &amp; final month</a:t>
+            </a:r>
+            <a:endParaRPr lang="en-US" sz="1250" dirty="0"/>
+          </a:p>
+        </p:txBody>
+      </p:sp>
+      <p:sp>
+        <p:nvSpPr>
+          <p:cNvPr id="18" name="Shape 14"/>
+          <p:cNvSpPr/>
+          <p:nvPr/>
+        </p:nvSpPr>
+        <p:spPr>
+          <a:xfrm>
+            <a:off x="4288536" y="2670048"/>
+            <a:ext cx="3611880" cy="3319272"/>
+          </a:xfrm>
+          <a:prstGeom prst="roundRect">
+            <a:avLst>
+              <a:gd name="adj" fmla="val 3306"/>
+            </a:avLst>
+          </a:prstGeom>
+          <a:solidFill>
+            <a:srgbClr val="FFF0F3"/>
+          </a:solidFill>
+          <a:ln w="12700">
+            <a:solidFill>
+              <a:srgbClr val="FBD8DF"/>
+            </a:solidFill>
+            <a:prstDash val="solid"/>
+          </a:ln>
+          <a:effectLst>
+            <a:outerShdw sx="100000" sy="100000" kx="0" ky="0" algn="bl" rotWithShape="0" blurRad="127000" dist="50800" dir="5400000">
+              <a:srgbClr val="C9A3AC">
+                <a:alpha val="45000"/>
+              </a:srgbClr>
+            </a:outerShdw>
+          </a:effectLst>
+        </p:spPr>
+      </p:sp>
+      <p:sp>
+        <p:nvSpPr>
+          <p:cNvPr id="19" name="Shape 15"/>
+          <p:cNvSpPr/>
+          <p:nvPr/>
+        </p:nvSpPr>
+        <p:spPr>
+          <a:xfrm>
+            <a:off x="4562856" y="2926080"/>
+            <a:ext cx="658368" cy="658368"/>
           </a:xfrm>
           <a:prstGeom prst="ellipse">
             <a:avLst/>
@@ -14785,7 +15256,7 @@
       </p:sp>
       <p:pic>
         <p:nvPicPr>
-          <p:cNvPr id="9" name="Image 2" descr="preencoded.png">    </p:cNvPr>
+          <p:cNvPr id="20" name="Image 2" descr="preencoded.png">    </p:cNvPr>
           <p:cNvPicPr>
             <a:picLocks noChangeAspect="1"/>
           </p:cNvPicPr>
@@ -14799,8 +15270,8 @@
         </p:blipFill>
         <p:spPr>
           <a:xfrm>
-            <a:off x="777240" y="2660904"/>
-            <a:ext cx="164592" cy="164592"/>
+            <a:off x="4718304" y="3081528"/>
+            <a:ext cx="347472" cy="347472"/>
           </a:xfrm>
           <a:prstGeom prst="rect">
             <a:avLst/>
@@ -14809,14 +15280,14 @@
       </p:pic>
       <p:sp>
         <p:nvSpPr>
-          <p:cNvPr id="10" name="Text 5"/>
-          <p:cNvSpPr/>
-          <p:nvPr/>
-        </p:nvSpPr>
-        <p:spPr>
-          <a:xfrm>
-            <a:off x="1188720" y="2578608"/>
-            <a:ext cx="10058400" cy="502920"/>
+          <p:cNvPr id="21" name="Text 16"/>
+          <p:cNvSpPr/>
+          <p:nvPr/>
+        </p:nvSpPr>
+        <p:spPr>
+          <a:xfrm>
+            <a:off x="5340096" y="2926080"/>
+            <a:ext cx="2423160" cy="658368"/>
           </a:xfrm>
           <a:prstGeom prst="rect">
             <a:avLst/>
@@ -14829,36 +15300,253 @@
           <a:lstStyle/>
           <a:p>
             <a:pPr algn="l" indent="0" marL="0">
+              <a:buNone/>
+            </a:pPr>
+            <a:r>
+              <a:rPr lang="en-US" sz="1700" b="1" dirty="0">
+                <a:solidFill>
+                  <a:srgbClr val="2B2B33"/>
+                </a:solidFill>
+                <a:latin typeface="Cambria" pitchFamily="34" charset="0"/>
+                <a:ea typeface="Cambria" pitchFamily="34" charset="-122"/>
+                <a:cs typeface="Cambria" pitchFamily="34" charset="-120"/>
+              </a:rPr>
+              <a:t>Acute Management</a:t>
+            </a:r>
+            <a:endParaRPr lang="en-US" sz="1700" dirty="0"/>
+          </a:p>
+        </p:txBody>
+      </p:sp>
+      <p:sp>
+        <p:nvSpPr>
+          <p:cNvPr id="22" name="Shape 17"/>
+          <p:cNvSpPr/>
+          <p:nvPr/>
+        </p:nvSpPr>
+        <p:spPr>
+          <a:xfrm>
+            <a:off x="4581144" y="3822192"/>
+            <a:ext cx="118872" cy="118872"/>
+          </a:xfrm>
+          <a:prstGeom prst="ellipse">
+            <a:avLst/>
+          </a:prstGeom>
+          <a:solidFill>
+            <a:srgbClr val="FF4D6D"/>
+          </a:solidFill>
+          <a:ln/>
+        </p:spPr>
+      </p:sp>
+      <p:sp>
+        <p:nvSpPr>
+          <p:cNvPr id="23" name="Text 18"/>
+          <p:cNvSpPr/>
+          <p:nvPr/>
+        </p:nvSpPr>
+        <p:spPr>
+          <a:xfrm>
+            <a:off x="4818888" y="3767328"/>
+            <a:ext cx="2834640" cy="676656"/>
+          </a:xfrm>
+          <a:prstGeom prst="rect">
+            <a:avLst/>
+          </a:prstGeom>
+          <a:noFill/>
+          <a:ln/>
+        </p:spPr>
+        <p:txBody>
+          <a:bodyPr wrap="square" lIns="0" tIns="0" rIns="0" bIns="0" rtlCol="0" anchor="t"/>
+          <a:lstStyle/>
+          <a:p>
+            <a:pPr algn="l" indent="0" marL="0">
               <a:lnSpc>
-                <a:spcPct val="105000"/>
+                <a:spcPct val="102000"/>
               </a:lnSpc>
               <a:buNone/>
             </a:pPr>
             <a:r>
-              <a:rPr lang="en-US" sz="1500" dirty="0">
-                <a:solidFill>
-                  <a:srgbClr val="FBD8DF"/>
+              <a:rPr lang="en-US" sz="1250" dirty="0">
+                <a:solidFill>
+                  <a:srgbClr val="2B2B33"/>
                 </a:solidFill>
                 <a:latin typeface="Calibri" pitchFamily="34" charset="0"/>
                 <a:ea typeface="Calibri" pitchFamily="34" charset="-122"/>
                 <a:cs typeface="Calibri" pitchFamily="34" charset="-120"/>
               </a:rPr>
-              <a:t>AF = irregularly irregular rhythm with absent P waves and a fibrillatory baseline.</a:t>
-            </a:r>
-            <a:endParaRPr lang="en-US" sz="1500" dirty="0"/>
-          </a:p>
-        </p:txBody>
-      </p:sp>
-      <p:sp>
-        <p:nvSpPr>
-          <p:cNvPr id="11" name="Shape 6"/>
-          <p:cNvSpPr/>
-          <p:nvPr/>
-        </p:nvSpPr>
-        <p:spPr>
-          <a:xfrm>
-            <a:off x="713232" y="3145536"/>
-            <a:ext cx="292608" cy="292608"/>
+              <a:t>DC cardioversion — safe at all stages</a:t>
+            </a:r>
+            <a:endParaRPr lang="en-US" sz="1250" dirty="0"/>
+          </a:p>
+        </p:txBody>
+      </p:sp>
+      <p:sp>
+        <p:nvSpPr>
+          <p:cNvPr id="24" name="Shape 19"/>
+          <p:cNvSpPr/>
+          <p:nvPr/>
+        </p:nvSpPr>
+        <p:spPr>
+          <a:xfrm>
+            <a:off x="4581144" y="4553712"/>
+            <a:ext cx="118872" cy="118872"/>
+          </a:xfrm>
+          <a:prstGeom prst="ellipse">
+            <a:avLst/>
+          </a:prstGeom>
+          <a:solidFill>
+            <a:srgbClr val="FF4D6D"/>
+          </a:solidFill>
+          <a:ln/>
+        </p:spPr>
+      </p:sp>
+      <p:sp>
+        <p:nvSpPr>
+          <p:cNvPr id="25" name="Text 20"/>
+          <p:cNvSpPr/>
+          <p:nvPr/>
+        </p:nvSpPr>
+        <p:spPr>
+          <a:xfrm>
+            <a:off x="4818888" y="4498848"/>
+            <a:ext cx="2834640" cy="676656"/>
+          </a:xfrm>
+          <a:prstGeom prst="rect">
+            <a:avLst/>
+          </a:prstGeom>
+          <a:noFill/>
+          <a:ln/>
+        </p:spPr>
+        <p:txBody>
+          <a:bodyPr wrap="square" lIns="0" tIns="0" rIns="0" bIns="0" rtlCol="0" anchor="t"/>
+          <a:lstStyle/>
+          <a:p>
+            <a:pPr algn="l" indent="0" marL="0">
+              <a:lnSpc>
+                <a:spcPct val="102000"/>
+              </a:lnSpc>
+              <a:buNone/>
+            </a:pPr>
+            <a:r>
+              <a:rPr lang="en-US" sz="1250" dirty="0">
+                <a:solidFill>
+                  <a:srgbClr val="2B2B33"/>
+                </a:solidFill>
+                <a:latin typeface="Calibri" pitchFamily="34" charset="0"/>
+                <a:ea typeface="Calibri" pitchFamily="34" charset="-122"/>
+                <a:cs typeface="Calibri" pitchFamily="34" charset="-120"/>
+              </a:rPr>
+              <a:t>IV metoprolol — rate control</a:t>
+            </a:r>
+            <a:endParaRPr lang="en-US" sz="1250" dirty="0"/>
+          </a:p>
+        </p:txBody>
+      </p:sp>
+      <p:sp>
+        <p:nvSpPr>
+          <p:cNvPr id="26" name="Shape 21"/>
+          <p:cNvSpPr/>
+          <p:nvPr/>
+        </p:nvSpPr>
+        <p:spPr>
+          <a:xfrm>
+            <a:off x="4581144" y="5285232"/>
+            <a:ext cx="118872" cy="118872"/>
+          </a:xfrm>
+          <a:prstGeom prst="ellipse">
+            <a:avLst/>
+          </a:prstGeom>
+          <a:solidFill>
+            <a:srgbClr val="FF4D6D"/>
+          </a:solidFill>
+          <a:ln/>
+        </p:spPr>
+      </p:sp>
+      <p:sp>
+        <p:nvSpPr>
+          <p:cNvPr id="27" name="Text 22"/>
+          <p:cNvSpPr/>
+          <p:nvPr/>
+        </p:nvSpPr>
+        <p:spPr>
+          <a:xfrm>
+            <a:off x="4818888" y="5230368"/>
+            <a:ext cx="2834640" cy="676656"/>
+          </a:xfrm>
+          <a:prstGeom prst="rect">
+            <a:avLst/>
+          </a:prstGeom>
+          <a:noFill/>
+          <a:ln/>
+        </p:spPr>
+        <p:txBody>
+          <a:bodyPr wrap="square" lIns="0" tIns="0" rIns="0" bIns="0" rtlCol="0" anchor="t"/>
+          <a:lstStyle/>
+          <a:p>
+            <a:pPr algn="l" indent="0" marL="0">
+              <a:lnSpc>
+                <a:spcPct val="102000"/>
+              </a:lnSpc>
+              <a:buNone/>
+            </a:pPr>
+            <a:r>
+              <a:rPr lang="en-US" sz="1250" dirty="0">
+                <a:solidFill>
+                  <a:srgbClr val="2B2B33"/>
+                </a:solidFill>
+                <a:latin typeface="Calibri" pitchFamily="34" charset="0"/>
+                <a:ea typeface="Calibri" pitchFamily="34" charset="-122"/>
+                <a:cs typeface="Calibri" pitchFamily="34" charset="-120"/>
+              </a:rPr>
+              <a:t>Flecainide or sotalol — conversion to sinus rhythm</a:t>
+            </a:r>
+            <a:endParaRPr lang="en-US" sz="1250" dirty="0"/>
+          </a:p>
+        </p:txBody>
+      </p:sp>
+      <p:sp>
+        <p:nvSpPr>
+          <p:cNvPr id="28" name="Shape 23"/>
+          <p:cNvSpPr/>
+          <p:nvPr/>
+        </p:nvSpPr>
+        <p:spPr>
+          <a:xfrm>
+            <a:off x="8074152" y="2670048"/>
+            <a:ext cx="3611880" cy="3319272"/>
+          </a:xfrm>
+          <a:prstGeom prst="roundRect">
+            <a:avLst>
+              <a:gd name="adj" fmla="val 3306"/>
+            </a:avLst>
+          </a:prstGeom>
+          <a:solidFill>
+            <a:srgbClr val="FFF0F3"/>
+          </a:solidFill>
+          <a:ln w="12700">
+            <a:solidFill>
+              <a:srgbClr val="FBD8DF"/>
+            </a:solidFill>
+            <a:prstDash val="solid"/>
+          </a:ln>
+          <a:effectLst>
+            <a:outerShdw sx="100000" sy="100000" kx="0" ky="0" algn="bl" rotWithShape="0" blurRad="127000" dist="50800" dir="5400000">
+              <a:srgbClr val="C9A3AC">
+                <a:alpha val="45000"/>
+              </a:srgbClr>
+            </a:outerShdw>
+          </a:effectLst>
+        </p:spPr>
+      </p:sp>
+      <p:sp>
+        <p:nvSpPr>
+          <p:cNvPr id="29" name="Shape 24"/>
+          <p:cNvSpPr/>
+          <p:nvPr/>
+        </p:nvSpPr>
+        <p:spPr>
+          <a:xfrm>
+            <a:off x="8348472" y="2926080"/>
+            <a:ext cx="658368" cy="658368"/>
           </a:xfrm>
           <a:prstGeom prst="ellipse">
             <a:avLst/>
@@ -14871,7 +15559,7 @@
       </p:sp>
       <p:pic>
         <p:nvPicPr>
-          <p:cNvPr id="12" name="Image 3" descr="preencoded.png">    </p:cNvPr>
+          <p:cNvPr id="30" name="Image 3" descr="preencoded.png">    </p:cNvPr>
           <p:cNvPicPr>
             <a:picLocks noChangeAspect="1"/>
           </p:cNvPicPr>
@@ -14885,8 +15573,8 @@
         </p:blipFill>
         <p:spPr>
           <a:xfrm>
-            <a:off x="777240" y="3209544"/>
-            <a:ext cx="164592" cy="164592"/>
+            <a:off x="8503920" y="3081528"/>
+            <a:ext cx="347472" cy="347472"/>
           </a:xfrm>
           <a:prstGeom prst="rect">
             <a:avLst/>
@@ -14895,14 +15583,14 @@
       </p:pic>
       <p:sp>
         <p:nvSpPr>
-          <p:cNvPr id="13" name="Text 7"/>
-          <p:cNvSpPr/>
-          <p:nvPr/>
-        </p:nvSpPr>
-        <p:spPr>
-          <a:xfrm>
-            <a:off x="1188720" y="3127248"/>
-            <a:ext cx="10058400" cy="502920"/>
+          <p:cNvPr id="31" name="Text 25"/>
+          <p:cNvSpPr/>
+          <p:nvPr/>
+        </p:nvSpPr>
+        <p:spPr>
+          <a:xfrm>
+            <a:off x="9125712" y="2926080"/>
+            <a:ext cx="2423160" cy="658368"/>
           </a:xfrm>
           <a:prstGeom prst="rect">
             <a:avLst/>
@@ -14915,403 +15603,242 @@
           <a:lstStyle/>
           <a:p>
             <a:pPr algn="l" indent="0" marL="0">
+              <a:buNone/>
+            </a:pPr>
+            <a:r>
+              <a:rPr lang="en-US" sz="1700" b="1" dirty="0">
+                <a:solidFill>
+                  <a:srgbClr val="2B2B33"/>
+                </a:solidFill>
+                <a:latin typeface="Cambria" pitchFamily="34" charset="0"/>
+                <a:ea typeface="Cambria" pitchFamily="34" charset="-122"/>
+                <a:cs typeface="Cambria" pitchFamily="34" charset="-120"/>
+              </a:rPr>
+              <a:t>Long-term Rhythm</a:t>
+            </a:r>
+            <a:endParaRPr lang="en-US" sz="1700" dirty="0"/>
+          </a:p>
+        </p:txBody>
+      </p:sp>
+      <p:sp>
+        <p:nvSpPr>
+          <p:cNvPr id="32" name="Shape 26"/>
+          <p:cNvSpPr/>
+          <p:nvPr/>
+        </p:nvSpPr>
+        <p:spPr>
+          <a:xfrm>
+            <a:off x="8366760" y="3822192"/>
+            <a:ext cx="118872" cy="118872"/>
+          </a:xfrm>
+          <a:prstGeom prst="ellipse">
+            <a:avLst/>
+          </a:prstGeom>
+          <a:solidFill>
+            <a:srgbClr val="FF4D6D"/>
+          </a:solidFill>
+          <a:ln/>
+        </p:spPr>
+      </p:sp>
+      <p:sp>
+        <p:nvSpPr>
+          <p:cNvPr id="33" name="Text 27"/>
+          <p:cNvSpPr/>
+          <p:nvPr/>
+        </p:nvSpPr>
+        <p:spPr>
+          <a:xfrm>
+            <a:off x="8604504" y="3767328"/>
+            <a:ext cx="2834640" cy="676656"/>
+          </a:xfrm>
+          <a:prstGeom prst="rect">
+            <a:avLst/>
+          </a:prstGeom>
+          <a:noFill/>
+          <a:ln/>
+        </p:spPr>
+        <p:txBody>
+          <a:bodyPr wrap="square" lIns="0" tIns="0" rIns="0" bIns="0" rtlCol="0" anchor="t"/>
+          <a:lstStyle/>
+          <a:p>
+            <a:pPr algn="l" indent="0" marL="0">
               <a:lnSpc>
-                <a:spcPct val="105000"/>
+                <a:spcPct val="102000"/>
               </a:lnSpc>
               <a:buNone/>
             </a:pPr>
             <a:r>
-              <a:rPr lang="en-US" sz="1500" dirty="0">
-                <a:solidFill>
-                  <a:srgbClr val="FBD8DF"/>
+              <a:rPr lang="en-US" sz="1250" dirty="0">
+                <a:solidFill>
+                  <a:srgbClr val="2B2B33"/>
                 </a:solidFill>
                 <a:latin typeface="Calibri" pitchFamily="34" charset="0"/>
                 <a:ea typeface="Calibri" pitchFamily="34" charset="-122"/>
                 <a:cs typeface="Calibri" pitchFamily="34" charset="-120"/>
               </a:rPr>
-              <a:t>The commonest sustained arrhythmia — linked to hypertension, age and structural heart disease.</a:t>
-            </a:r>
-            <a:endParaRPr lang="en-US" sz="1500" dirty="0"/>
-          </a:p>
-        </p:txBody>
-      </p:sp>
-      <p:sp>
-        <p:nvSpPr>
-          <p:cNvPr id="14" name="Shape 8"/>
-          <p:cNvSpPr/>
-          <p:nvPr/>
-        </p:nvSpPr>
-        <p:spPr>
-          <a:xfrm>
-            <a:off x="713232" y="3694176"/>
-            <a:ext cx="292608" cy="292608"/>
+              <a:t>No structural disease — flecainide, sotalol</a:t>
+            </a:r>
+            <a:endParaRPr lang="en-US" sz="1250" dirty="0"/>
+          </a:p>
+        </p:txBody>
+      </p:sp>
+      <p:sp>
+        <p:nvSpPr>
+          <p:cNvPr id="34" name="Shape 28"/>
+          <p:cNvSpPr/>
+          <p:nvPr/>
+        </p:nvSpPr>
+        <p:spPr>
+          <a:xfrm>
+            <a:off x="8366760" y="4553712"/>
+            <a:ext cx="118872" cy="118872"/>
           </a:xfrm>
           <a:prstGeom prst="ellipse">
             <a:avLst/>
           </a:prstGeom>
           <a:solidFill>
-            <a:srgbClr val="A4133C"/>
+            <a:srgbClr val="FF4D6D"/>
           </a:solidFill>
           <a:ln/>
         </p:spPr>
       </p:sp>
-      <p:pic>
-        <p:nvPicPr>
-          <p:cNvPr id="15" name="Image 4" descr="preencoded.png">    </p:cNvPr>
-          <p:cNvPicPr>
-            <a:picLocks noChangeAspect="1"/>
-          </p:cNvPicPr>
-          <p:nvPr/>
-        </p:nvPicPr>
-        <p:blipFill>
-          <a:blip r:embed="rId5"/>
-          <a:stretch>
-            <a:fillRect/>
-          </a:stretch>
-        </p:blipFill>
-        <p:spPr>
-          <a:xfrm>
-            <a:off x="777240" y="3758184"/>
-            <a:ext cx="164592" cy="164592"/>
-          </a:xfrm>
-          <a:prstGeom prst="rect">
-            <a:avLst/>
-          </a:prstGeom>
-        </p:spPr>
-      </p:pic>
-      <p:sp>
-        <p:nvSpPr>
-          <p:cNvPr id="16" name="Text 9"/>
-          <p:cNvSpPr/>
-          <p:nvPr/>
-        </p:nvSpPr>
-        <p:spPr>
-          <a:xfrm>
-            <a:off x="1188720" y="3675888"/>
-            <a:ext cx="10058400" cy="502920"/>
-          </a:xfrm>
-          <a:prstGeom prst="rect">
-            <a:avLst/>
-          </a:prstGeom>
-          <a:noFill/>
-          <a:ln/>
-        </p:spPr>
-        <p:txBody>
-          <a:bodyPr wrap="square" lIns="0" tIns="0" rIns="0" bIns="0" rtlCol="0" anchor="ctr"/>
+      <p:sp>
+        <p:nvSpPr>
+          <p:cNvPr id="35" name="Text 29"/>
+          <p:cNvSpPr/>
+          <p:nvPr/>
+        </p:nvSpPr>
+        <p:spPr>
+          <a:xfrm>
+            <a:off x="8604504" y="4498848"/>
+            <a:ext cx="2834640" cy="676656"/>
+          </a:xfrm>
+          <a:prstGeom prst="rect">
+            <a:avLst/>
+          </a:prstGeom>
+          <a:noFill/>
+          <a:ln/>
+        </p:spPr>
+        <p:txBody>
+          <a:bodyPr wrap="square" lIns="0" tIns="0" rIns="0" bIns="0" rtlCol="0" anchor="t"/>
           <a:lstStyle/>
           <a:p>
             <a:pPr algn="l" indent="0" marL="0">
               <a:lnSpc>
-                <a:spcPct val="105000"/>
+                <a:spcPct val="102000"/>
               </a:lnSpc>
               <a:buNone/>
             </a:pPr>
             <a:r>
-              <a:rPr lang="en-US" sz="1500" dirty="0">
-                <a:solidFill>
-                  <a:srgbClr val="FBD8DF"/>
+              <a:rPr lang="en-US" sz="1250" dirty="0">
+                <a:solidFill>
+                  <a:srgbClr val="2B2B33"/>
                 </a:solidFill>
                 <a:latin typeface="Calibri" pitchFamily="34" charset="0"/>
                 <a:ea typeface="Calibri" pitchFamily="34" charset="-122"/>
                 <a:cs typeface="Calibri" pitchFamily="34" charset="-120"/>
               </a:rPr>
-              <a:t>Its main danger is thromboembolic stroke — always assess stroke risk (CHA₂DS₂-VASc).</a:t>
-            </a:r>
-            <a:endParaRPr lang="en-US" sz="1500" dirty="0"/>
-          </a:p>
-        </p:txBody>
-      </p:sp>
-      <p:sp>
-        <p:nvSpPr>
-          <p:cNvPr id="17" name="Shape 10"/>
-          <p:cNvSpPr/>
-          <p:nvPr/>
-        </p:nvSpPr>
-        <p:spPr>
-          <a:xfrm>
-            <a:off x="713232" y="4242816"/>
-            <a:ext cx="292608" cy="292608"/>
+              <a:t>Structural disease — amiodarone</a:t>
+            </a:r>
+            <a:endParaRPr lang="en-US" sz="1250" dirty="0"/>
+          </a:p>
+        </p:txBody>
+      </p:sp>
+      <p:sp>
+        <p:nvSpPr>
+          <p:cNvPr id="36" name="Shape 30"/>
+          <p:cNvSpPr/>
+          <p:nvPr/>
+        </p:nvSpPr>
+        <p:spPr>
+          <a:xfrm>
+            <a:off x="8366760" y="5285232"/>
+            <a:ext cx="118872" cy="118872"/>
           </a:xfrm>
           <a:prstGeom prst="ellipse">
             <a:avLst/>
           </a:prstGeom>
           <a:solidFill>
-            <a:srgbClr val="A4133C"/>
+            <a:srgbClr val="FF4D6D"/>
           </a:solidFill>
           <a:ln/>
         </p:spPr>
       </p:sp>
-      <p:pic>
-        <p:nvPicPr>
-          <p:cNvPr id="18" name="Image 5" descr="preencoded.png">    </p:cNvPr>
-          <p:cNvPicPr>
-            <a:picLocks noChangeAspect="1"/>
-          </p:cNvPicPr>
-          <p:nvPr/>
-        </p:nvPicPr>
-        <p:blipFill>
-          <a:blip r:embed="rId6"/>
-          <a:stretch>
-            <a:fillRect/>
-          </a:stretch>
-        </p:blipFill>
-        <p:spPr>
-          <a:xfrm>
-            <a:off x="777240" y="4306824"/>
-            <a:ext cx="164592" cy="164592"/>
-          </a:xfrm>
-          <a:prstGeom prst="rect">
-            <a:avLst/>
-          </a:prstGeom>
-        </p:spPr>
-      </p:pic>
-      <p:sp>
-        <p:nvSpPr>
-          <p:cNvPr id="19" name="Text 11"/>
-          <p:cNvSpPr/>
-          <p:nvPr/>
-        </p:nvSpPr>
-        <p:spPr>
-          <a:xfrm>
-            <a:off x="1188720" y="4224528"/>
-            <a:ext cx="10058400" cy="502920"/>
-          </a:xfrm>
-          <a:prstGeom prst="rect">
-            <a:avLst/>
-          </a:prstGeom>
-          <a:noFill/>
-          <a:ln/>
-        </p:spPr>
-        <p:txBody>
-          <a:bodyPr wrap="square" lIns="0" tIns="0" rIns="0" bIns="0" rtlCol="0" anchor="ctr"/>
+      <p:sp>
+        <p:nvSpPr>
+          <p:cNvPr id="37" name="Text 31"/>
+          <p:cNvSpPr/>
+          <p:nvPr/>
+        </p:nvSpPr>
+        <p:spPr>
+          <a:xfrm>
+            <a:off x="8604504" y="5230368"/>
+            <a:ext cx="2834640" cy="676656"/>
+          </a:xfrm>
+          <a:prstGeom prst="rect">
+            <a:avLst/>
+          </a:prstGeom>
+          <a:noFill/>
+          <a:ln/>
+        </p:spPr>
+        <p:txBody>
+          <a:bodyPr wrap="square" lIns="0" tIns="0" rIns="0" bIns="0" rtlCol="0" anchor="t"/>
           <a:lstStyle/>
           <a:p>
             <a:pPr algn="l" indent="0" marL="0">
               <a:lnSpc>
-                <a:spcPct val="105000"/>
+                <a:spcPct val="102000"/>
               </a:lnSpc>
               <a:buNone/>
             </a:pPr>
             <a:r>
-              <a:rPr lang="en-US" sz="1500" dirty="0">
-                <a:solidFill>
-                  <a:srgbClr val="FBD8DF"/>
+              <a:rPr lang="en-US" sz="1250" dirty="0">
+                <a:solidFill>
+                  <a:srgbClr val="2B2B33"/>
                 </a:solidFill>
                 <a:latin typeface="Calibri" pitchFamily="34" charset="0"/>
                 <a:ea typeface="Calibri" pitchFamily="34" charset="-122"/>
                 <a:cs typeface="Calibri" pitchFamily="34" charset="-120"/>
               </a:rPr>
-              <a:t>Differentials: atrial flutter, multifocal atrial tachycardia, frequent PACs, SVT, pre-excited AF / VT.</a:t>
-            </a:r>
-            <a:endParaRPr lang="en-US" sz="1500" dirty="0"/>
-          </a:p>
-        </p:txBody>
-      </p:sp>
-      <p:sp>
-        <p:nvSpPr>
-          <p:cNvPr id="20" name="Shape 12"/>
-          <p:cNvSpPr/>
-          <p:nvPr/>
-        </p:nvSpPr>
-        <p:spPr>
-          <a:xfrm>
-            <a:off x="713232" y="4791456"/>
-            <a:ext cx="292608" cy="292608"/>
-          </a:xfrm>
-          <a:prstGeom prst="ellipse">
-            <a:avLst/>
-          </a:prstGeom>
-          <a:solidFill>
-            <a:srgbClr val="A4133C"/>
-          </a:solidFill>
-          <a:ln/>
-        </p:spPr>
-      </p:sp>
-      <p:pic>
-        <p:nvPicPr>
-          <p:cNvPr id="21" name="Image 6" descr="preencoded.png">    </p:cNvPr>
-          <p:cNvPicPr>
-            <a:picLocks noChangeAspect="1"/>
-          </p:cNvPicPr>
-          <p:nvPr/>
-        </p:nvPicPr>
-        <p:blipFill>
-          <a:blip r:embed="rId7"/>
-          <a:stretch>
-            <a:fillRect/>
-          </a:stretch>
-        </p:blipFill>
-        <p:spPr>
-          <a:xfrm>
-            <a:off x="777240" y="4855464"/>
-            <a:ext cx="164592" cy="164592"/>
-          </a:xfrm>
-          <a:prstGeom prst="rect">
-            <a:avLst/>
-          </a:prstGeom>
-        </p:spPr>
-      </p:pic>
-      <p:sp>
-        <p:nvSpPr>
-          <p:cNvPr id="22" name="Text 13"/>
-          <p:cNvSpPr/>
-          <p:nvPr/>
-        </p:nvSpPr>
-        <p:spPr>
-          <a:xfrm>
-            <a:off x="1188720" y="4773168"/>
-            <a:ext cx="10058400" cy="502920"/>
-          </a:xfrm>
-          <a:prstGeom prst="rect">
-            <a:avLst/>
-          </a:prstGeom>
-          <a:noFill/>
-          <a:ln/>
-        </p:spPr>
-        <p:txBody>
-          <a:bodyPr wrap="square" lIns="0" tIns="0" rIns="0" bIns="0" rtlCol="0" anchor="ctr"/>
-          <a:lstStyle/>
-          <a:p>
-            <a:pPr algn="l" indent="0" marL="0">
-              <a:lnSpc>
-                <a:spcPct val="105000"/>
-              </a:lnSpc>
-              <a:buNone/>
-            </a:pPr>
-            <a:r>
-              <a:rPr lang="en-US" sz="1500" dirty="0">
-                <a:solidFill>
-                  <a:srgbClr val="FBD8DF"/>
+              <a:t>Rate: digoxin; beta-blocker only after 1st trimester</a:t>
+            </a:r>
+            <a:endParaRPr lang="en-US" sz="1250" dirty="0"/>
+          </a:p>
+        </p:txBody>
+      </p:sp>
+      <p:sp>
+        <p:nvSpPr>
+          <p:cNvPr id="38" name="Text 32"/>
+          <p:cNvSpPr/>
+          <p:nvPr/>
+        </p:nvSpPr>
+        <p:spPr>
+          <a:xfrm>
+            <a:off x="11277295" y="6355080"/>
+            <a:ext cx="548640" cy="320040"/>
+          </a:xfrm>
+          <a:prstGeom prst="rect">
+            <a:avLst/>
+          </a:prstGeom>
+          <a:noFill/>
+          <a:ln/>
+        </p:spPr>
+        <p:txBody>
+          <a:bodyPr wrap="square" rtlCol="0" anchor="t"/>
+          <a:lstStyle/>
+          <a:p>
+            <a:pPr algn="r" indent="0" marL="0">
+              <a:buNone/>
+            </a:pPr>
+            <a:r>
+              <a:rPr lang="en-US" sz="1100" b="1" dirty="0">
+                <a:solidFill>
+                  <a:srgbClr val="6B6B76"/>
                 </a:solidFill>
                 <a:latin typeface="Calibri" pitchFamily="34" charset="0"/>
                 <a:ea typeface="Calibri" pitchFamily="34" charset="-122"/>
                 <a:cs typeface="Calibri" pitchFamily="34" charset="-120"/>
               </a:rPr>
-              <a:t>Manage with the ABC pathway: Anticoagulation, Better symptom control, Comorbidities.</a:t>
-            </a:r>
-            <a:endParaRPr lang="en-US" sz="1500" dirty="0"/>
-          </a:p>
-        </p:txBody>
-      </p:sp>
-      <p:sp>
-        <p:nvSpPr>
-          <p:cNvPr id="23" name="Shape 14"/>
-          <p:cNvSpPr/>
-          <p:nvPr/>
-        </p:nvSpPr>
-        <p:spPr>
-          <a:xfrm>
-            <a:off x="713232" y="5340096"/>
-            <a:ext cx="292608" cy="292608"/>
-          </a:xfrm>
-          <a:prstGeom prst="ellipse">
-            <a:avLst/>
-          </a:prstGeom>
-          <a:solidFill>
-            <a:srgbClr val="A4133C"/>
-          </a:solidFill>
-          <a:ln/>
-        </p:spPr>
-      </p:sp>
-      <p:pic>
-        <p:nvPicPr>
-          <p:cNvPr id="24" name="Image 7" descr="preencoded.png">    </p:cNvPr>
-          <p:cNvPicPr>
-            <a:picLocks noChangeAspect="1"/>
-          </p:cNvPicPr>
-          <p:nvPr/>
-        </p:nvPicPr>
-        <p:blipFill>
-          <a:blip r:embed="rId8"/>
-          <a:stretch>
-            <a:fillRect/>
-          </a:stretch>
-        </p:blipFill>
-        <p:spPr>
-          <a:xfrm>
-            <a:off x="777240" y="5404104"/>
-            <a:ext cx="164592" cy="164592"/>
-          </a:xfrm>
-          <a:prstGeom prst="rect">
-            <a:avLst/>
-          </a:prstGeom>
-        </p:spPr>
-      </p:pic>
-      <p:sp>
-        <p:nvSpPr>
-          <p:cNvPr id="25" name="Text 15"/>
-          <p:cNvSpPr/>
-          <p:nvPr/>
-        </p:nvSpPr>
-        <p:spPr>
-          <a:xfrm>
-            <a:off x="1188720" y="5321808"/>
-            <a:ext cx="10058400" cy="502920"/>
-          </a:xfrm>
-          <a:prstGeom prst="rect">
-            <a:avLst/>
-          </a:prstGeom>
-          <a:noFill/>
-          <a:ln/>
-        </p:spPr>
-        <p:txBody>
-          <a:bodyPr wrap="square" lIns="0" tIns="0" rIns="0" bIns="0" rtlCol="0" anchor="ctr"/>
-          <a:lstStyle/>
-          <a:p>
-            <a:pPr algn="l" indent="0" marL="0">
-              <a:lnSpc>
-                <a:spcPct val="105000"/>
-              </a:lnSpc>
-              <a:buNone/>
-            </a:pPr>
-            <a:r>
-              <a:rPr lang="en-US" sz="1500" dirty="0">
-                <a:solidFill>
-                  <a:srgbClr val="FBD8DF"/>
-                </a:solidFill>
-                <a:latin typeface="Calibri" pitchFamily="34" charset="0"/>
-                <a:ea typeface="Calibri" pitchFamily="34" charset="-122"/>
-                <a:cs typeface="Calibri" pitchFamily="34" charset="-120"/>
-              </a:rPr>
-              <a:t>In pregnancy: LMWH is the anticoagulant of choice — avoid warfarin and DOACs.</a:t>
-            </a:r>
-            <a:endParaRPr lang="en-US" sz="1500" dirty="0"/>
-          </a:p>
-        </p:txBody>
-      </p:sp>
-      <p:sp>
-        <p:nvSpPr>
-          <p:cNvPr id="26" name="Text 16"/>
-          <p:cNvSpPr/>
-          <p:nvPr/>
-        </p:nvSpPr>
-        <p:spPr>
-          <a:xfrm>
-            <a:off x="11277295" y="6355080"/>
-            <a:ext cx="548640" cy="320040"/>
-          </a:xfrm>
-          <a:prstGeom prst="rect">
-            <a:avLst/>
-          </a:prstGeom>
-          <a:noFill/>
-          <a:ln/>
-        </p:spPr>
-        <p:txBody>
-          <a:bodyPr wrap="square" rtlCol="0" anchor="t"/>
-          <a:lstStyle/>
-          <a:p>
-            <a:pPr algn="r" indent="0" marL="0">
-              <a:buNone/>
-            </a:pPr>
-            <a:r>
-              <a:rPr lang="en-US" sz="1100" b="1" dirty="0">
-                <a:solidFill>
-                  <a:srgbClr val="FBD8DF"/>
-                </a:solidFill>
-                <a:latin typeface="Calibri" pitchFamily="34" charset="0"/>
-                <a:ea typeface="Calibri" pitchFamily="34" charset="-122"/>
-                <a:cs typeface="Calibri" pitchFamily="34" charset="-120"/>
-              </a:rPr>
               <a:t>19</a:t>
             </a:r>
             <a:endParaRPr lang="en-US" sz="1100" dirty="0"/>
@@ -15320,7 +15847,7 @@
       </p:sp>
       <p:sp>
         <p:nvSpPr>
-          <p:cNvPr id="27" name="Text 17"/>
+          <p:cNvPr id="39" name="Text 33"/>
           <p:cNvSpPr/>
           <p:nvPr/>
         </p:nvSpPr>
@@ -15345,7 +15872,7 @@
             <a:r>
               <a:rPr lang="en-US" sz="900" dirty="0">
                 <a:solidFill>
-                  <a:srgbClr val="FBD8DF"/>
+                  <a:srgbClr val="6B6B76"/>
                 </a:solidFill>
                 <a:latin typeface="Calibri" pitchFamily="34" charset="0"/>
                 <a:ea typeface="Calibri" pitchFamily="34" charset="-122"/>
@@ -16086,6 +16613,802 @@
 <file path=ppt/slides/slide20.xml><?xml version="1.0" encoding="utf-8"?>
 <p:sld xmlns:a="http://schemas.openxmlformats.org/drawingml/2006/main" xmlns:r="http://schemas.openxmlformats.org/officeDocument/2006/relationships" xmlns:p="http://schemas.openxmlformats.org/presentationml/2006/main">
   <p:cSld name="Slide 20">
+    <p:bg>
+      <p:bgPr>
+        <a:solidFill>
+          <a:srgbClr val="590D22"/>
+        </a:solidFill>
+      </p:bgPr>
+    </p:bg>
+    <p:spTree>
+      <p:nvGrpSpPr>
+        <p:cNvPr id="1" name=""/>
+        <p:cNvGrpSpPr/>
+        <p:nvPr/>
+      </p:nvGrpSpPr>
+      <p:grpSpPr>
+        <a:xfrm>
+          <a:off x="0" y="0"/>
+          <a:ext cx="0" cy="0"/>
+          <a:chOff x="0" y="0"/>
+          <a:chExt cx="0" cy="0"/>
+        </a:xfrm>
+      </p:grpSpPr>
+      <p:sp>
+        <p:nvSpPr>
+          <p:cNvPr id="2" name="Shape 0"/>
+          <p:cNvSpPr/>
+          <p:nvPr/>
+        </p:nvSpPr>
+        <p:spPr>
+          <a:xfrm>
+            <a:off x="0" y="0"/>
+            <a:ext cx="12191695" cy="6858000"/>
+          </a:xfrm>
+          <a:prstGeom prst="rect">
+            <a:avLst/>
+          </a:prstGeom>
+          <a:solidFill>
+            <a:srgbClr val="3A0A17">
+              <a:alpha val="65000"/>
+            </a:srgbClr>
+          </a:solidFill>
+          <a:ln/>
+        </p:spPr>
+      </p:sp>
+      <p:pic>
+        <p:nvPicPr>
+          <p:cNvPr id="3" name="Image 0" descr="preencoded.png">    </p:cNvPr>
+          <p:cNvPicPr>
+            <a:picLocks noChangeAspect="1"/>
+          </p:cNvPicPr>
+          <p:nvPr/>
+        </p:nvPicPr>
+        <p:blipFill>
+          <a:blip r:embed="rId1">
+            <a:alphaModFix amt="9000"/>
+          </a:blip>
+          <a:stretch>
+            <a:fillRect/>
+          </a:stretch>
+        </p:blipFill>
+        <p:spPr>
+          <a:xfrm>
+            <a:off x="8321040" y="3291840"/>
+            <a:ext cx="4572000" cy="4572000"/>
+          </a:xfrm>
+          <a:prstGeom prst="rect">
+            <a:avLst/>
+          </a:prstGeom>
+        </p:spPr>
+      </p:pic>
+      <p:sp>
+        <p:nvSpPr>
+          <p:cNvPr id="4" name="Shape 1"/>
+          <p:cNvSpPr/>
+          <p:nvPr/>
+        </p:nvSpPr>
+        <p:spPr>
+          <a:xfrm>
+            <a:off x="685800" y="685800"/>
+            <a:ext cx="960120" cy="960120"/>
+          </a:xfrm>
+          <a:prstGeom prst="ellipse">
+            <a:avLst/>
+          </a:prstGeom>
+          <a:solidFill>
+            <a:srgbClr val="A4133C"/>
+          </a:solidFill>
+          <a:ln/>
+        </p:spPr>
+      </p:sp>
+      <p:pic>
+        <p:nvPicPr>
+          <p:cNvPr id="5" name="Image 1" descr="preencoded.png">    </p:cNvPr>
+          <p:cNvPicPr>
+            <a:picLocks noChangeAspect="1"/>
+          </p:cNvPicPr>
+          <p:nvPr/>
+        </p:nvPicPr>
+        <p:blipFill>
+          <a:blip r:embed="rId2"/>
+          <a:stretch>
+            <a:fillRect/>
+          </a:stretch>
+        </p:blipFill>
+        <p:spPr>
+          <a:xfrm>
+            <a:off x="905256" y="905256"/>
+            <a:ext cx="521208" cy="521208"/>
+          </a:xfrm>
+          <a:prstGeom prst="rect">
+            <a:avLst/>
+          </a:prstGeom>
+        </p:spPr>
+      </p:pic>
+      <p:sp>
+        <p:nvSpPr>
+          <p:cNvPr id="6" name="Text 2"/>
+          <p:cNvSpPr/>
+          <p:nvPr/>
+        </p:nvSpPr>
+        <p:spPr>
+          <a:xfrm>
+            <a:off x="1828800" y="868680"/>
+            <a:ext cx="8229600" cy="548640"/>
+          </a:xfrm>
+          <a:prstGeom prst="rect">
+            <a:avLst/>
+          </a:prstGeom>
+          <a:noFill/>
+          <a:ln/>
+        </p:spPr>
+        <p:txBody>
+          <a:bodyPr wrap="square" rtlCol="0" anchor="ctr"/>
+          <a:lstStyle/>
+          <a:p>
+            <a:pPr algn="l" indent="0" marL="0">
+              <a:buNone/>
+            </a:pPr>
+            <a:r>
+              <a:rPr lang="en-US" sz="1700" b="1" spc="300" kern="0" dirty="0">
+                <a:solidFill>
+                  <a:srgbClr val="FF4D6D"/>
+                </a:solidFill>
+                <a:latin typeface="Calibri" pitchFamily="34" charset="0"/>
+                <a:ea typeface="Calibri" pitchFamily="34" charset="-122"/>
+                <a:cs typeface="Calibri" pitchFamily="34" charset="-120"/>
+              </a:rPr>
+              <a:t>SUMMARY</a:t>
+            </a:r>
+            <a:endParaRPr lang="en-US" sz="1700" dirty="0"/>
+          </a:p>
+        </p:txBody>
+      </p:sp>
+      <p:sp>
+        <p:nvSpPr>
+          <p:cNvPr id="7" name="Text 3"/>
+          <p:cNvSpPr/>
+          <p:nvPr/>
+        </p:nvSpPr>
+        <p:spPr>
+          <a:xfrm>
+            <a:off x="640080" y="1691640"/>
+            <a:ext cx="10058400" cy="914400"/>
+          </a:xfrm>
+          <a:prstGeom prst="rect">
+            <a:avLst/>
+          </a:prstGeom>
+          <a:noFill/>
+          <a:ln/>
+        </p:spPr>
+        <p:txBody>
+          <a:bodyPr wrap="square" rtlCol="0" anchor="t"/>
+          <a:lstStyle/>
+          <a:p>
+            <a:pPr algn="l" indent="0" marL="0">
+              <a:buNone/>
+            </a:pPr>
+            <a:r>
+              <a:rPr lang="en-US" sz="4600" b="1" dirty="0">
+                <a:solidFill>
+                  <a:srgbClr val="FFFFFF"/>
+                </a:solidFill>
+                <a:latin typeface="Cambria" pitchFamily="34" charset="0"/>
+                <a:ea typeface="Cambria" pitchFamily="34" charset="-122"/>
+                <a:cs typeface="Cambria" pitchFamily="34" charset="-120"/>
+              </a:rPr>
+              <a:t>Key Points</a:t>
+            </a:r>
+            <a:endParaRPr lang="en-US" sz="4600" dirty="0"/>
+          </a:p>
+        </p:txBody>
+      </p:sp>
+      <p:sp>
+        <p:nvSpPr>
+          <p:cNvPr id="8" name="Shape 4"/>
+          <p:cNvSpPr/>
+          <p:nvPr/>
+        </p:nvSpPr>
+        <p:spPr>
+          <a:xfrm>
+            <a:off x="713232" y="2596896"/>
+            <a:ext cx="292608" cy="292608"/>
+          </a:xfrm>
+          <a:prstGeom prst="ellipse">
+            <a:avLst/>
+          </a:prstGeom>
+          <a:solidFill>
+            <a:srgbClr val="A4133C"/>
+          </a:solidFill>
+          <a:ln/>
+        </p:spPr>
+      </p:sp>
+      <p:pic>
+        <p:nvPicPr>
+          <p:cNvPr id="9" name="Image 2" descr="preencoded.png">    </p:cNvPr>
+          <p:cNvPicPr>
+            <a:picLocks noChangeAspect="1"/>
+          </p:cNvPicPr>
+          <p:nvPr/>
+        </p:nvPicPr>
+        <p:blipFill>
+          <a:blip r:embed="rId3"/>
+          <a:stretch>
+            <a:fillRect/>
+          </a:stretch>
+        </p:blipFill>
+        <p:spPr>
+          <a:xfrm>
+            <a:off x="777240" y="2660904"/>
+            <a:ext cx="164592" cy="164592"/>
+          </a:xfrm>
+          <a:prstGeom prst="rect">
+            <a:avLst/>
+          </a:prstGeom>
+        </p:spPr>
+      </p:pic>
+      <p:sp>
+        <p:nvSpPr>
+          <p:cNvPr id="10" name="Text 5"/>
+          <p:cNvSpPr/>
+          <p:nvPr/>
+        </p:nvSpPr>
+        <p:spPr>
+          <a:xfrm>
+            <a:off x="1188720" y="2578608"/>
+            <a:ext cx="10058400" cy="502920"/>
+          </a:xfrm>
+          <a:prstGeom prst="rect">
+            <a:avLst/>
+          </a:prstGeom>
+          <a:noFill/>
+          <a:ln/>
+        </p:spPr>
+        <p:txBody>
+          <a:bodyPr wrap="square" lIns="0" tIns="0" rIns="0" bIns="0" rtlCol="0" anchor="ctr"/>
+          <a:lstStyle/>
+          <a:p>
+            <a:pPr algn="l" indent="0" marL="0">
+              <a:lnSpc>
+                <a:spcPct val="105000"/>
+              </a:lnSpc>
+              <a:buNone/>
+            </a:pPr>
+            <a:r>
+              <a:rPr lang="en-US" sz="1500" dirty="0">
+                <a:solidFill>
+                  <a:srgbClr val="FBD8DF"/>
+                </a:solidFill>
+                <a:latin typeface="Calibri" pitchFamily="34" charset="0"/>
+                <a:ea typeface="Calibri" pitchFamily="34" charset="-122"/>
+                <a:cs typeface="Calibri" pitchFamily="34" charset="-120"/>
+              </a:rPr>
+              <a:t>AF = irregularly irregular rhythm with absent P waves and a fibrillatory baseline.</a:t>
+            </a:r>
+            <a:endParaRPr lang="en-US" sz="1500" dirty="0"/>
+          </a:p>
+        </p:txBody>
+      </p:sp>
+      <p:sp>
+        <p:nvSpPr>
+          <p:cNvPr id="11" name="Shape 6"/>
+          <p:cNvSpPr/>
+          <p:nvPr/>
+        </p:nvSpPr>
+        <p:spPr>
+          <a:xfrm>
+            <a:off x="713232" y="3145536"/>
+            <a:ext cx="292608" cy="292608"/>
+          </a:xfrm>
+          <a:prstGeom prst="ellipse">
+            <a:avLst/>
+          </a:prstGeom>
+          <a:solidFill>
+            <a:srgbClr val="A4133C"/>
+          </a:solidFill>
+          <a:ln/>
+        </p:spPr>
+      </p:sp>
+      <p:pic>
+        <p:nvPicPr>
+          <p:cNvPr id="12" name="Image 3" descr="preencoded.png">    </p:cNvPr>
+          <p:cNvPicPr>
+            <a:picLocks noChangeAspect="1"/>
+          </p:cNvPicPr>
+          <p:nvPr/>
+        </p:nvPicPr>
+        <p:blipFill>
+          <a:blip r:embed="rId4"/>
+          <a:stretch>
+            <a:fillRect/>
+          </a:stretch>
+        </p:blipFill>
+        <p:spPr>
+          <a:xfrm>
+            <a:off x="777240" y="3209544"/>
+            <a:ext cx="164592" cy="164592"/>
+          </a:xfrm>
+          <a:prstGeom prst="rect">
+            <a:avLst/>
+          </a:prstGeom>
+        </p:spPr>
+      </p:pic>
+      <p:sp>
+        <p:nvSpPr>
+          <p:cNvPr id="13" name="Text 7"/>
+          <p:cNvSpPr/>
+          <p:nvPr/>
+        </p:nvSpPr>
+        <p:spPr>
+          <a:xfrm>
+            <a:off x="1188720" y="3127248"/>
+            <a:ext cx="10058400" cy="502920"/>
+          </a:xfrm>
+          <a:prstGeom prst="rect">
+            <a:avLst/>
+          </a:prstGeom>
+          <a:noFill/>
+          <a:ln/>
+        </p:spPr>
+        <p:txBody>
+          <a:bodyPr wrap="square" lIns="0" tIns="0" rIns="0" bIns="0" rtlCol="0" anchor="ctr"/>
+          <a:lstStyle/>
+          <a:p>
+            <a:pPr algn="l" indent="0" marL="0">
+              <a:lnSpc>
+                <a:spcPct val="105000"/>
+              </a:lnSpc>
+              <a:buNone/>
+            </a:pPr>
+            <a:r>
+              <a:rPr lang="en-US" sz="1500" dirty="0">
+                <a:solidFill>
+                  <a:srgbClr val="FBD8DF"/>
+                </a:solidFill>
+                <a:latin typeface="Calibri" pitchFamily="34" charset="0"/>
+                <a:ea typeface="Calibri" pitchFamily="34" charset="-122"/>
+                <a:cs typeface="Calibri" pitchFamily="34" charset="-120"/>
+              </a:rPr>
+              <a:t>The commonest sustained arrhythmia — linked to hypertension, age and structural heart disease.</a:t>
+            </a:r>
+            <a:endParaRPr lang="en-US" sz="1500" dirty="0"/>
+          </a:p>
+        </p:txBody>
+      </p:sp>
+      <p:sp>
+        <p:nvSpPr>
+          <p:cNvPr id="14" name="Shape 8"/>
+          <p:cNvSpPr/>
+          <p:nvPr/>
+        </p:nvSpPr>
+        <p:spPr>
+          <a:xfrm>
+            <a:off x="713232" y="3694176"/>
+            <a:ext cx="292608" cy="292608"/>
+          </a:xfrm>
+          <a:prstGeom prst="ellipse">
+            <a:avLst/>
+          </a:prstGeom>
+          <a:solidFill>
+            <a:srgbClr val="A4133C"/>
+          </a:solidFill>
+          <a:ln/>
+        </p:spPr>
+      </p:sp>
+      <p:pic>
+        <p:nvPicPr>
+          <p:cNvPr id="15" name="Image 4" descr="preencoded.png">    </p:cNvPr>
+          <p:cNvPicPr>
+            <a:picLocks noChangeAspect="1"/>
+          </p:cNvPicPr>
+          <p:nvPr/>
+        </p:nvPicPr>
+        <p:blipFill>
+          <a:blip r:embed="rId5"/>
+          <a:stretch>
+            <a:fillRect/>
+          </a:stretch>
+        </p:blipFill>
+        <p:spPr>
+          <a:xfrm>
+            <a:off x="777240" y="3758184"/>
+            <a:ext cx="164592" cy="164592"/>
+          </a:xfrm>
+          <a:prstGeom prst="rect">
+            <a:avLst/>
+          </a:prstGeom>
+        </p:spPr>
+      </p:pic>
+      <p:sp>
+        <p:nvSpPr>
+          <p:cNvPr id="16" name="Text 9"/>
+          <p:cNvSpPr/>
+          <p:nvPr/>
+        </p:nvSpPr>
+        <p:spPr>
+          <a:xfrm>
+            <a:off x="1188720" y="3675888"/>
+            <a:ext cx="10058400" cy="502920"/>
+          </a:xfrm>
+          <a:prstGeom prst="rect">
+            <a:avLst/>
+          </a:prstGeom>
+          <a:noFill/>
+          <a:ln/>
+        </p:spPr>
+        <p:txBody>
+          <a:bodyPr wrap="square" lIns="0" tIns="0" rIns="0" bIns="0" rtlCol="0" anchor="ctr"/>
+          <a:lstStyle/>
+          <a:p>
+            <a:pPr algn="l" indent="0" marL="0">
+              <a:lnSpc>
+                <a:spcPct val="105000"/>
+              </a:lnSpc>
+              <a:buNone/>
+            </a:pPr>
+            <a:r>
+              <a:rPr lang="en-US" sz="1500" dirty="0">
+                <a:solidFill>
+                  <a:srgbClr val="FBD8DF"/>
+                </a:solidFill>
+                <a:latin typeface="Calibri" pitchFamily="34" charset="0"/>
+                <a:ea typeface="Calibri" pitchFamily="34" charset="-122"/>
+                <a:cs typeface="Calibri" pitchFamily="34" charset="-120"/>
+              </a:rPr>
+              <a:t>Its main danger is thromboembolic stroke — always assess stroke risk (CHA₂DS₂-VASc).</a:t>
+            </a:r>
+            <a:endParaRPr lang="en-US" sz="1500" dirty="0"/>
+          </a:p>
+        </p:txBody>
+      </p:sp>
+      <p:sp>
+        <p:nvSpPr>
+          <p:cNvPr id="17" name="Shape 10"/>
+          <p:cNvSpPr/>
+          <p:nvPr/>
+        </p:nvSpPr>
+        <p:spPr>
+          <a:xfrm>
+            <a:off x="713232" y="4242816"/>
+            <a:ext cx="292608" cy="292608"/>
+          </a:xfrm>
+          <a:prstGeom prst="ellipse">
+            <a:avLst/>
+          </a:prstGeom>
+          <a:solidFill>
+            <a:srgbClr val="A4133C"/>
+          </a:solidFill>
+          <a:ln/>
+        </p:spPr>
+      </p:sp>
+      <p:pic>
+        <p:nvPicPr>
+          <p:cNvPr id="18" name="Image 5" descr="preencoded.png">    </p:cNvPr>
+          <p:cNvPicPr>
+            <a:picLocks noChangeAspect="1"/>
+          </p:cNvPicPr>
+          <p:nvPr/>
+        </p:nvPicPr>
+        <p:blipFill>
+          <a:blip r:embed="rId6"/>
+          <a:stretch>
+            <a:fillRect/>
+          </a:stretch>
+        </p:blipFill>
+        <p:spPr>
+          <a:xfrm>
+            <a:off x="777240" y="4306824"/>
+            <a:ext cx="164592" cy="164592"/>
+          </a:xfrm>
+          <a:prstGeom prst="rect">
+            <a:avLst/>
+          </a:prstGeom>
+        </p:spPr>
+      </p:pic>
+      <p:sp>
+        <p:nvSpPr>
+          <p:cNvPr id="19" name="Text 11"/>
+          <p:cNvSpPr/>
+          <p:nvPr/>
+        </p:nvSpPr>
+        <p:spPr>
+          <a:xfrm>
+            <a:off x="1188720" y="4224528"/>
+            <a:ext cx="10058400" cy="502920"/>
+          </a:xfrm>
+          <a:prstGeom prst="rect">
+            <a:avLst/>
+          </a:prstGeom>
+          <a:noFill/>
+          <a:ln/>
+        </p:spPr>
+        <p:txBody>
+          <a:bodyPr wrap="square" lIns="0" tIns="0" rIns="0" bIns="0" rtlCol="0" anchor="ctr"/>
+          <a:lstStyle/>
+          <a:p>
+            <a:pPr algn="l" indent="0" marL="0">
+              <a:lnSpc>
+                <a:spcPct val="105000"/>
+              </a:lnSpc>
+              <a:buNone/>
+            </a:pPr>
+            <a:r>
+              <a:rPr lang="en-US" sz="1500" dirty="0">
+                <a:solidFill>
+                  <a:srgbClr val="FBD8DF"/>
+                </a:solidFill>
+                <a:latin typeface="Calibri" pitchFamily="34" charset="0"/>
+                <a:ea typeface="Calibri" pitchFamily="34" charset="-122"/>
+                <a:cs typeface="Calibri" pitchFamily="34" charset="-120"/>
+              </a:rPr>
+              <a:t>Differentials: atrial flutter, multifocal atrial tachycardia, frequent PACs, SVT, pre-excited AF / VT.</a:t>
+            </a:r>
+            <a:endParaRPr lang="en-US" sz="1500" dirty="0"/>
+          </a:p>
+        </p:txBody>
+      </p:sp>
+      <p:sp>
+        <p:nvSpPr>
+          <p:cNvPr id="20" name="Shape 12"/>
+          <p:cNvSpPr/>
+          <p:nvPr/>
+        </p:nvSpPr>
+        <p:spPr>
+          <a:xfrm>
+            <a:off x="713232" y="4791456"/>
+            <a:ext cx="292608" cy="292608"/>
+          </a:xfrm>
+          <a:prstGeom prst="ellipse">
+            <a:avLst/>
+          </a:prstGeom>
+          <a:solidFill>
+            <a:srgbClr val="A4133C"/>
+          </a:solidFill>
+          <a:ln/>
+        </p:spPr>
+      </p:sp>
+      <p:pic>
+        <p:nvPicPr>
+          <p:cNvPr id="21" name="Image 6" descr="preencoded.png">    </p:cNvPr>
+          <p:cNvPicPr>
+            <a:picLocks noChangeAspect="1"/>
+          </p:cNvPicPr>
+          <p:nvPr/>
+        </p:nvPicPr>
+        <p:blipFill>
+          <a:blip r:embed="rId7"/>
+          <a:stretch>
+            <a:fillRect/>
+          </a:stretch>
+        </p:blipFill>
+        <p:spPr>
+          <a:xfrm>
+            <a:off x="777240" y="4855464"/>
+            <a:ext cx="164592" cy="164592"/>
+          </a:xfrm>
+          <a:prstGeom prst="rect">
+            <a:avLst/>
+          </a:prstGeom>
+        </p:spPr>
+      </p:pic>
+      <p:sp>
+        <p:nvSpPr>
+          <p:cNvPr id="22" name="Text 13"/>
+          <p:cNvSpPr/>
+          <p:nvPr/>
+        </p:nvSpPr>
+        <p:spPr>
+          <a:xfrm>
+            <a:off x="1188720" y="4773168"/>
+            <a:ext cx="10058400" cy="502920"/>
+          </a:xfrm>
+          <a:prstGeom prst="rect">
+            <a:avLst/>
+          </a:prstGeom>
+          <a:noFill/>
+          <a:ln/>
+        </p:spPr>
+        <p:txBody>
+          <a:bodyPr wrap="square" lIns="0" tIns="0" rIns="0" bIns="0" rtlCol="0" anchor="ctr"/>
+          <a:lstStyle/>
+          <a:p>
+            <a:pPr algn="l" indent="0" marL="0">
+              <a:lnSpc>
+                <a:spcPct val="105000"/>
+              </a:lnSpc>
+              <a:buNone/>
+            </a:pPr>
+            <a:r>
+              <a:rPr lang="en-US" sz="1500" dirty="0">
+                <a:solidFill>
+                  <a:srgbClr val="FBD8DF"/>
+                </a:solidFill>
+                <a:latin typeface="Calibri" pitchFamily="34" charset="0"/>
+                <a:ea typeface="Calibri" pitchFamily="34" charset="-122"/>
+                <a:cs typeface="Calibri" pitchFamily="34" charset="-120"/>
+              </a:rPr>
+              <a:t>Manage with the ABC pathway: Anticoagulation, Better symptom control, Comorbidities.</a:t>
+            </a:r>
+            <a:endParaRPr lang="en-US" sz="1500" dirty="0"/>
+          </a:p>
+        </p:txBody>
+      </p:sp>
+      <p:sp>
+        <p:nvSpPr>
+          <p:cNvPr id="23" name="Shape 14"/>
+          <p:cNvSpPr/>
+          <p:nvPr/>
+        </p:nvSpPr>
+        <p:spPr>
+          <a:xfrm>
+            <a:off x="713232" y="5340096"/>
+            <a:ext cx="292608" cy="292608"/>
+          </a:xfrm>
+          <a:prstGeom prst="ellipse">
+            <a:avLst/>
+          </a:prstGeom>
+          <a:solidFill>
+            <a:srgbClr val="A4133C"/>
+          </a:solidFill>
+          <a:ln/>
+        </p:spPr>
+      </p:sp>
+      <p:pic>
+        <p:nvPicPr>
+          <p:cNvPr id="24" name="Image 7" descr="preencoded.png">    </p:cNvPr>
+          <p:cNvPicPr>
+            <a:picLocks noChangeAspect="1"/>
+          </p:cNvPicPr>
+          <p:nvPr/>
+        </p:nvPicPr>
+        <p:blipFill>
+          <a:blip r:embed="rId8"/>
+          <a:stretch>
+            <a:fillRect/>
+          </a:stretch>
+        </p:blipFill>
+        <p:spPr>
+          <a:xfrm>
+            <a:off x="777240" y="5404104"/>
+            <a:ext cx="164592" cy="164592"/>
+          </a:xfrm>
+          <a:prstGeom prst="rect">
+            <a:avLst/>
+          </a:prstGeom>
+        </p:spPr>
+      </p:pic>
+      <p:sp>
+        <p:nvSpPr>
+          <p:cNvPr id="25" name="Text 15"/>
+          <p:cNvSpPr/>
+          <p:nvPr/>
+        </p:nvSpPr>
+        <p:spPr>
+          <a:xfrm>
+            <a:off x="1188720" y="5321808"/>
+            <a:ext cx="10058400" cy="502920"/>
+          </a:xfrm>
+          <a:prstGeom prst="rect">
+            <a:avLst/>
+          </a:prstGeom>
+          <a:noFill/>
+          <a:ln/>
+        </p:spPr>
+        <p:txBody>
+          <a:bodyPr wrap="square" lIns="0" tIns="0" rIns="0" bIns="0" rtlCol="0" anchor="ctr"/>
+          <a:lstStyle/>
+          <a:p>
+            <a:pPr algn="l" indent="0" marL="0">
+              <a:lnSpc>
+                <a:spcPct val="105000"/>
+              </a:lnSpc>
+              <a:buNone/>
+            </a:pPr>
+            <a:r>
+              <a:rPr lang="en-US" sz="1500" dirty="0">
+                <a:solidFill>
+                  <a:srgbClr val="FBD8DF"/>
+                </a:solidFill>
+                <a:latin typeface="Calibri" pitchFamily="34" charset="0"/>
+                <a:ea typeface="Calibri" pitchFamily="34" charset="-122"/>
+                <a:cs typeface="Calibri" pitchFamily="34" charset="-120"/>
+              </a:rPr>
+              <a:t>In pregnancy: LMWH is the anticoagulant of choice — avoid warfarin and DOACs.</a:t>
+            </a:r>
+            <a:endParaRPr lang="en-US" sz="1500" dirty="0"/>
+          </a:p>
+        </p:txBody>
+      </p:sp>
+      <p:sp>
+        <p:nvSpPr>
+          <p:cNvPr id="26" name="Text 16"/>
+          <p:cNvSpPr/>
+          <p:nvPr/>
+        </p:nvSpPr>
+        <p:spPr>
+          <a:xfrm>
+            <a:off x="11277295" y="6355080"/>
+            <a:ext cx="548640" cy="320040"/>
+          </a:xfrm>
+          <a:prstGeom prst="rect">
+            <a:avLst/>
+          </a:prstGeom>
+          <a:noFill/>
+          <a:ln/>
+        </p:spPr>
+        <p:txBody>
+          <a:bodyPr wrap="square" rtlCol="0" anchor="t"/>
+          <a:lstStyle/>
+          <a:p>
+            <a:pPr algn="r" indent="0" marL="0">
+              <a:buNone/>
+            </a:pPr>
+            <a:r>
+              <a:rPr lang="en-US" sz="1100" b="1" dirty="0">
+                <a:solidFill>
+                  <a:srgbClr val="FBD8DF"/>
+                </a:solidFill>
+                <a:latin typeface="Calibri" pitchFamily="34" charset="0"/>
+                <a:ea typeface="Calibri" pitchFamily="34" charset="-122"/>
+                <a:cs typeface="Calibri" pitchFamily="34" charset="-120"/>
+              </a:rPr>
+              <a:t>20</a:t>
+            </a:r>
+            <a:endParaRPr lang="en-US" sz="1100" dirty="0"/>
+          </a:p>
+        </p:txBody>
+      </p:sp>
+      <p:sp>
+        <p:nvSpPr>
+          <p:cNvPr id="27" name="Text 17"/>
+          <p:cNvSpPr/>
+          <p:nvPr/>
+        </p:nvSpPr>
+        <p:spPr>
+          <a:xfrm>
+            <a:off x="502920" y="6355080"/>
+            <a:ext cx="7315200" cy="320040"/>
+          </a:xfrm>
+          <a:prstGeom prst="rect">
+            <a:avLst/>
+          </a:prstGeom>
+          <a:noFill/>
+          <a:ln/>
+        </p:spPr>
+        <p:txBody>
+          <a:bodyPr wrap="square" rtlCol="0" anchor="t"/>
+          <a:lstStyle/>
+          <a:p>
+            <a:pPr algn="l" indent="0" marL="0">
+              <a:buNone/>
+            </a:pPr>
+            <a:r>
+              <a:rPr lang="en-US" sz="900" dirty="0">
+                <a:solidFill>
+                  <a:srgbClr val="FBD8DF"/>
+                </a:solidFill>
+                <a:latin typeface="Calibri" pitchFamily="34" charset="0"/>
+                <a:ea typeface="Calibri" pitchFamily="34" charset="-122"/>
+                <a:cs typeface="Calibri" pitchFamily="34" charset="-120"/>
+              </a:rPr>
+              <a:t>Atrial Fibrillation — Clinical Topic Review</a:t>
+            </a:r>
+            <a:endParaRPr lang="en-US" sz="900" dirty="0"/>
+          </a:p>
+        </p:txBody>
+      </p:sp>
+    </p:spTree>
+  </p:cSld>
+  <p:clrMapOvr>
+    <a:masterClrMapping/>
+  </p:clrMapOvr>
+</p:sld>
+</file>
+
+<file path=ppt/slides/slide21.xml><?xml version="1.0" encoding="utf-8"?>
+<p:sld xmlns:a="http://schemas.openxmlformats.org/drawingml/2006/main" xmlns:r="http://schemas.openxmlformats.org/officeDocument/2006/relationships" xmlns:p="http://schemas.openxmlformats.org/presentationml/2006/main">
+  <p:cSld name="Slide 21">
     <p:bg>
       <p:bgPr>
         <a:solidFill>

</xml_diff>

<commit_message>
Beautify CVS slide; add pericarditis to AF causes
- CVS slide: vivid crimson icon badges with clean header+bullets layout;
  inspection updated to 'shape of precordium normal; rest not performed
  due to limited exposure'
- Causes & Risk Factors: add Pericarditis to cardiac causes; rebalance
  both panels to 7 items each

Co-Authored-By: Claude Opus 4.8 <noreply@anthropic.com>
Claude-Session: https://claude.ai/code/session_01S7QW8AwqyMReKwuqyBkBBv
</commit_message>
<xml_diff>
--- a/presentations/Atrial-Fibrillation-Topic-Review.pptx
+++ b/presentations/Atrial-Fibrillation-Topic-Review.pptx
@@ -19919,7 +19919,7 @@
         </p:nvSpPr>
         <p:spPr>
           <a:xfrm>
-            <a:off x="868680" y="2103120"/>
+            <a:off x="868680" y="2084832"/>
             <a:ext cx="4800600" cy="320040"/>
           </a:xfrm>
           <a:prstGeom prst="rect">
@@ -19958,12 +19958,12 @@
         </p:nvSpPr>
         <p:spPr>
           <a:xfrm>
-            <a:off x="868680" y="2606040"/>
-            <a:ext cx="2263140" cy="868680"/>
+            <a:off x="868680" y="2542032"/>
+            <a:ext cx="2263140" cy="713232"/>
           </a:xfrm>
           <a:prstGeom prst="roundRect">
             <a:avLst>
-              <a:gd name="adj" fmla="val 9474"/>
+              <a:gd name="adj" fmla="val 11538"/>
             </a:avLst>
           </a:prstGeom>
           <a:solidFill>
@@ -19985,8 +19985,8 @@
         </p:nvSpPr>
         <p:spPr>
           <a:xfrm>
-            <a:off x="1014984" y="2788920"/>
-            <a:ext cx="502920" cy="502920"/>
+            <a:off x="1005840" y="2688336"/>
+            <a:ext cx="438912" cy="438912"/>
           </a:xfrm>
           <a:prstGeom prst="ellipse">
             <a:avLst/>
@@ -20013,8 +20013,8 @@
         </p:blipFill>
         <p:spPr>
           <a:xfrm>
-            <a:off x="1133856" y="2907792"/>
-            <a:ext cx="265176" cy="265176"/>
+            <a:off x="1115568" y="2793492"/>
+            <a:ext cx="228600" cy="228600"/>
           </a:xfrm>
           <a:prstGeom prst="rect">
             <a:avLst/>
@@ -20029,8 +20029,8 @@
         </p:nvSpPr>
         <p:spPr>
           <a:xfrm>
-            <a:off x="1618488" y="2606040"/>
-            <a:ext cx="1421892" cy="868680"/>
+            <a:off x="1545336" y="2542032"/>
+            <a:ext cx="1495044" cy="713232"/>
           </a:xfrm>
           <a:prstGeom prst="rect">
             <a:avLst/>
@@ -20044,12 +20044,12 @@
           <a:p>
             <a:pPr algn="l" indent="0" marL="0">
               <a:lnSpc>
-                <a:spcPct val="102000"/>
+                <a:spcPct val="100000"/>
               </a:lnSpc>
               <a:buNone/>
             </a:pPr>
             <a:r>
-              <a:rPr lang="en-US" sz="1300" b="1" dirty="0">
+              <a:rPr lang="en-US" sz="1250" b="1" dirty="0">
                 <a:solidFill>
                   <a:srgbClr val="2B2B33"/>
                 </a:solidFill>
@@ -20059,7 +20059,7 @@
               </a:rPr>
               <a:t>Hypertension</a:t>
             </a:r>
-            <a:endParaRPr lang="en-US" sz="1300" dirty="0"/>
+            <a:endParaRPr lang="en-US" sz="1250" dirty="0"/>
           </a:p>
         </p:txBody>
       </p:sp>
@@ -20071,12 +20071,12 @@
         </p:nvSpPr>
         <p:spPr>
           <a:xfrm>
-            <a:off x="3406140" y="2606040"/>
-            <a:ext cx="2263140" cy="868680"/>
+            <a:off x="3406140" y="2542032"/>
+            <a:ext cx="2263140" cy="713232"/>
           </a:xfrm>
           <a:prstGeom prst="roundRect">
             <a:avLst>
-              <a:gd name="adj" fmla="val 9474"/>
+              <a:gd name="adj" fmla="val 11538"/>
             </a:avLst>
           </a:prstGeom>
           <a:solidFill>
@@ -20098,8 +20098,8 @@
         </p:nvSpPr>
         <p:spPr>
           <a:xfrm>
-            <a:off x="3552444" y="2788920"/>
-            <a:ext cx="502920" cy="502920"/>
+            <a:off x="3543300" y="2688336"/>
+            <a:ext cx="438912" cy="438912"/>
           </a:xfrm>
           <a:prstGeom prst="ellipse">
             <a:avLst/>
@@ -20126,8 +20126,8 @@
         </p:blipFill>
         <p:spPr>
           <a:xfrm>
-            <a:off x="3671316" y="2907792"/>
-            <a:ext cx="265176" cy="265176"/>
+            <a:off x="3653028" y="2793492"/>
+            <a:ext cx="228600" cy="228600"/>
           </a:xfrm>
           <a:prstGeom prst="rect">
             <a:avLst/>
@@ -20142,8 +20142,8 @@
         </p:nvSpPr>
         <p:spPr>
           <a:xfrm>
-            <a:off x="4155948" y="2606040"/>
-            <a:ext cx="1421892" cy="868680"/>
+            <a:off x="4082796" y="2542032"/>
+            <a:ext cx="1495044" cy="713232"/>
           </a:xfrm>
           <a:prstGeom prst="rect">
             <a:avLst/>
@@ -20157,12 +20157,12 @@
           <a:p>
             <a:pPr algn="l" indent="0" marL="0">
               <a:lnSpc>
-                <a:spcPct val="102000"/>
+                <a:spcPct val="100000"/>
               </a:lnSpc>
               <a:buNone/>
             </a:pPr>
             <a:r>
-              <a:rPr lang="en-US" sz="1300" b="1" dirty="0">
+              <a:rPr lang="en-US" sz="1250" b="1" dirty="0">
                 <a:solidFill>
                   <a:srgbClr val="2B2B33"/>
                 </a:solidFill>
@@ -20172,7 +20172,7 @@
               </a:rPr>
               <a:t>Ischaemic heart disease</a:t>
             </a:r>
-            <a:endParaRPr lang="en-US" sz="1300" dirty="0"/>
+            <a:endParaRPr lang="en-US" sz="1250" dirty="0"/>
           </a:p>
         </p:txBody>
       </p:sp>
@@ -20184,12 +20184,12 @@
         </p:nvSpPr>
         <p:spPr>
           <a:xfrm>
-            <a:off x="868680" y="3630168"/>
-            <a:ext cx="2263140" cy="868680"/>
+            <a:off x="868680" y="3364992"/>
+            <a:ext cx="2263140" cy="713232"/>
           </a:xfrm>
           <a:prstGeom prst="roundRect">
             <a:avLst>
-              <a:gd name="adj" fmla="val 9474"/>
+              <a:gd name="adj" fmla="val 11538"/>
             </a:avLst>
           </a:prstGeom>
           <a:solidFill>
@@ -20211,8 +20211,8 @@
         </p:nvSpPr>
         <p:spPr>
           <a:xfrm>
-            <a:off x="1014984" y="3813048"/>
-            <a:ext cx="502920" cy="502920"/>
+            <a:off x="1005840" y="3511296"/>
+            <a:ext cx="438912" cy="438912"/>
           </a:xfrm>
           <a:prstGeom prst="ellipse">
             <a:avLst/>
@@ -20239,8 +20239,8 @@
         </p:blipFill>
         <p:spPr>
           <a:xfrm>
-            <a:off x="1133856" y="3931920"/>
-            <a:ext cx="265176" cy="265176"/>
+            <a:off x="1115568" y="3616452"/>
+            <a:ext cx="228600" cy="228600"/>
           </a:xfrm>
           <a:prstGeom prst="rect">
             <a:avLst/>
@@ -20255,8 +20255,8 @@
         </p:nvSpPr>
         <p:spPr>
           <a:xfrm>
-            <a:off x="1618488" y="3630168"/>
-            <a:ext cx="1421892" cy="868680"/>
+            <a:off x="1545336" y="3364992"/>
+            <a:ext cx="1495044" cy="713232"/>
           </a:xfrm>
           <a:prstGeom prst="rect">
             <a:avLst/>
@@ -20270,12 +20270,12 @@
           <a:p>
             <a:pPr algn="l" indent="0" marL="0">
               <a:lnSpc>
-                <a:spcPct val="102000"/>
+                <a:spcPct val="100000"/>
               </a:lnSpc>
               <a:buNone/>
             </a:pPr>
             <a:r>
-              <a:rPr lang="en-US" sz="1300" b="1" dirty="0">
+              <a:rPr lang="en-US" sz="1250" b="1" dirty="0">
                 <a:solidFill>
                   <a:srgbClr val="2B2B33"/>
                 </a:solidFill>
@@ -20285,7 +20285,7 @@
               </a:rPr>
               <a:t>Valvular disease (mitral stenosis)</a:t>
             </a:r>
-            <a:endParaRPr lang="en-US" sz="1300" dirty="0"/>
+            <a:endParaRPr lang="en-US" sz="1250" dirty="0"/>
           </a:p>
         </p:txBody>
       </p:sp>
@@ -20297,12 +20297,12 @@
         </p:nvSpPr>
         <p:spPr>
           <a:xfrm>
-            <a:off x="3406140" y="3630168"/>
-            <a:ext cx="2263140" cy="868680"/>
+            <a:off x="3406140" y="3364992"/>
+            <a:ext cx="2263140" cy="713232"/>
           </a:xfrm>
           <a:prstGeom prst="roundRect">
             <a:avLst>
-              <a:gd name="adj" fmla="val 9474"/>
+              <a:gd name="adj" fmla="val 11538"/>
             </a:avLst>
           </a:prstGeom>
           <a:solidFill>
@@ -20324,8 +20324,8 @@
         </p:nvSpPr>
         <p:spPr>
           <a:xfrm>
-            <a:off x="3552444" y="3813048"/>
-            <a:ext cx="502920" cy="502920"/>
+            <a:off x="3543300" y="3511296"/>
+            <a:ext cx="438912" cy="438912"/>
           </a:xfrm>
           <a:prstGeom prst="ellipse">
             <a:avLst/>
@@ -20352,8 +20352,8 @@
         </p:blipFill>
         <p:spPr>
           <a:xfrm>
-            <a:off x="3671316" y="3931920"/>
-            <a:ext cx="265176" cy="265176"/>
+            <a:off x="3653028" y="3616452"/>
+            <a:ext cx="228600" cy="228600"/>
           </a:xfrm>
           <a:prstGeom prst="rect">
             <a:avLst/>
@@ -20368,8 +20368,8 @@
         </p:nvSpPr>
         <p:spPr>
           <a:xfrm>
-            <a:off x="4155948" y="3630168"/>
-            <a:ext cx="1421892" cy="868680"/>
+            <a:off x="4082796" y="3364992"/>
+            <a:ext cx="1495044" cy="713232"/>
           </a:xfrm>
           <a:prstGeom prst="rect">
             <a:avLst/>
@@ -20383,12 +20383,12 @@
           <a:p>
             <a:pPr algn="l" indent="0" marL="0">
               <a:lnSpc>
-                <a:spcPct val="102000"/>
+                <a:spcPct val="100000"/>
               </a:lnSpc>
               <a:buNone/>
             </a:pPr>
             <a:r>
-              <a:rPr lang="en-US" sz="1300" b="1" dirty="0">
+              <a:rPr lang="en-US" sz="1250" b="1" dirty="0">
                 <a:solidFill>
                   <a:srgbClr val="2B2B33"/>
                 </a:solidFill>
@@ -20398,7 +20398,7 @@
               </a:rPr>
               <a:t>Heart failure</a:t>
             </a:r>
-            <a:endParaRPr lang="en-US" sz="1300" dirty="0"/>
+            <a:endParaRPr lang="en-US" sz="1250" dirty="0"/>
           </a:p>
         </p:txBody>
       </p:sp>
@@ -20410,12 +20410,12 @@
         </p:nvSpPr>
         <p:spPr>
           <a:xfrm>
-            <a:off x="868680" y="4654296"/>
-            <a:ext cx="2263140" cy="868680"/>
+            <a:off x="868680" y="4187952"/>
+            <a:ext cx="2263140" cy="713232"/>
           </a:xfrm>
           <a:prstGeom prst="roundRect">
             <a:avLst>
-              <a:gd name="adj" fmla="val 9474"/>
+              <a:gd name="adj" fmla="val 11538"/>
             </a:avLst>
           </a:prstGeom>
           <a:solidFill>
@@ -20437,8 +20437,8 @@
         </p:nvSpPr>
         <p:spPr>
           <a:xfrm>
-            <a:off x="1014984" y="4837176"/>
-            <a:ext cx="502920" cy="502920"/>
+            <a:off x="1005840" y="4334256"/>
+            <a:ext cx="438912" cy="438912"/>
           </a:xfrm>
           <a:prstGeom prst="ellipse">
             <a:avLst/>
@@ -20465,8 +20465,8 @@
         </p:blipFill>
         <p:spPr>
           <a:xfrm>
-            <a:off x="1133856" y="4956048"/>
-            <a:ext cx="265176" cy="265176"/>
+            <a:off x="1115568" y="4439412"/>
+            <a:ext cx="228600" cy="228600"/>
           </a:xfrm>
           <a:prstGeom prst="rect">
             <a:avLst/>
@@ -20481,8 +20481,8 @@
         </p:nvSpPr>
         <p:spPr>
           <a:xfrm>
-            <a:off x="1618488" y="4654296"/>
-            <a:ext cx="1421892" cy="868680"/>
+            <a:off x="1545336" y="4187952"/>
+            <a:ext cx="1495044" cy="713232"/>
           </a:xfrm>
           <a:prstGeom prst="rect">
             <a:avLst/>
@@ -20496,12 +20496,12 @@
           <a:p>
             <a:pPr algn="l" indent="0" marL="0">
               <a:lnSpc>
-                <a:spcPct val="102000"/>
+                <a:spcPct val="100000"/>
               </a:lnSpc>
               <a:buNone/>
             </a:pPr>
             <a:r>
-              <a:rPr lang="en-US" sz="1300" b="1" dirty="0">
+              <a:rPr lang="en-US" sz="1250" b="1" dirty="0">
                 <a:solidFill>
                   <a:srgbClr val="2B2B33"/>
                 </a:solidFill>
@@ -20511,7 +20511,7 @@
               </a:rPr>
               <a:t>Cardiomyopathy</a:t>
             </a:r>
-            <a:endParaRPr lang="en-US" sz="1300" dirty="0"/>
+            <a:endParaRPr lang="en-US" sz="1250" dirty="0"/>
           </a:p>
         </p:txBody>
       </p:sp>
@@ -20523,12 +20523,12 @@
         </p:nvSpPr>
         <p:spPr>
           <a:xfrm>
-            <a:off x="3406140" y="4654296"/>
-            <a:ext cx="2263140" cy="868680"/>
+            <a:off x="3406140" y="4187952"/>
+            <a:ext cx="2263140" cy="713232"/>
           </a:xfrm>
           <a:prstGeom prst="roundRect">
             <a:avLst>
-              <a:gd name="adj" fmla="val 9474"/>
+              <a:gd name="adj" fmla="val 11538"/>
             </a:avLst>
           </a:prstGeom>
           <a:solidFill>
@@ -20550,8 +20550,8 @@
         </p:nvSpPr>
         <p:spPr>
           <a:xfrm>
-            <a:off x="3552444" y="4837176"/>
-            <a:ext cx="502920" cy="502920"/>
+            <a:off x="3543300" y="4334256"/>
+            <a:ext cx="438912" cy="438912"/>
           </a:xfrm>
           <a:prstGeom prst="ellipse">
             <a:avLst/>
@@ -20578,8 +20578,8 @@
         </p:blipFill>
         <p:spPr>
           <a:xfrm>
-            <a:off x="3671316" y="4956048"/>
-            <a:ext cx="265176" cy="265176"/>
+            <a:off x="3653028" y="4439412"/>
+            <a:ext cx="228600" cy="228600"/>
           </a:xfrm>
           <a:prstGeom prst="rect">
             <a:avLst/>
@@ -20594,8 +20594,8 @@
         </p:nvSpPr>
         <p:spPr>
           <a:xfrm>
-            <a:off x="4155948" y="4654296"/>
-            <a:ext cx="1421892" cy="868680"/>
+            <a:off x="4082796" y="4187952"/>
+            <a:ext cx="1495044" cy="713232"/>
           </a:xfrm>
           <a:prstGeom prst="rect">
             <a:avLst/>
@@ -20609,12 +20609,12 @@
           <a:p>
             <a:pPr algn="l" indent="0" marL="0">
               <a:lnSpc>
-                <a:spcPct val="102000"/>
+                <a:spcPct val="100000"/>
               </a:lnSpc>
               <a:buNone/>
             </a:pPr>
             <a:r>
-              <a:rPr lang="en-US" sz="1300" b="1" dirty="0">
+              <a:rPr lang="en-US" sz="1250" b="1" dirty="0">
                 <a:solidFill>
                   <a:srgbClr val="2B2B33"/>
                 </a:solidFill>
@@ -20622,15 +20622,128 @@
                 <a:ea typeface="Calibri" pitchFamily="34" charset="-122"/>
                 <a:cs typeface="Calibri" pitchFamily="34" charset="-120"/>
               </a:rPr>
+              <a:t>Pericarditis</a:t>
+            </a:r>
+            <a:endParaRPr lang="en-US" sz="1250" dirty="0"/>
+          </a:p>
+        </p:txBody>
+      </p:sp>
+      <p:sp>
+        <p:nvSpPr>
+          <p:cNvPr id="32" name="Shape 23"/>
+          <p:cNvSpPr/>
+          <p:nvPr/>
+        </p:nvSpPr>
+        <p:spPr>
+          <a:xfrm>
+            <a:off x="868680" y="5010912"/>
+            <a:ext cx="2263140" cy="713232"/>
+          </a:xfrm>
+          <a:prstGeom prst="roundRect">
+            <a:avLst>
+              <a:gd name="adj" fmla="val 11538"/>
+            </a:avLst>
+          </a:prstGeom>
+          <a:solidFill>
+            <a:srgbClr val="FFFFFF"/>
+          </a:solidFill>
+          <a:ln w="12700">
+            <a:solidFill>
+              <a:srgbClr val="FBD8DF"/>
+            </a:solidFill>
+            <a:prstDash val="solid"/>
+          </a:ln>
+        </p:spPr>
+      </p:sp>
+      <p:sp>
+        <p:nvSpPr>
+          <p:cNvPr id="33" name="Shape 24"/>
+          <p:cNvSpPr/>
+          <p:nvPr/>
+        </p:nvSpPr>
+        <p:spPr>
+          <a:xfrm>
+            <a:off x="1005840" y="5157216"/>
+            <a:ext cx="438912" cy="438912"/>
+          </a:xfrm>
+          <a:prstGeom prst="ellipse">
+            <a:avLst/>
+          </a:prstGeom>
+          <a:solidFill>
+            <a:srgbClr val="FFF0F3"/>
+          </a:solidFill>
+          <a:ln/>
+        </p:spPr>
+      </p:sp>
+      <p:pic>
+        <p:nvPicPr>
+          <p:cNvPr id="34" name="Image 7" descr="preencoded.png">    </p:cNvPr>
+          <p:cNvPicPr>
+            <a:picLocks noChangeAspect="1"/>
+          </p:cNvPicPr>
+          <p:nvPr/>
+        </p:nvPicPr>
+        <p:blipFill>
+          <a:blip r:embed="rId8"/>
+          <a:stretch>
+            <a:fillRect/>
+          </a:stretch>
+        </p:blipFill>
+        <p:spPr>
+          <a:xfrm>
+            <a:off x="1115568" y="5262372"/>
+            <a:ext cx="228600" cy="228600"/>
+          </a:xfrm>
+          <a:prstGeom prst="rect">
+            <a:avLst/>
+          </a:prstGeom>
+        </p:spPr>
+      </p:pic>
+      <p:sp>
+        <p:nvSpPr>
+          <p:cNvPr id="35" name="Text 25"/>
+          <p:cNvSpPr/>
+          <p:nvPr/>
+        </p:nvSpPr>
+        <p:spPr>
+          <a:xfrm>
+            <a:off x="1545336" y="5010912"/>
+            <a:ext cx="1495044" cy="713232"/>
+          </a:xfrm>
+          <a:prstGeom prst="rect">
+            <a:avLst/>
+          </a:prstGeom>
+          <a:noFill/>
+          <a:ln/>
+        </p:spPr>
+        <p:txBody>
+          <a:bodyPr wrap="square" lIns="0" tIns="0" rIns="0" bIns="0" rtlCol="0" anchor="ctr"/>
+          <a:lstStyle/>
+          <a:p>
+            <a:pPr algn="l" indent="0" marL="0">
+              <a:lnSpc>
+                <a:spcPct val="100000"/>
+              </a:lnSpc>
+              <a:buNone/>
+            </a:pPr>
+            <a:r>
+              <a:rPr lang="en-US" sz="1250" b="1" dirty="0">
+                <a:solidFill>
+                  <a:srgbClr val="2B2B33"/>
+                </a:solidFill>
+                <a:latin typeface="Calibri" pitchFamily="34" charset="0"/>
+                <a:ea typeface="Calibri" pitchFamily="34" charset="-122"/>
+                <a:cs typeface="Calibri" pitchFamily="34" charset="-120"/>
+              </a:rPr>
               <a:t>Post-cardiac surgery</a:t>
             </a:r>
-            <a:endParaRPr lang="en-US" sz="1300" dirty="0"/>
-          </a:p>
-        </p:txBody>
-      </p:sp>
-      <p:sp>
-        <p:nvSpPr>
-          <p:cNvPr id="32" name="Shape 23"/>
+            <a:endParaRPr lang="en-US" sz="1250" dirty="0"/>
+          </a:p>
+        </p:txBody>
+      </p:sp>
+      <p:sp>
+        <p:nvSpPr>
+          <p:cNvPr id="36" name="Shape 26"/>
           <p:cNvSpPr/>
           <p:nvPr/>
         </p:nvSpPr>
@@ -20664,13 +20777,13 @@
       </p:sp>
       <p:sp>
         <p:nvSpPr>
-          <p:cNvPr id="33" name="Text 24"/>
-          <p:cNvSpPr/>
-          <p:nvPr/>
-        </p:nvSpPr>
-        <p:spPr>
-          <a:xfrm>
-            <a:off x="6519672" y="2103120"/>
+          <p:cNvPr id="37" name="Text 27"/>
+          <p:cNvSpPr/>
+          <p:nvPr/>
+        </p:nvSpPr>
+        <p:spPr>
+          <a:xfrm>
+            <a:off x="6519672" y="2084832"/>
             <a:ext cx="4800600" cy="320040"/>
           </a:xfrm>
           <a:prstGeom prst="rect">
@@ -20703,18 +20816,18 @@
       </p:sp>
       <p:sp>
         <p:nvSpPr>
-          <p:cNvPr id="34" name="Shape 25"/>
-          <p:cNvSpPr/>
-          <p:nvPr/>
-        </p:nvSpPr>
-        <p:spPr>
-          <a:xfrm>
-            <a:off x="6519672" y="2606040"/>
-            <a:ext cx="2263140" cy="868680"/>
+          <p:cNvPr id="38" name="Shape 28"/>
+          <p:cNvSpPr/>
+          <p:nvPr/>
+        </p:nvSpPr>
+        <p:spPr>
+          <a:xfrm>
+            <a:off x="6519672" y="2542032"/>
+            <a:ext cx="2263140" cy="713232"/>
           </a:xfrm>
           <a:prstGeom prst="roundRect">
             <a:avLst>
-              <a:gd name="adj" fmla="val 9474"/>
+              <a:gd name="adj" fmla="val 11538"/>
             </a:avLst>
           </a:prstGeom>
           <a:solidFill>
@@ -20730,14 +20843,14 @@
       </p:sp>
       <p:sp>
         <p:nvSpPr>
-          <p:cNvPr id="35" name="Shape 26"/>
-          <p:cNvSpPr/>
-          <p:nvPr/>
-        </p:nvSpPr>
-        <p:spPr>
-          <a:xfrm>
-            <a:off x="6665976" y="2788920"/>
-            <a:ext cx="502920" cy="502920"/>
+          <p:cNvPr id="39" name="Shape 29"/>
+          <p:cNvSpPr/>
+          <p:nvPr/>
+        </p:nvSpPr>
+        <p:spPr>
+          <a:xfrm>
+            <a:off x="6656832" y="2688336"/>
+            <a:ext cx="438912" cy="438912"/>
           </a:xfrm>
           <a:prstGeom prst="ellipse">
             <a:avLst/>
@@ -20750,22 +20863,22 @@
       </p:sp>
       <p:pic>
         <p:nvPicPr>
-          <p:cNvPr id="36" name="Image 7" descr="preencoded.png">    </p:cNvPr>
+          <p:cNvPr id="40" name="Image 8" descr="preencoded.png">    </p:cNvPr>
           <p:cNvPicPr>
             <a:picLocks noChangeAspect="1"/>
           </p:cNvPicPr>
           <p:nvPr/>
         </p:nvPicPr>
         <p:blipFill>
-          <a:blip r:embed="rId8"/>
+          <a:blip r:embed="rId9"/>
           <a:stretch>
             <a:fillRect/>
           </a:stretch>
         </p:blipFill>
         <p:spPr>
           <a:xfrm>
-            <a:off x="6784848" y="2907792"/>
-            <a:ext cx="265176" cy="265176"/>
+            <a:off x="6766560" y="2793492"/>
+            <a:ext cx="228600" cy="228600"/>
           </a:xfrm>
           <a:prstGeom prst="rect">
             <a:avLst/>
@@ -20774,14 +20887,14 @@
       </p:pic>
       <p:sp>
         <p:nvSpPr>
-          <p:cNvPr id="37" name="Text 27"/>
-          <p:cNvSpPr/>
-          <p:nvPr/>
-        </p:nvSpPr>
-        <p:spPr>
-          <a:xfrm>
-            <a:off x="7269480" y="2606040"/>
-            <a:ext cx="1421892" cy="868680"/>
+          <p:cNvPr id="41" name="Text 30"/>
+          <p:cNvSpPr/>
+          <p:nvPr/>
+        </p:nvSpPr>
+        <p:spPr>
+          <a:xfrm>
+            <a:off x="7196328" y="2542032"/>
+            <a:ext cx="1495044" cy="713232"/>
           </a:xfrm>
           <a:prstGeom prst="rect">
             <a:avLst/>
@@ -20795,12 +20908,12 @@
           <a:p>
             <a:pPr algn="l" indent="0" marL="0">
               <a:lnSpc>
-                <a:spcPct val="102000"/>
+                <a:spcPct val="100000"/>
               </a:lnSpc>
               <a:buNone/>
             </a:pPr>
             <a:r>
-              <a:rPr lang="en-US" sz="1300" b="1" dirty="0">
+              <a:rPr lang="en-US" sz="1250" b="1" dirty="0">
                 <a:solidFill>
                   <a:srgbClr val="2B2B33"/>
                 </a:solidFill>
@@ -20810,24 +20923,24 @@
               </a:rPr>
               <a:t>Hyperthyroidism</a:t>
             </a:r>
-            <a:endParaRPr lang="en-US" sz="1300" dirty="0"/>
-          </a:p>
-        </p:txBody>
-      </p:sp>
-      <p:sp>
-        <p:nvSpPr>
-          <p:cNvPr id="38" name="Shape 28"/>
-          <p:cNvSpPr/>
-          <p:nvPr/>
-        </p:nvSpPr>
-        <p:spPr>
-          <a:xfrm>
-            <a:off x="9057132" y="2606040"/>
-            <a:ext cx="2263140" cy="868680"/>
+            <a:endParaRPr lang="en-US" sz="1250" dirty="0"/>
+          </a:p>
+        </p:txBody>
+      </p:sp>
+      <p:sp>
+        <p:nvSpPr>
+          <p:cNvPr id="42" name="Shape 31"/>
+          <p:cNvSpPr/>
+          <p:nvPr/>
+        </p:nvSpPr>
+        <p:spPr>
+          <a:xfrm>
+            <a:off x="9057132" y="2542032"/>
+            <a:ext cx="2263140" cy="713232"/>
           </a:xfrm>
           <a:prstGeom prst="roundRect">
             <a:avLst>
-              <a:gd name="adj" fmla="val 9474"/>
+              <a:gd name="adj" fmla="val 11538"/>
             </a:avLst>
           </a:prstGeom>
           <a:solidFill>
@@ -20843,14 +20956,14 @@
       </p:sp>
       <p:sp>
         <p:nvSpPr>
-          <p:cNvPr id="39" name="Shape 29"/>
-          <p:cNvSpPr/>
-          <p:nvPr/>
-        </p:nvSpPr>
-        <p:spPr>
-          <a:xfrm>
-            <a:off x="9203436" y="2788920"/>
-            <a:ext cx="502920" cy="502920"/>
+          <p:cNvPr id="43" name="Shape 32"/>
+          <p:cNvSpPr/>
+          <p:nvPr/>
+        </p:nvSpPr>
+        <p:spPr>
+          <a:xfrm>
+            <a:off x="9194292" y="2688336"/>
+            <a:ext cx="438912" cy="438912"/>
           </a:xfrm>
           <a:prstGeom prst="ellipse">
             <a:avLst/>
@@ -20863,22 +20976,22 @@
       </p:sp>
       <p:pic>
         <p:nvPicPr>
-          <p:cNvPr id="40" name="Image 8" descr="preencoded.png">    </p:cNvPr>
+          <p:cNvPr id="44" name="Image 9" descr="preencoded.png">    </p:cNvPr>
           <p:cNvPicPr>
             <a:picLocks noChangeAspect="1"/>
           </p:cNvPicPr>
           <p:nvPr/>
         </p:nvPicPr>
         <p:blipFill>
-          <a:blip r:embed="rId9"/>
+          <a:blip r:embed="rId10"/>
           <a:stretch>
             <a:fillRect/>
           </a:stretch>
         </p:blipFill>
         <p:spPr>
           <a:xfrm>
-            <a:off x="9322308" y="2907792"/>
-            <a:ext cx="265176" cy="265176"/>
+            <a:off x="9304020" y="2793492"/>
+            <a:ext cx="228600" cy="228600"/>
           </a:xfrm>
           <a:prstGeom prst="rect">
             <a:avLst/>
@@ -20887,14 +21000,14 @@
       </p:pic>
       <p:sp>
         <p:nvSpPr>
-          <p:cNvPr id="41" name="Text 30"/>
-          <p:cNvSpPr/>
-          <p:nvPr/>
-        </p:nvSpPr>
-        <p:spPr>
-          <a:xfrm>
-            <a:off x="9806940" y="2606040"/>
-            <a:ext cx="1421892" cy="868680"/>
+          <p:cNvPr id="45" name="Text 33"/>
+          <p:cNvSpPr/>
+          <p:nvPr/>
+        </p:nvSpPr>
+        <p:spPr>
+          <a:xfrm>
+            <a:off x="9733788" y="2542032"/>
+            <a:ext cx="1495044" cy="713232"/>
           </a:xfrm>
           <a:prstGeom prst="rect">
             <a:avLst/>
@@ -20908,12 +21021,12 @@
           <a:p>
             <a:pPr algn="l" indent="0" marL="0">
               <a:lnSpc>
-                <a:spcPct val="102000"/>
+                <a:spcPct val="100000"/>
               </a:lnSpc>
               <a:buNone/>
             </a:pPr>
             <a:r>
-              <a:rPr lang="en-US" sz="1300" b="1" dirty="0">
+              <a:rPr lang="en-US" sz="1250" b="1" dirty="0">
                 <a:solidFill>
                   <a:srgbClr val="2B2B33"/>
                 </a:solidFill>
@@ -20923,24 +21036,24 @@
               </a:rPr>
               <a:t>Alcohol (“holiday heart”)</a:t>
             </a:r>
-            <a:endParaRPr lang="en-US" sz="1300" dirty="0"/>
-          </a:p>
-        </p:txBody>
-      </p:sp>
-      <p:sp>
-        <p:nvSpPr>
-          <p:cNvPr id="42" name="Shape 31"/>
-          <p:cNvSpPr/>
-          <p:nvPr/>
-        </p:nvSpPr>
-        <p:spPr>
-          <a:xfrm>
-            <a:off x="6519672" y="3630168"/>
-            <a:ext cx="2263140" cy="868680"/>
+            <a:endParaRPr lang="en-US" sz="1250" dirty="0"/>
+          </a:p>
+        </p:txBody>
+      </p:sp>
+      <p:sp>
+        <p:nvSpPr>
+          <p:cNvPr id="46" name="Shape 34"/>
+          <p:cNvSpPr/>
+          <p:nvPr/>
+        </p:nvSpPr>
+        <p:spPr>
+          <a:xfrm>
+            <a:off x="6519672" y="3364992"/>
+            <a:ext cx="2263140" cy="713232"/>
           </a:xfrm>
           <a:prstGeom prst="roundRect">
             <a:avLst>
-              <a:gd name="adj" fmla="val 9474"/>
+              <a:gd name="adj" fmla="val 11538"/>
             </a:avLst>
           </a:prstGeom>
           <a:solidFill>
@@ -20956,14 +21069,14 @@
       </p:sp>
       <p:sp>
         <p:nvSpPr>
-          <p:cNvPr id="43" name="Shape 32"/>
-          <p:cNvSpPr/>
-          <p:nvPr/>
-        </p:nvSpPr>
-        <p:spPr>
-          <a:xfrm>
-            <a:off x="6665976" y="3813048"/>
-            <a:ext cx="502920" cy="502920"/>
+          <p:cNvPr id="47" name="Shape 35"/>
+          <p:cNvSpPr/>
+          <p:nvPr/>
+        </p:nvSpPr>
+        <p:spPr>
+          <a:xfrm>
+            <a:off x="6656832" y="3511296"/>
+            <a:ext cx="438912" cy="438912"/>
           </a:xfrm>
           <a:prstGeom prst="ellipse">
             <a:avLst/>
@@ -20976,22 +21089,22 @@
       </p:sp>
       <p:pic>
         <p:nvPicPr>
-          <p:cNvPr id="44" name="Image 9" descr="preencoded.png">    </p:cNvPr>
+          <p:cNvPr id="48" name="Image 10" descr="preencoded.png">    </p:cNvPr>
           <p:cNvPicPr>
             <a:picLocks noChangeAspect="1"/>
           </p:cNvPicPr>
           <p:nvPr/>
         </p:nvPicPr>
         <p:blipFill>
-          <a:blip r:embed="rId10"/>
+          <a:blip r:embed="rId11"/>
           <a:stretch>
             <a:fillRect/>
           </a:stretch>
         </p:blipFill>
         <p:spPr>
           <a:xfrm>
-            <a:off x="6784848" y="3931920"/>
-            <a:ext cx="265176" cy="265176"/>
+            <a:off x="6766560" y="3616452"/>
+            <a:ext cx="228600" cy="228600"/>
           </a:xfrm>
           <a:prstGeom prst="rect">
             <a:avLst/>
@@ -21000,14 +21113,14 @@
       </p:pic>
       <p:sp>
         <p:nvSpPr>
-          <p:cNvPr id="45" name="Text 33"/>
-          <p:cNvSpPr/>
-          <p:nvPr/>
-        </p:nvSpPr>
-        <p:spPr>
-          <a:xfrm>
-            <a:off x="7269480" y="3630168"/>
-            <a:ext cx="1421892" cy="868680"/>
+          <p:cNvPr id="49" name="Text 36"/>
+          <p:cNvSpPr/>
+          <p:nvPr/>
+        </p:nvSpPr>
+        <p:spPr>
+          <a:xfrm>
+            <a:off x="7196328" y="3364992"/>
+            <a:ext cx="1495044" cy="713232"/>
           </a:xfrm>
           <a:prstGeom prst="rect">
             <a:avLst/>
@@ -21021,12 +21134,12 @@
           <a:p>
             <a:pPr algn="l" indent="0" marL="0">
               <a:lnSpc>
-                <a:spcPct val="102000"/>
+                <a:spcPct val="100000"/>
               </a:lnSpc>
               <a:buNone/>
             </a:pPr>
             <a:r>
-              <a:rPr lang="en-US" sz="1300" b="1" dirty="0">
+              <a:rPr lang="en-US" sz="1250" b="1" dirty="0">
                 <a:solidFill>
                   <a:srgbClr val="2B2B33"/>
                 </a:solidFill>
@@ -21036,24 +21149,24 @@
               </a:rPr>
               <a:t>Obesity / sleep apnoea</a:t>
             </a:r>
-            <a:endParaRPr lang="en-US" sz="1300" dirty="0"/>
-          </a:p>
-        </p:txBody>
-      </p:sp>
-      <p:sp>
-        <p:nvSpPr>
-          <p:cNvPr id="46" name="Shape 34"/>
-          <p:cNvSpPr/>
-          <p:nvPr/>
-        </p:nvSpPr>
-        <p:spPr>
-          <a:xfrm>
-            <a:off x="9057132" y="3630168"/>
-            <a:ext cx="2263140" cy="868680"/>
+            <a:endParaRPr lang="en-US" sz="1250" dirty="0"/>
+          </a:p>
+        </p:txBody>
+      </p:sp>
+      <p:sp>
+        <p:nvSpPr>
+          <p:cNvPr id="50" name="Shape 37"/>
+          <p:cNvSpPr/>
+          <p:nvPr/>
+        </p:nvSpPr>
+        <p:spPr>
+          <a:xfrm>
+            <a:off x="9057132" y="3364992"/>
+            <a:ext cx="2263140" cy="713232"/>
           </a:xfrm>
           <a:prstGeom prst="roundRect">
             <a:avLst>
-              <a:gd name="adj" fmla="val 9474"/>
+              <a:gd name="adj" fmla="val 11538"/>
             </a:avLst>
           </a:prstGeom>
           <a:solidFill>
@@ -21069,14 +21182,14 @@
       </p:sp>
       <p:sp>
         <p:nvSpPr>
-          <p:cNvPr id="47" name="Shape 35"/>
-          <p:cNvSpPr/>
-          <p:nvPr/>
-        </p:nvSpPr>
-        <p:spPr>
-          <a:xfrm>
-            <a:off x="9203436" y="3813048"/>
-            <a:ext cx="502920" cy="502920"/>
+          <p:cNvPr id="51" name="Shape 38"/>
+          <p:cNvSpPr/>
+          <p:nvPr/>
+        </p:nvSpPr>
+        <p:spPr>
+          <a:xfrm>
+            <a:off x="9194292" y="3511296"/>
+            <a:ext cx="438912" cy="438912"/>
           </a:xfrm>
           <a:prstGeom prst="ellipse">
             <a:avLst/>
@@ -21089,22 +21202,22 @@
       </p:sp>
       <p:pic>
         <p:nvPicPr>
-          <p:cNvPr id="48" name="Image 10" descr="preencoded.png">    </p:cNvPr>
+          <p:cNvPr id="52" name="Image 11" descr="preencoded.png">    </p:cNvPr>
           <p:cNvPicPr>
             <a:picLocks noChangeAspect="1"/>
           </p:cNvPicPr>
           <p:nvPr/>
         </p:nvPicPr>
         <p:blipFill>
-          <a:blip r:embed="rId11"/>
+          <a:blip r:embed="rId12"/>
           <a:stretch>
             <a:fillRect/>
           </a:stretch>
         </p:blipFill>
         <p:spPr>
           <a:xfrm>
-            <a:off x="9322308" y="3931920"/>
-            <a:ext cx="265176" cy="265176"/>
+            <a:off x="9304020" y="3616452"/>
+            <a:ext cx="228600" cy="228600"/>
           </a:xfrm>
           <a:prstGeom prst="rect">
             <a:avLst/>
@@ -21113,14 +21226,14 @@
       </p:pic>
       <p:sp>
         <p:nvSpPr>
-          <p:cNvPr id="49" name="Text 36"/>
-          <p:cNvSpPr/>
-          <p:nvPr/>
-        </p:nvSpPr>
-        <p:spPr>
-          <a:xfrm>
-            <a:off x="9806940" y="3630168"/>
-            <a:ext cx="1421892" cy="868680"/>
+          <p:cNvPr id="53" name="Text 39"/>
+          <p:cNvSpPr/>
+          <p:nvPr/>
+        </p:nvSpPr>
+        <p:spPr>
+          <a:xfrm>
+            <a:off x="9733788" y="3364992"/>
+            <a:ext cx="1495044" cy="713232"/>
           </a:xfrm>
           <a:prstGeom prst="rect">
             <a:avLst/>
@@ -21134,12 +21247,12 @@
           <a:p>
             <a:pPr algn="l" indent="0" marL="0">
               <a:lnSpc>
-                <a:spcPct val="102000"/>
+                <a:spcPct val="100000"/>
               </a:lnSpc>
               <a:buNone/>
             </a:pPr>
             <a:r>
-              <a:rPr lang="en-US" sz="1300" b="1" dirty="0">
+              <a:rPr lang="en-US" sz="1250" b="1" dirty="0">
                 <a:solidFill>
                   <a:srgbClr val="2B2B33"/>
                 </a:solidFill>
@@ -21149,24 +21262,24 @@
               </a:rPr>
               <a:t>Sepsis / infection</a:t>
             </a:r>
-            <a:endParaRPr lang="en-US" sz="1300" dirty="0"/>
-          </a:p>
-        </p:txBody>
-      </p:sp>
-      <p:sp>
-        <p:nvSpPr>
-          <p:cNvPr id="50" name="Shape 37"/>
-          <p:cNvSpPr/>
-          <p:nvPr/>
-        </p:nvSpPr>
-        <p:spPr>
-          <a:xfrm>
-            <a:off x="6519672" y="4654296"/>
-            <a:ext cx="2263140" cy="868680"/>
+            <a:endParaRPr lang="en-US" sz="1250" dirty="0"/>
+          </a:p>
+        </p:txBody>
+      </p:sp>
+      <p:sp>
+        <p:nvSpPr>
+          <p:cNvPr id="54" name="Shape 40"/>
+          <p:cNvSpPr/>
+          <p:nvPr/>
+        </p:nvSpPr>
+        <p:spPr>
+          <a:xfrm>
+            <a:off x="6519672" y="4187952"/>
+            <a:ext cx="2263140" cy="713232"/>
           </a:xfrm>
           <a:prstGeom prst="roundRect">
             <a:avLst>
-              <a:gd name="adj" fmla="val 9474"/>
+              <a:gd name="adj" fmla="val 11538"/>
             </a:avLst>
           </a:prstGeom>
           <a:solidFill>
@@ -21182,14 +21295,14 @@
       </p:sp>
       <p:sp>
         <p:nvSpPr>
-          <p:cNvPr id="51" name="Shape 38"/>
-          <p:cNvSpPr/>
-          <p:nvPr/>
-        </p:nvSpPr>
-        <p:spPr>
-          <a:xfrm>
-            <a:off x="6665976" y="4837176"/>
-            <a:ext cx="502920" cy="502920"/>
+          <p:cNvPr id="55" name="Shape 41"/>
+          <p:cNvSpPr/>
+          <p:nvPr/>
+        </p:nvSpPr>
+        <p:spPr>
+          <a:xfrm>
+            <a:off x="6656832" y="4334256"/>
+            <a:ext cx="438912" cy="438912"/>
           </a:xfrm>
           <a:prstGeom prst="ellipse">
             <a:avLst/>
@@ -21202,22 +21315,22 @@
       </p:sp>
       <p:pic>
         <p:nvPicPr>
-          <p:cNvPr id="52" name="Image 11" descr="preencoded.png">    </p:cNvPr>
+          <p:cNvPr id="56" name="Image 12" descr="preencoded.png">    </p:cNvPr>
           <p:cNvPicPr>
             <a:picLocks noChangeAspect="1"/>
           </p:cNvPicPr>
           <p:nvPr/>
         </p:nvPicPr>
         <p:blipFill>
-          <a:blip r:embed="rId12"/>
+          <a:blip r:embed="rId13"/>
           <a:stretch>
             <a:fillRect/>
           </a:stretch>
         </p:blipFill>
         <p:spPr>
           <a:xfrm>
-            <a:off x="6784848" y="4956048"/>
-            <a:ext cx="265176" cy="265176"/>
+            <a:off x="6766560" y="4439412"/>
+            <a:ext cx="228600" cy="228600"/>
           </a:xfrm>
           <a:prstGeom prst="rect">
             <a:avLst/>
@@ -21226,14 +21339,14 @@
       </p:pic>
       <p:sp>
         <p:nvSpPr>
-          <p:cNvPr id="53" name="Text 39"/>
-          <p:cNvSpPr/>
-          <p:nvPr/>
-        </p:nvSpPr>
-        <p:spPr>
-          <a:xfrm>
-            <a:off x="7269480" y="4654296"/>
-            <a:ext cx="1421892" cy="868680"/>
+          <p:cNvPr id="57" name="Text 42"/>
+          <p:cNvSpPr/>
+          <p:nvPr/>
+        </p:nvSpPr>
+        <p:spPr>
+          <a:xfrm>
+            <a:off x="7196328" y="4187952"/>
+            <a:ext cx="1495044" cy="713232"/>
           </a:xfrm>
           <a:prstGeom prst="rect">
             <a:avLst/>
@@ -21247,12 +21360,12 @@
           <a:p>
             <a:pPr algn="l" indent="0" marL="0">
               <a:lnSpc>
-                <a:spcPct val="102000"/>
+                <a:spcPct val="100000"/>
               </a:lnSpc>
               <a:buNone/>
             </a:pPr>
             <a:r>
-              <a:rPr lang="en-US" sz="1300" b="1" dirty="0">
+              <a:rPr lang="en-US" sz="1250" b="1" dirty="0">
                 <a:solidFill>
                   <a:srgbClr val="2B2B33"/>
                 </a:solidFill>
@@ -21262,24 +21375,24 @@
               </a:rPr>
               <a:t>Pulmonary — PE, COPD</a:t>
             </a:r>
-            <a:endParaRPr lang="en-US" sz="1300" dirty="0"/>
-          </a:p>
-        </p:txBody>
-      </p:sp>
-      <p:sp>
-        <p:nvSpPr>
-          <p:cNvPr id="54" name="Shape 40"/>
-          <p:cNvSpPr/>
-          <p:nvPr/>
-        </p:nvSpPr>
-        <p:spPr>
-          <a:xfrm>
-            <a:off x="9057132" y="4654296"/>
-            <a:ext cx="2263140" cy="868680"/>
+            <a:endParaRPr lang="en-US" sz="1250" dirty="0"/>
+          </a:p>
+        </p:txBody>
+      </p:sp>
+      <p:sp>
+        <p:nvSpPr>
+          <p:cNvPr id="58" name="Shape 43"/>
+          <p:cNvSpPr/>
+          <p:nvPr/>
+        </p:nvSpPr>
+        <p:spPr>
+          <a:xfrm>
+            <a:off x="9057132" y="4187952"/>
+            <a:ext cx="2263140" cy="713232"/>
           </a:xfrm>
           <a:prstGeom prst="roundRect">
             <a:avLst>
-              <a:gd name="adj" fmla="val 9474"/>
+              <a:gd name="adj" fmla="val 11538"/>
             </a:avLst>
           </a:prstGeom>
           <a:solidFill>
@@ -21295,14 +21408,14 @@
       </p:sp>
       <p:sp>
         <p:nvSpPr>
-          <p:cNvPr id="55" name="Shape 41"/>
-          <p:cNvSpPr/>
-          <p:nvPr/>
-        </p:nvSpPr>
-        <p:spPr>
-          <a:xfrm>
-            <a:off x="9203436" y="4837176"/>
-            <a:ext cx="502920" cy="502920"/>
+          <p:cNvPr id="59" name="Shape 44"/>
+          <p:cNvSpPr/>
+          <p:nvPr/>
+        </p:nvSpPr>
+        <p:spPr>
+          <a:xfrm>
+            <a:off x="9194292" y="4334256"/>
+            <a:ext cx="438912" cy="438912"/>
           </a:xfrm>
           <a:prstGeom prst="ellipse">
             <a:avLst/>
@@ -21315,22 +21428,22 @@
       </p:sp>
       <p:pic>
         <p:nvPicPr>
-          <p:cNvPr id="56" name="Image 12" descr="preencoded.png">    </p:cNvPr>
+          <p:cNvPr id="60" name="Image 13" descr="preencoded.png">    </p:cNvPr>
           <p:cNvPicPr>
             <a:picLocks noChangeAspect="1"/>
           </p:cNvPicPr>
           <p:nvPr/>
         </p:nvPicPr>
         <p:blipFill>
-          <a:blip r:embed="rId13"/>
+          <a:blip r:embed="rId14"/>
           <a:stretch>
             <a:fillRect/>
           </a:stretch>
         </p:blipFill>
         <p:spPr>
           <a:xfrm>
-            <a:off x="9322308" y="4956048"/>
-            <a:ext cx="265176" cy="265176"/>
+            <a:off x="9304020" y="4439412"/>
+            <a:ext cx="228600" cy="228600"/>
           </a:xfrm>
           <a:prstGeom prst="rect">
             <a:avLst/>
@@ -21339,14 +21452,14 @@
       </p:pic>
       <p:sp>
         <p:nvSpPr>
-          <p:cNvPr id="57" name="Text 42"/>
-          <p:cNvSpPr/>
-          <p:nvPr/>
-        </p:nvSpPr>
-        <p:spPr>
-          <a:xfrm>
-            <a:off x="9806940" y="4654296"/>
-            <a:ext cx="1421892" cy="868680"/>
+          <p:cNvPr id="61" name="Text 45"/>
+          <p:cNvSpPr/>
+          <p:nvPr/>
+        </p:nvSpPr>
+        <p:spPr>
+          <a:xfrm>
+            <a:off x="9733788" y="4187952"/>
+            <a:ext cx="1495044" cy="713232"/>
           </a:xfrm>
           <a:prstGeom prst="rect">
             <a:avLst/>
@@ -21360,12 +21473,12 @@
           <a:p>
             <a:pPr algn="l" indent="0" marL="0">
               <a:lnSpc>
-                <a:spcPct val="102000"/>
+                <a:spcPct val="100000"/>
               </a:lnSpc>
               <a:buNone/>
             </a:pPr>
             <a:r>
-              <a:rPr lang="en-US" sz="1300" b="1" dirty="0">
+              <a:rPr lang="en-US" sz="1250" b="1" dirty="0">
                 <a:solidFill>
                   <a:srgbClr val="2B2B33"/>
                 </a:solidFill>
@@ -21373,45 +21486,158 @@
                 <a:ea typeface="Calibri" pitchFamily="34" charset="-122"/>
                 <a:cs typeface="Calibri" pitchFamily="34" charset="-120"/>
               </a:rPr>
-              <a:t>Electrolytes / diabetes / age</a:t>
-            </a:r>
-            <a:endParaRPr lang="en-US" sz="1300" dirty="0"/>
-          </a:p>
-        </p:txBody>
-      </p:sp>
-      <p:sp>
-        <p:nvSpPr>
-          <p:cNvPr id="58" name="Text 43"/>
-          <p:cNvSpPr/>
-          <p:nvPr/>
-        </p:nvSpPr>
-        <p:spPr>
-          <a:xfrm>
-            <a:off x="11277295" y="6355080"/>
-            <a:ext cx="548640" cy="320040"/>
-          </a:xfrm>
-          <a:prstGeom prst="rect">
-            <a:avLst/>
-          </a:prstGeom>
-          <a:noFill/>
-          <a:ln/>
-        </p:spPr>
-        <p:txBody>
-          <a:bodyPr wrap="square" rtlCol="0" anchor="t"/>
-          <a:lstStyle/>
-          <a:p>
-            <a:pPr algn="r" indent="0" marL="0">
-              <a:buNone/>
-            </a:pPr>
-            <a:r>
-              <a:rPr lang="en-US" sz="1100" b="1" dirty="0">
-                <a:solidFill>
-                  <a:srgbClr val="6B6B76"/>
+              <a:t>Electrolytes / diabetes</a:t>
+            </a:r>
+            <a:endParaRPr lang="en-US" sz="1250" dirty="0"/>
+          </a:p>
+        </p:txBody>
+      </p:sp>
+      <p:sp>
+        <p:nvSpPr>
+          <p:cNvPr id="62" name="Shape 46"/>
+          <p:cNvSpPr/>
+          <p:nvPr/>
+        </p:nvSpPr>
+        <p:spPr>
+          <a:xfrm>
+            <a:off x="6519672" y="5010912"/>
+            <a:ext cx="2263140" cy="713232"/>
+          </a:xfrm>
+          <a:prstGeom prst="roundRect">
+            <a:avLst>
+              <a:gd name="adj" fmla="val 11538"/>
+            </a:avLst>
+          </a:prstGeom>
+          <a:solidFill>
+            <a:srgbClr val="FFFFFF"/>
+          </a:solidFill>
+          <a:ln w="12700">
+            <a:solidFill>
+              <a:srgbClr val="FBD8DF"/>
+            </a:solidFill>
+            <a:prstDash val="solid"/>
+          </a:ln>
+        </p:spPr>
+      </p:sp>
+      <p:sp>
+        <p:nvSpPr>
+          <p:cNvPr id="63" name="Shape 47"/>
+          <p:cNvSpPr/>
+          <p:nvPr/>
+        </p:nvSpPr>
+        <p:spPr>
+          <a:xfrm>
+            <a:off x="6656832" y="5157216"/>
+            <a:ext cx="438912" cy="438912"/>
+          </a:xfrm>
+          <a:prstGeom prst="ellipse">
+            <a:avLst/>
+          </a:prstGeom>
+          <a:solidFill>
+            <a:srgbClr val="FFF0F3"/>
+          </a:solidFill>
+          <a:ln/>
+        </p:spPr>
+      </p:sp>
+      <p:pic>
+        <p:nvPicPr>
+          <p:cNvPr id="64" name="Image 14" descr="preencoded.png">    </p:cNvPr>
+          <p:cNvPicPr>
+            <a:picLocks noChangeAspect="1"/>
+          </p:cNvPicPr>
+          <p:nvPr/>
+        </p:nvPicPr>
+        <p:blipFill>
+          <a:blip r:embed="rId15"/>
+          <a:stretch>
+            <a:fillRect/>
+          </a:stretch>
+        </p:blipFill>
+        <p:spPr>
+          <a:xfrm>
+            <a:off x="6766560" y="5262372"/>
+            <a:ext cx="228600" cy="228600"/>
+          </a:xfrm>
+          <a:prstGeom prst="rect">
+            <a:avLst/>
+          </a:prstGeom>
+        </p:spPr>
+      </p:pic>
+      <p:sp>
+        <p:nvSpPr>
+          <p:cNvPr id="65" name="Text 48"/>
+          <p:cNvSpPr/>
+          <p:nvPr/>
+        </p:nvSpPr>
+        <p:spPr>
+          <a:xfrm>
+            <a:off x="7196328" y="5010912"/>
+            <a:ext cx="1495044" cy="713232"/>
+          </a:xfrm>
+          <a:prstGeom prst="rect">
+            <a:avLst/>
+          </a:prstGeom>
+          <a:noFill/>
+          <a:ln/>
+        </p:spPr>
+        <p:txBody>
+          <a:bodyPr wrap="square" lIns="0" tIns="0" rIns="0" bIns="0" rtlCol="0" anchor="ctr"/>
+          <a:lstStyle/>
+          <a:p>
+            <a:pPr algn="l" indent="0" marL="0">
+              <a:lnSpc>
+                <a:spcPct val="100000"/>
+              </a:lnSpc>
+              <a:buNone/>
+            </a:pPr>
+            <a:r>
+              <a:rPr lang="en-US" sz="1250" b="1" dirty="0">
+                <a:solidFill>
+                  <a:srgbClr val="2B2B33"/>
                 </a:solidFill>
                 <a:latin typeface="Calibri" pitchFamily="34" charset="0"/>
                 <a:ea typeface="Calibri" pitchFamily="34" charset="-122"/>
                 <a:cs typeface="Calibri" pitchFamily="34" charset="-120"/>
               </a:rPr>
+              <a:t>Advancing age</a:t>
+            </a:r>
+            <a:endParaRPr lang="en-US" sz="1250" dirty="0"/>
+          </a:p>
+        </p:txBody>
+      </p:sp>
+      <p:sp>
+        <p:nvSpPr>
+          <p:cNvPr id="66" name="Text 49"/>
+          <p:cNvSpPr/>
+          <p:nvPr/>
+        </p:nvSpPr>
+        <p:spPr>
+          <a:xfrm>
+            <a:off x="11277295" y="6355080"/>
+            <a:ext cx="548640" cy="320040"/>
+          </a:xfrm>
+          <a:prstGeom prst="rect">
+            <a:avLst/>
+          </a:prstGeom>
+          <a:noFill/>
+          <a:ln/>
+        </p:spPr>
+        <p:txBody>
+          <a:bodyPr wrap="square" rtlCol="0" anchor="t"/>
+          <a:lstStyle/>
+          <a:p>
+            <a:pPr algn="r" indent="0" marL="0">
+              <a:buNone/>
+            </a:pPr>
+            <a:r>
+              <a:rPr lang="en-US" sz="1100" b="1" dirty="0">
+                <a:solidFill>
+                  <a:srgbClr val="6B6B76"/>
+                </a:solidFill>
+                <a:latin typeface="Calibri" pitchFamily="34" charset="0"/>
+                <a:ea typeface="Calibri" pitchFamily="34" charset="-122"/>
+                <a:cs typeface="Calibri" pitchFamily="34" charset="-120"/>
+              </a:rPr>
               <a:t>05</a:t>
             </a:r>
             <a:endParaRPr lang="en-US" sz="1100" dirty="0"/>
@@ -21420,7 +21646,7 @@
       </p:sp>
       <p:sp>
         <p:nvSpPr>
-          <p:cNvPr id="59" name="Text 44"/>
+          <p:cNvPr id="67" name="Text 50"/>
           <p:cNvSpPr/>
           <p:nvPr/>
         </p:nvSpPr>

</xml_diff>

<commit_message>
Remove 'Atrial Fibrillation' from slide footers
Footers now read 'Clinicopathological Conference' (case) and 'Clinical
Topic Review' (topic) — the word is removed from every slide's footer.

Co-Authored-By: Claude Opus 4.8 <noreply@anthropic.com>
Claude-Session: https://claude.ai/code/session_01S7QW8AwqyMReKwuqyBkBBv
</commit_message>
<xml_diff>
--- a/presentations/Atrial-Fibrillation-Topic-Review.pptx
+++ b/presentations/Atrial-Fibrillation-Topic-Review.pptx
@@ -4407,7 +4407,7 @@
                 <a:ea typeface="Calibri" pitchFamily="34" charset="-122"/>
                 <a:cs typeface="Calibri" pitchFamily="34" charset="-120"/>
               </a:rPr>
-              <a:t>Atrial Fibrillation — Clinical Topic Review</a:t>
+              <a:t>Clinical Topic Review</a:t>
             </a:r>
             <a:endParaRPr lang="en-US" sz="900" dirty="0"/>
           </a:p>
@@ -5145,7 +5145,7 @@
                 <a:ea typeface="Calibri" pitchFamily="34" charset="-122"/>
                 <a:cs typeface="Calibri" pitchFamily="34" charset="-120"/>
               </a:rPr>
-              <a:t>Atrial Fibrillation — Clinical Topic Review</a:t>
+              <a:t>Clinical Topic Review</a:t>
             </a:r>
             <a:endParaRPr lang="en-US" sz="900" dirty="0"/>
           </a:p>
@@ -7350,7 +7350,7 @@
                 <a:ea typeface="Calibri" pitchFamily="34" charset="-122"/>
                 <a:cs typeface="Calibri" pitchFamily="34" charset="-120"/>
               </a:rPr>
-              <a:t>Atrial Fibrillation — Clinical Topic Review</a:t>
+              <a:t>Clinical Topic Review</a:t>
             </a:r>
             <a:endParaRPr lang="en-US" sz="900" dirty="0"/>
           </a:p>
@@ -8175,7 +8175,7 @@
                 <a:ea typeface="Calibri" pitchFamily="34" charset="-122"/>
                 <a:cs typeface="Calibri" pitchFamily="34" charset="-120"/>
               </a:rPr>
-              <a:t>Atrial Fibrillation — Clinical Topic Review</a:t>
+              <a:t>Clinical Topic Review</a:t>
             </a:r>
             <a:endParaRPr lang="en-US" sz="900" dirty="0"/>
           </a:p>
@@ -9975,7 +9975,7 @@
                 <a:ea typeface="Calibri" pitchFamily="34" charset="-122"/>
                 <a:cs typeface="Calibri" pitchFamily="34" charset="-120"/>
               </a:rPr>
-              <a:t>Atrial Fibrillation — Clinical Topic Review</a:t>
+              <a:t>Clinical Topic Review</a:t>
             </a:r>
             <a:endParaRPr lang="en-US" sz="900" dirty="0"/>
           </a:p>
@@ -10955,7 +10955,7 @@
                 <a:ea typeface="Calibri" pitchFamily="34" charset="-122"/>
                 <a:cs typeface="Calibri" pitchFamily="34" charset="-120"/>
               </a:rPr>
-              <a:t>Atrial Fibrillation — Clinical Topic Review</a:t>
+              <a:t>Clinical Topic Review</a:t>
             </a:r>
             <a:endParaRPr lang="en-US" sz="900" dirty="0"/>
           </a:p>
@@ -11781,7 +11781,7 @@
                 <a:ea typeface="Calibri" pitchFamily="34" charset="-122"/>
                 <a:cs typeface="Calibri" pitchFamily="34" charset="-120"/>
               </a:rPr>
-              <a:t>Atrial Fibrillation — Clinical Topic Review</a:t>
+              <a:t>Clinical Topic Review</a:t>
             </a:r>
             <a:endParaRPr lang="en-US" sz="900" dirty="0"/>
           </a:p>
@@ -12641,7 +12641,7 @@
                 <a:ea typeface="Calibri" pitchFamily="34" charset="-122"/>
                 <a:cs typeface="Calibri" pitchFamily="34" charset="-120"/>
               </a:rPr>
-              <a:t>Atrial Fibrillation — Clinical Topic Review</a:t>
+              <a:t>Clinical Topic Review</a:t>
             </a:r>
             <a:endParaRPr lang="en-US" sz="900" dirty="0"/>
           </a:p>
@@ -13662,7 +13662,7 @@
                 <a:ea typeface="Calibri" pitchFamily="34" charset="-122"/>
                 <a:cs typeface="Calibri" pitchFamily="34" charset="-120"/>
               </a:rPr>
-              <a:t>Atrial Fibrillation — Clinical Topic Review</a:t>
+              <a:t>Clinical Topic Review</a:t>
             </a:r>
             <a:endParaRPr lang="en-US" sz="900" dirty="0"/>
           </a:p>
@@ -14696,7 +14696,7 @@
                 <a:ea typeface="Calibri" pitchFamily="34" charset="-122"/>
                 <a:cs typeface="Calibri" pitchFamily="34" charset="-120"/>
               </a:rPr>
-              <a:t>Atrial Fibrillation — Clinical Topic Review</a:t>
+              <a:t>Clinical Topic Review</a:t>
             </a:r>
             <a:endParaRPr lang="en-US" sz="900" dirty="0"/>
           </a:p>
@@ -15754,7 +15754,7 @@
                 <a:ea typeface="Calibri" pitchFamily="34" charset="-122"/>
                 <a:cs typeface="Calibri" pitchFamily="34" charset="-120"/>
               </a:rPr>
-              <a:t>Atrial Fibrillation — Clinical Topic Review</a:t>
+              <a:t>Clinical Topic Review</a:t>
             </a:r>
             <a:endParaRPr lang="en-US" sz="900" dirty="0"/>
           </a:p>
@@ -16472,7 +16472,7 @@
                 <a:ea typeface="Calibri" pitchFamily="34" charset="-122"/>
                 <a:cs typeface="Calibri" pitchFamily="34" charset="-120"/>
               </a:rPr>
-              <a:t>Atrial Fibrillation — Clinical Topic Review</a:t>
+              <a:t>Clinical Topic Review</a:t>
             </a:r>
             <a:endParaRPr lang="en-US" sz="900" dirty="0"/>
           </a:p>
@@ -17706,7 +17706,7 @@
                 <a:ea typeface="Calibri" pitchFamily="34" charset="-122"/>
                 <a:cs typeface="Calibri" pitchFamily="34" charset="-120"/>
               </a:rPr>
-              <a:t>Atrial Fibrillation — Clinical Topic Review</a:t>
+              <a:t>Clinical Topic Review</a:t>
             </a:r>
             <a:endParaRPr lang="en-US" sz="900" dirty="0"/>
           </a:p>
@@ -18502,7 +18502,7 @@
                 <a:ea typeface="Calibri" pitchFamily="34" charset="-122"/>
                 <a:cs typeface="Calibri" pitchFamily="34" charset="-120"/>
               </a:rPr>
-              <a:t>Atrial Fibrillation — Clinical Topic Review</a:t>
+              <a:t>Clinical Topic Review</a:t>
             </a:r>
             <a:endParaRPr lang="en-US" sz="900" dirty="0"/>
           </a:p>
@@ -19941,7 +19941,7 @@
                 <a:ea typeface="Calibri" pitchFamily="34" charset="-122"/>
                 <a:cs typeface="Calibri" pitchFamily="34" charset="-120"/>
               </a:rPr>
-              <a:t>Atrial Fibrillation — Clinical Topic Review</a:t>
+              <a:t>Clinical Topic Review</a:t>
             </a:r>
             <a:endParaRPr lang="en-US" sz="900" dirty="0"/>
           </a:p>
@@ -20822,7 +20822,7 @@
                 <a:ea typeface="Calibri" pitchFamily="34" charset="-122"/>
                 <a:cs typeface="Calibri" pitchFamily="34" charset="-120"/>
               </a:rPr>
-              <a:t>Atrial Fibrillation — Clinical Topic Review</a:t>
+              <a:t>Clinical Topic Review</a:t>
             </a:r>
             <a:endParaRPr lang="en-US" sz="900" dirty="0"/>
           </a:p>
@@ -22787,7 +22787,7 @@
                 <a:ea typeface="Calibri" pitchFamily="34" charset="-122"/>
                 <a:cs typeface="Calibri" pitchFamily="34" charset="-120"/>
               </a:rPr>
-              <a:t>Atrial Fibrillation — Clinical Topic Review</a:t>
+              <a:t>Clinical Topic Review</a:t>
             </a:r>
             <a:endParaRPr lang="en-US" sz="900" dirty="0"/>
           </a:p>
@@ -24242,7 +24242,7 @@
                 <a:ea typeface="Calibri" pitchFamily="34" charset="-122"/>
                 <a:cs typeface="Calibri" pitchFamily="34" charset="-120"/>
               </a:rPr>
-              <a:t>Atrial Fibrillation — Clinical Topic Review</a:t>
+              <a:t>Clinical Topic Review</a:t>
             </a:r>
             <a:endParaRPr lang="en-US" sz="900" dirty="0"/>
           </a:p>
@@ -26537,7 +26537,7 @@
                 <a:ea typeface="Calibri" pitchFamily="34" charset="-122"/>
                 <a:cs typeface="Calibri" pitchFamily="34" charset="-120"/>
               </a:rPr>
-              <a:t>Atrial Fibrillation — Clinical Topic Review</a:t>
+              <a:t>Clinical Topic Review</a:t>
             </a:r>
             <a:endParaRPr lang="en-US" sz="900" dirty="0"/>
           </a:p>
@@ -27758,7 +27758,7 @@
                 <a:ea typeface="Calibri" pitchFamily="34" charset="-122"/>
                 <a:cs typeface="Calibri" pitchFamily="34" charset="-120"/>
               </a:rPr>
-              <a:t>Atrial Fibrillation — Clinical Topic Review</a:t>
+              <a:t>Clinical Topic Review</a:t>
             </a:r>
             <a:endParaRPr lang="en-US" sz="900" dirty="0"/>
           </a:p>
@@ -29142,7 +29142,7 @@
                 <a:ea typeface="Calibri" pitchFamily="34" charset="-122"/>
                 <a:cs typeface="Calibri" pitchFamily="34" charset="-120"/>
               </a:rPr>
-              <a:t>Atrial Fibrillation — Clinical Topic Review</a:t>
+              <a:t>Clinical Topic Review</a:t>
             </a:r>
             <a:endParaRPr lang="en-US" sz="900" dirty="0"/>
           </a:p>

</xml_diff>